<commit_message>
Add end-to-end alert/patch/self-heal walkthrough to service-desk docs
Per josh's request: explain concretely how automatic patching/administration
and alerting flow through the architecture, and how the system self-heals
without human intervention. Added a new "Walkthrough" section/slide (HTML,
PDF source + regenerated PDF, and pptx) tracing two real cases end to end:
a Tier 0 disk-cleanup that runs fully unattended, and a Tier 2 patch that
stays gated behind one approval click — consistent with the page's existing
"human approves everything above Tier 0/1" thesis rather than contradicting it.
</commit_message>
<xml_diff>
--- a/website/service-desk-architecture.pptx
+++ b/website/service-desk-architecture.pptx
@@ -15,6 +15,7 @@
     <p:sldId id="263" r:id="rId14"/>
     <p:sldId id="264" r:id="rId15"/>
     <p:sldId id="265" r:id="rId16"/>
+    <p:sldId id="271" r:id="rId22"/>
     <p:sldId id="266" r:id="rId17"/>
     <p:sldId id="267" r:id="rId18"/>
     <p:sldId id="268" r:id="rId19"/>
@@ -4905,6 +4906,203 @@
                 <a:latin typeface="Calibri"/>
               </a:rPr>
               <a:t>This deck &amp; the PDF guide: free, no signup</a:t>
+            </a:r>
+          </a:p>
+        </p:txBody>
+      </p:sp>
+    </p:spTree>
+  </p:cSld>
+  <p:clrMapOvr>
+    <a:masterClrMapping/>
+  </p:clrMapOvr>
+</p:sld>
+</file>
+
+<file path=ppt/slides/slide16.xml><?xml version="1.0" encoding="utf-8"?>
+<p:sld xmlns:a="http://schemas.openxmlformats.org/drawingml/2006/main" xmlns:p="http://schemas.openxmlformats.org/presentationml/2006/main" xmlns:r="http://schemas.openxmlformats.org/officeDocument/2006/relationships">
+  <p:cSld>
+    <p:spTree>
+      <p:nvGrpSpPr>
+        <p:cNvPr id="1" name=""/>
+        <p:cNvGrpSpPr/>
+        <p:nvPr/>
+      </p:nvGrpSpPr>
+      <p:grpSpPr/>
+      <p:sp>
+        <p:nvSpPr>
+          <p:cNvPr id="2" name="TextBox 1"/>
+          <p:cNvSpPr txBox="1"/>
+          <p:nvPr/>
+        </p:nvSpPr>
+        <p:spPr>
+          <a:xfrm>
+            <a:off x="548640" y="365760"/>
+            <a:ext cx="11064240" cy="914400"/>
+          </a:xfrm>
+          <a:prstGeom prst="rect">
+            <a:avLst/>
+          </a:prstGeom>
+          <a:noFill/>
+        </p:spPr>
+        <p:txBody>
+          <a:bodyPr wrap="square">
+            <a:spAutoFit/>
+          </a:bodyPr>
+          <a:lstStyle/>
+          <a:p>
+            <a:r>
+              <a:rPr sz="3200" b="1">
+                <a:solidFill>
+                  <a:srgbClr val="1C1F26"/>
+                </a:solidFill>
+                <a:latin typeface="Calibri"/>
+              </a:rPr>
+              <a:t>Walkthrough: an alert firing, end to end</a:t>
+            </a:r>
+          </a:p>
+        </p:txBody>
+      </p:sp>
+      <p:sp>
+        <p:nvSpPr>
+          <p:cNvPr id="3" name="Rectangle 2"/>
+          <p:cNvSpPr/>
+          <p:nvPr/>
+        </p:nvSpPr>
+        <p:spPr>
+          <a:xfrm>
+            <a:off x="548640" y="1143000"/>
+            <a:ext cx="2743200" cy="27940"/>
+          </a:xfrm>
+          <a:prstGeom prst="rect">
+            <a:avLst/>
+          </a:prstGeom>
+          <a:solidFill>
+            <a:srgbClr val="C96343"/>
+          </a:solidFill>
+          <a:ln>
+            <a:noFill/>
+          </a:ln>
+          <a:effectLst/>
+        </p:spPr>
+        <p:style>
+          <a:lnRef idx="1">
+            <a:schemeClr val="accent1"/>
+          </a:lnRef>
+          <a:fillRef idx="3">
+            <a:schemeClr val="accent1"/>
+          </a:fillRef>
+          <a:effectRef idx="2">
+            <a:schemeClr val="accent1"/>
+          </a:effectRef>
+          <a:fontRef idx="minor">
+            <a:schemeClr val="lt1"/>
+          </a:fontRef>
+        </p:style>
+        <p:txBody>
+          <a:bodyPr rtlCol="0" anchor="ctr"/>
+          <a:lstStyle/>
+          <a:p>
+            <a:pPr algn="ctr"/>
+          </a:p>
+        </p:txBody>
+      </p:sp>
+      <p:sp>
+        <p:nvSpPr>
+          <p:cNvPr id="4" name="TextBox 3"/>
+          <p:cNvSpPr txBox="1"/>
+          <p:nvPr/>
+        </p:nvSpPr>
+        <p:spPr>
+          <a:xfrm>
+            <a:off x="548640" y="1417320"/>
+            <a:ext cx="11064240" cy="4846320"/>
+          </a:xfrm>
+          <a:prstGeom prst="rect">
+            <a:avLst/>
+          </a:prstGeom>
+          <a:noFill/>
+        </p:spPr>
+        <p:txBody>
+          <a:bodyPr wrap="square">
+            <a:spAutoFit/>
+          </a:bodyPr>
+          <a:lstStyle/>
+          <a:p>
+            <a:pPr>
+              <a:spcAft>
+                <a:spcPts val="1200"/>
+              </a:spcAft>
+              <a:defRPr>
+                <a:latin typeface="Calibri"/>
+              </a:defRPr>
+            </a:pPr>
+            <a:r>
+              <a:rPr b="1" sz="1600">
+                <a:solidFill>
+                  <a:srgbClr val="C96343"/>
+                </a:solidFill>
+              </a:rPr>
+              <a:t>A — disk fills up, Tier 0, zero human touch:  </a:t>
+            </a:r>
+            <a:r>
+              <a:rPr b="0" sz="1600">
+                <a:solidFill>
+                  <a:srgbClr val="1C1F26"/>
+                </a:solidFill>
+              </a:rPr>
+              <a:t>Zabbix trigger → auto-opened ServiceNow Incident → Linux Server agent runs its cleanup playbook → verifies → writes the audit log. No approval record — Tier 0 doesn't need one.</a:t>
+            </a:r>
+          </a:p>
+          <a:p>
+            <a:pPr>
+              <a:spcAft>
+                <a:spcPts val="1200"/>
+              </a:spcAft>
+              <a:defRPr>
+                <a:latin typeface="Calibri"/>
+              </a:defRPr>
+            </a:pPr>
+            <a:r>
+              <a:rPr b="1" sz="1600">
+                <a:solidFill>
+                  <a:srgbClr val="C96343"/>
+                </a:solidFill>
+              </a:rPr>
+              <a:t>B — missing security patch, same host class, Tier 2:  </a:t>
+            </a:r>
+            <a:r>
+              <a:rPr b="0" sz="1600">
+                <a:solidFill>
+                  <a:srgbClr val="1C1F26"/>
+                </a:solidFill>
+              </a:rPr>
+              <a:t>Nightly compliance scan finds it → patch staged in canary with a real dry-run diff attached → one ServiceNow approval → canary rollout, verified batch by batch → logged.</a:t>
+            </a:r>
+          </a:p>
+          <a:p>
+            <a:pPr>
+              <a:spcAft>
+                <a:spcPts val="1200"/>
+              </a:spcAft>
+              <a:defRPr>
+                <a:latin typeface="Calibri"/>
+              </a:defRPr>
+            </a:pPr>
+            <a:r>
+              <a:rPr b="1" sz="1600">
+                <a:solidFill>
+                  <a:srgbClr val="C96343"/>
+                </a:solidFill>
+              </a:rPr>
+              <a:t>The pattern:  </a:t>
+            </a:r>
+            <a:r>
+              <a:rPr b="0" sz="1600">
+                <a:solidFill>
+                  <a:srgbClr val="1C1F26"/>
+                </a:solidFill>
+              </a:rPr>
+              <a:t>detection, staging, canary rollout, and verification all run unattended. Only the decision to change a production system's state waits on a human — one click against a real diff, not a request to go patch a server by hand.</a:t>
             </a:r>
           </a:p>
         </p:txBody>

</xml_diff>

<commit_message>
Add 7 new supporting systems to the service-desk guides
josh asked via Telegram to add Cisco Firepower Management Center, Cisco
Catalyst Center, VMware Aria, Microsoft SCOM, Azure Monitor, MECM, and
Red Hat Satellite. Extended service-desk.html's architecture diagram and
tables, added matching integration-guide sections (11-17) with setup
steps and MCP server code, and mirrored both into the print PDF sources
and the architecture pptx so every format stays in sync.
</commit_message>
<xml_diff>
--- a/website/service-desk-architecture.pptx
+++ b/website/service-desk-architecture.pptx
@@ -10,6 +10,7 @@
     <p:sldId id="258" r:id="rId9"/>
     <p:sldId id="259" r:id="rId10"/>
     <p:sldId id="260" r:id="rId11"/>
+    <p:sldId id="272" r:id="rId23"/>
     <p:sldId id="261" r:id="rId12"/>
     <p:sldId id="262" r:id="rId13"/>
     <p:sldId id="263" r:id="rId14"/>
@@ -3799,1128 +3800,6 @@
 <file path=ppt/slides/slide11.xml><?xml version="1.0" encoding="utf-8"?>
 <p:sld xmlns:a="http://schemas.openxmlformats.org/drawingml/2006/main" xmlns:p="http://schemas.openxmlformats.org/presentationml/2006/main" xmlns:r="http://schemas.openxmlformats.org/officeDocument/2006/relationships">
   <p:cSld>
-    <p:bg>
-      <p:bgPr>
-        <a:solidFill>
-          <a:srgbClr val="FFFFFF"/>
-        </a:solidFill>
-        <a:effectLst/>
-      </p:bgPr>
-    </p:bg>
-    <p:spTree>
-      <p:nvGrpSpPr>
-        <p:cNvPr id="1" name=""/>
-        <p:cNvGrpSpPr/>
-        <p:nvPr/>
-      </p:nvGrpSpPr>
-      <p:grpSpPr/>
-      <p:sp>
-        <p:nvSpPr>
-          <p:cNvPr id="2" name="TextBox 1"/>
-          <p:cNvSpPr txBox="1"/>
-          <p:nvPr/>
-        </p:nvSpPr>
-        <p:spPr>
-          <a:xfrm>
-            <a:off x="548640" y="365760"/>
-            <a:ext cx="11064240" cy="914400"/>
-          </a:xfrm>
-          <a:prstGeom prst="rect">
-            <a:avLst/>
-          </a:prstGeom>
-          <a:noFill/>
-        </p:spPr>
-        <p:txBody>
-          <a:bodyPr wrap="square">
-            <a:spAutoFit/>
-          </a:bodyPr>
-          <a:lstStyle/>
-          <a:p>
-            <a:r>
-              <a:rPr sz="3200" b="1">
-                <a:solidFill>
-                  <a:srgbClr val="1C1F26"/>
-                </a:solidFill>
-                <a:latin typeface="Calibri"/>
-              </a:rPr>
-              <a:t>Guardrails that make broad autonomy survivable</a:t>
-            </a:r>
-          </a:p>
-        </p:txBody>
-      </p:sp>
-      <p:sp>
-        <p:nvSpPr>
-          <p:cNvPr id="3" name="Rectangle 2"/>
-          <p:cNvSpPr/>
-          <p:nvPr/>
-        </p:nvSpPr>
-        <p:spPr>
-          <a:xfrm>
-            <a:off x="548640" y="1143000"/>
-            <a:ext cx="2743200" cy="27940"/>
-          </a:xfrm>
-          <a:prstGeom prst="rect">
-            <a:avLst/>
-          </a:prstGeom>
-          <a:solidFill>
-            <a:srgbClr val="C96343"/>
-          </a:solidFill>
-          <a:ln>
-            <a:noFill/>
-          </a:ln>
-        </p:spPr>
-        <p:style>
-          <a:lnRef idx="1">
-            <a:schemeClr val="accent1"/>
-          </a:lnRef>
-          <a:fillRef idx="3">
-            <a:schemeClr val="accent1"/>
-          </a:fillRef>
-          <a:effectRef idx="2">
-            <a:schemeClr val="accent1"/>
-          </a:effectRef>
-          <a:fontRef idx="minor">
-            <a:schemeClr val="lt1"/>
-          </a:fontRef>
-        </p:style>
-        <p:txBody>
-          <a:bodyPr rtlCol="0" anchor="ctr"/>
-          <a:lstStyle/>
-          <a:p>
-            <a:pPr algn="ctr"/>
-          </a:p>
-        </p:txBody>
-      </p:sp>
-      <p:sp>
-        <p:nvSpPr>
-          <p:cNvPr id="4" name="TextBox 3"/>
-          <p:cNvSpPr txBox="1"/>
-          <p:nvPr/>
-        </p:nvSpPr>
-        <p:spPr>
-          <a:xfrm>
-            <a:off x="548640" y="1417320"/>
-            <a:ext cx="11064240" cy="4846320"/>
-          </a:xfrm>
-          <a:prstGeom prst="rect">
-            <a:avLst/>
-          </a:prstGeom>
-          <a:noFill/>
-        </p:spPr>
-        <p:txBody>
-          <a:bodyPr wrap="square">
-            <a:spAutoFit/>
-          </a:bodyPr>
-          <a:lstStyle/>
-          <a:p>
-            <a:pPr>
-              <a:spcAft>
-                <a:spcPts val="1200"/>
-              </a:spcAft>
-              <a:defRPr>
-                <a:latin typeface="Calibri"/>
-              </a:defRPr>
-            </a:pPr>
-            <a:r>
-              <a:rPr b="1" sz="1600">
-                <a:solidFill>
-                  <a:srgbClr val="C96343"/>
-                </a:solidFill>
-              </a:rPr>
-              <a:t>Least privilege, per domain:  </a:t>
-            </a:r>
-            <a:r>
-              <a:rPr sz="1600">
-                <a:solidFill>
-                  <a:srgbClr val="1C1F26"/>
-                </a:solidFill>
-              </a:rPr>
-              <a:t>no standing domain-admin/enable-15/root credential — just-in-time from a vault.</a:t>
-            </a:r>
-          </a:p>
-          <a:p>
-            <a:pPr>
-              <a:spcAft>
-                <a:spcPts val="1200"/>
-              </a:spcAft>
-              <a:defRPr>
-                <a:latin typeface="Calibri"/>
-              </a:defRPr>
-            </a:pPr>
-            <a:r>
-              <a:rPr b="1" sz="1600">
-                <a:solidFill>
-                  <a:srgbClr val="C96343"/>
-                </a:solidFill>
-              </a:rPr>
-              <a:t>Mandatory dry-run for Tier ≥2:  </a:t>
-            </a:r>
-            <a:r>
-              <a:rPr sz="1600">
-                <a:solidFill>
-                  <a:srgbClr val="1C1F26"/>
-                </a:solidFill>
-              </a:rPr>
-              <a:t>a real config diff, not a text description of intent.</a:t>
-            </a:r>
-          </a:p>
-          <a:p>
-            <a:pPr>
-              <a:spcAft>
-                <a:spcPts val="1200"/>
-              </a:spcAft>
-              <a:defRPr>
-                <a:latin typeface="Calibri"/>
-              </a:defRPr>
-            </a:pPr>
-            <a:r>
-              <a:rPr b="1" sz="1600">
-                <a:solidFill>
-                  <a:srgbClr val="C96343"/>
-                </a:solidFill>
-              </a:rPr>
-              <a:t>Immutable audit log:  </a:t>
-            </a:r>
-            <a:r>
-              <a:rPr sz="1600">
-                <a:solidFill>
-                  <a:srgbClr val="1C1F26"/>
-                </a:solidFill>
-              </a:rPr>
-              <a:t>every plan, approval, action, and verification result, appended, never edited.</a:t>
-            </a:r>
-          </a:p>
-          <a:p>
-            <a:pPr>
-              <a:spcAft>
-                <a:spcPts val="1200"/>
-              </a:spcAft>
-              <a:defRPr>
-                <a:latin typeface="Calibri"/>
-              </a:defRPr>
-            </a:pPr>
-            <a:r>
-              <a:rPr b="1" sz="1600">
-                <a:solidFill>
-                  <a:srgbClr val="C96343"/>
-                </a:solidFill>
-              </a:rPr>
-              <a:t>Required rollback plan:  </a:t>
-            </a:r>
-            <a:r>
-              <a:rPr sz="1600">
-                <a:solidFill>
-                  <a:srgbClr val="1C1F26"/>
-                </a:solidFill>
-              </a:rPr>
-              <a:t>no mutating action ships without a paired undo step.</a:t>
-            </a:r>
-          </a:p>
-          <a:p>
-            <a:pPr>
-              <a:spcAft>
-                <a:spcPts val="1200"/>
-              </a:spcAft>
-              <a:defRPr>
-                <a:latin typeface="Calibri"/>
-              </a:defRPr>
-            </a:pPr>
-            <a:r>
-              <a:rPr b="1" sz="1600">
-                <a:solidFill>
-                  <a:srgbClr val="C96343"/>
-                </a:solidFill>
-              </a:rPr>
-              <a:t>Circuit breakers:  </a:t>
-            </a:r>
-            <a:r>
-              <a:rPr sz="1600">
-                <a:solidFill>
-                  <a:srgbClr val="1C1F26"/>
-                </a:solidFill>
-              </a:rPr>
-              <a:t>hard caps on actions-per-hour and blast-radius-per-action.</a:t>
-            </a:r>
-          </a:p>
-          <a:p>
-            <a:pPr>
-              <a:spcAft>
-                <a:spcPts val="1200"/>
-              </a:spcAft>
-              <a:defRPr>
-                <a:latin typeface="Calibri"/>
-              </a:defRPr>
-            </a:pPr>
-            <a:r>
-              <a:rPr b="1" sz="1600">
-                <a:solidFill>
-                  <a:srgbClr val="C96343"/>
-                </a:solidFill>
-              </a:rPr>
-              <a:t>Hard deny-list:  </a:t>
-            </a:r>
-            <a:r>
-              <a:rPr sz="1600">
-                <a:solidFill>
-                  <a:srgbClr val="1C1F26"/>
-                </a:solidFill>
-              </a:rPr>
-              <a:t>a small set of actions no tier and no approval can unlock.</a:t>
-            </a:r>
-          </a:p>
-        </p:txBody>
-      </p:sp>
-    </p:spTree>
-  </p:cSld>
-  <p:clrMapOvr>
-    <a:masterClrMapping/>
-  </p:clrMapOvr>
-</p:sld>
-</file>
-
-<file path=ppt/slides/slide12.xml><?xml version="1.0" encoding="utf-8"?>
-<p:sld xmlns:a="http://schemas.openxmlformats.org/drawingml/2006/main" xmlns:p="http://schemas.openxmlformats.org/presentationml/2006/main" xmlns:r="http://schemas.openxmlformats.org/officeDocument/2006/relationships">
-  <p:cSld>
-    <p:bg>
-      <p:bgPr>
-        <a:solidFill>
-          <a:srgbClr val="FFFFFF"/>
-        </a:solidFill>
-        <a:effectLst/>
-      </p:bgPr>
-    </p:bg>
-    <p:spTree>
-      <p:nvGrpSpPr>
-        <p:cNvPr id="1" name=""/>
-        <p:cNvGrpSpPr/>
-        <p:nvPr/>
-      </p:nvGrpSpPr>
-      <p:grpSpPr/>
-      <p:sp>
-        <p:nvSpPr>
-          <p:cNvPr id="2" name="TextBox 1"/>
-          <p:cNvSpPr txBox="1"/>
-          <p:nvPr/>
-        </p:nvSpPr>
-        <p:spPr>
-          <a:xfrm>
-            <a:off x="548640" y="365760"/>
-            <a:ext cx="11064240" cy="914400"/>
-          </a:xfrm>
-          <a:prstGeom prst="rect">
-            <a:avLst/>
-          </a:prstGeom>
-          <a:noFill/>
-        </p:spPr>
-        <p:txBody>
-          <a:bodyPr wrap="square">
-            <a:spAutoFit/>
-          </a:bodyPr>
-          <a:lstStyle/>
-          <a:p>
-            <a:r>
-              <a:rPr sz="2600" b="1">
-                <a:solidFill>
-                  <a:srgbClr val="1C1F26"/>
-                </a:solidFill>
-                <a:latin typeface="Calibri"/>
-              </a:rPr>
-              <a:t>Deployment guide — Phase 0 &amp; 1</a:t>
-            </a:r>
-          </a:p>
-        </p:txBody>
-      </p:sp>
-      <p:sp>
-        <p:nvSpPr>
-          <p:cNvPr id="3" name="Rectangle 2"/>
-          <p:cNvSpPr/>
-          <p:nvPr/>
-        </p:nvSpPr>
-        <p:spPr>
-          <a:xfrm>
-            <a:off x="548640" y="1143000"/>
-            <a:ext cx="2743200" cy="27940"/>
-          </a:xfrm>
-          <a:prstGeom prst="rect">
-            <a:avLst/>
-          </a:prstGeom>
-          <a:solidFill>
-            <a:srgbClr val="C96343"/>
-          </a:solidFill>
-          <a:ln>
-            <a:noFill/>
-          </a:ln>
-        </p:spPr>
-        <p:style>
-          <a:lnRef idx="1">
-            <a:schemeClr val="accent1"/>
-          </a:lnRef>
-          <a:fillRef idx="3">
-            <a:schemeClr val="accent1"/>
-          </a:fillRef>
-          <a:effectRef idx="2">
-            <a:schemeClr val="accent1"/>
-          </a:effectRef>
-          <a:fontRef idx="minor">
-            <a:schemeClr val="lt1"/>
-          </a:fontRef>
-        </p:style>
-        <p:txBody>
-          <a:bodyPr rtlCol="0" anchor="ctr"/>
-          <a:lstStyle/>
-          <a:p>
-            <a:pPr algn="ctr"/>
-          </a:p>
-        </p:txBody>
-      </p:sp>
-      <p:sp>
-        <p:nvSpPr>
-          <p:cNvPr id="4" name="TextBox 3"/>
-          <p:cNvSpPr txBox="1"/>
-          <p:nvPr/>
-        </p:nvSpPr>
-        <p:spPr>
-          <a:xfrm>
-            <a:off x="548640" y="1371600"/>
-            <a:ext cx="11064240" cy="4846320"/>
-          </a:xfrm>
-          <a:prstGeom prst="rect">
-            <a:avLst/>
-          </a:prstGeom>
-          <a:noFill/>
-        </p:spPr>
-        <p:txBody>
-          <a:bodyPr wrap="square">
-            <a:spAutoFit/>
-          </a:bodyPr>
-          <a:lstStyle/>
-          <a:p>
-            <a:pPr>
-              <a:spcAft>
-                <a:spcPts val="1200"/>
-              </a:spcAft>
-              <a:defRPr>
-                <a:latin typeface="Calibri"/>
-              </a:defRPr>
-            </a:pPr>
-            <a:r>
-              <a:rPr sz="1550">
-                <a:solidFill>
-                  <a:srgbClr val="1C1F26"/>
-                </a:solidFill>
-              </a:rPr>
-              <a:t>1. Stand up the audit log store first, before any agent code runs.</a:t>
-            </a:r>
-          </a:p>
-          <a:p>
-            <a:pPr>
-              <a:spcAft>
-                <a:spcPts val="1200"/>
-              </a:spcAft>
-              <a:defRPr>
-                <a:latin typeface="Calibri"/>
-              </a:defRPr>
-            </a:pPr>
-            <a:r>
-              <a:rPr sz="1550">
-                <a:solidFill>
-                  <a:srgbClr val="1C1F26"/>
-                </a:solidFill>
-              </a:rPr>
-              <a:t>2. Stand up NetBox (inventory/IPAM) and Zabbix + Grafana (monitoring) — Platform Ops depends on both later.</a:t>
-            </a:r>
-          </a:p>
-          <a:p>
-            <a:pPr>
-              <a:spcAft>
-                <a:spcPts val="1200"/>
-              </a:spcAft>
-              <a:defRPr>
-                <a:latin typeface="Calibri"/>
-              </a:defRPr>
-            </a:pPr>
-            <a:r>
-              <a:rPr sz="1550">
-                <a:solidFill>
-                  <a:srgbClr val="1C1F26"/>
-                </a:solidFill>
-              </a:rPr>
-              <a:t>3. Wire ServiceNow: subscribe to tickets, scoped CMDB read access, Zabbix → Incident webhook.</a:t>
-            </a:r>
-          </a:p>
-          <a:p>
-            <a:pPr>
-              <a:spcAft>
-                <a:spcPts val="1200"/>
-              </a:spcAft>
-              <a:defRPr>
-                <a:latin typeface="Calibri"/>
-              </a:defRPr>
-            </a:pPr>
-            <a:r>
-              <a:rPr sz="1550">
-                <a:solidFill>
-                  <a:srgbClr val="1C1F26"/>
-                </a:solidFill>
-              </a:rPr>
-              <a:t>4. Build the orchestrator's intake, classification, and risk-tier scorer.</a:t>
-            </a:r>
-          </a:p>
-          <a:p>
-            <a:pPr>
-              <a:spcAft>
-                <a:spcPts val="1200"/>
-              </a:spcAft>
-              <a:defRPr>
-                <a:latin typeface="Calibri"/>
-              </a:defRPr>
-            </a:pPr>
-            <a:r>
-              <a:rPr sz="1550">
-                <a:solidFill>
-                  <a:srgbClr val="1C1F26"/>
-                </a:solidFill>
-              </a:rPr>
-              <a:t>5–6. Draft-only for 4–6 weeks, tuning against what humans actually did — no execution yet.</a:t>
-            </a:r>
-          </a:p>
-          <a:p>
-            <a:pPr>
-              <a:spcAft>
-                <a:spcPts val="1200"/>
-              </a:spcAft>
-              <a:defRPr>
-                <a:latin typeface="Calibri"/>
-              </a:defRPr>
-            </a:pPr>
-            <a:r>
-              <a:rPr sz="1550">
-                <a:solidFill>
-                  <a:srgbClr val="1C1F26"/>
-                </a:solidFill>
-              </a:rPr>
-              <a:t>7–8. Build Identity/AD password reset end-to-end; auto-execute Tier 0–1 only.</a:t>
-            </a:r>
-          </a:p>
-          <a:p>
-            <a:pPr>
-              <a:spcAft>
-                <a:spcPts val="1200"/>
-              </a:spcAft>
-              <a:defRPr>
-                <a:latin typeface="Calibri"/>
-              </a:defRPr>
-            </a:pPr>
-            <a:r>
-              <a:rPr sz="1550">
-                <a:solidFill>
-                  <a:srgbClr val="1C1F26"/>
-                </a:solidFill>
-              </a:rPr>
-              <a:t>9–10. Circuit breakers before unattended execution; bring remaining Tier 1 agents online one at a time.</a:t>
-            </a:r>
-          </a:p>
-        </p:txBody>
-      </p:sp>
-    </p:spTree>
-  </p:cSld>
-  <p:clrMapOvr>
-    <a:masterClrMapping/>
-  </p:clrMapOvr>
-</p:sld>
-</file>
-
-<file path=ppt/slides/slide13.xml><?xml version="1.0" encoding="utf-8"?>
-<p:sld xmlns:a="http://schemas.openxmlformats.org/drawingml/2006/main" xmlns:p="http://schemas.openxmlformats.org/presentationml/2006/main" xmlns:r="http://schemas.openxmlformats.org/officeDocument/2006/relationships">
-  <p:cSld>
-    <p:bg>
-      <p:bgPr>
-        <a:solidFill>
-          <a:srgbClr val="FFFFFF"/>
-        </a:solidFill>
-        <a:effectLst/>
-      </p:bgPr>
-    </p:bg>
-    <p:spTree>
-      <p:nvGrpSpPr>
-        <p:cNvPr id="1" name=""/>
-        <p:cNvGrpSpPr/>
-        <p:nvPr/>
-      </p:nvGrpSpPr>
-      <p:grpSpPr/>
-      <p:sp>
-        <p:nvSpPr>
-          <p:cNvPr id="2" name="TextBox 1"/>
-          <p:cNvSpPr txBox="1"/>
-          <p:nvPr/>
-        </p:nvSpPr>
-        <p:spPr>
-          <a:xfrm>
-            <a:off x="548640" y="365760"/>
-            <a:ext cx="11064240" cy="914400"/>
-          </a:xfrm>
-          <a:prstGeom prst="rect">
-            <a:avLst/>
-          </a:prstGeom>
-          <a:noFill/>
-        </p:spPr>
-        <p:txBody>
-          <a:bodyPr wrap="square">
-            <a:spAutoFit/>
-          </a:bodyPr>
-          <a:lstStyle/>
-          <a:p>
-            <a:r>
-              <a:rPr sz="2600" b="1">
-                <a:solidFill>
-                  <a:srgbClr val="1C1F26"/>
-                </a:solidFill>
-                <a:latin typeface="Calibri"/>
-              </a:rPr>
-              <a:t>Deployment guide — Phase 2 &amp; 3</a:t>
-            </a:r>
-          </a:p>
-        </p:txBody>
-      </p:sp>
-      <p:sp>
-        <p:nvSpPr>
-          <p:cNvPr id="3" name="Rectangle 2"/>
-          <p:cNvSpPr/>
-          <p:nvPr/>
-        </p:nvSpPr>
-        <p:spPr>
-          <a:xfrm>
-            <a:off x="548640" y="1143000"/>
-            <a:ext cx="2743200" cy="27940"/>
-          </a:xfrm>
-          <a:prstGeom prst="rect">
-            <a:avLst/>
-          </a:prstGeom>
-          <a:solidFill>
-            <a:srgbClr val="C96343"/>
-          </a:solidFill>
-          <a:ln>
-            <a:noFill/>
-          </a:ln>
-        </p:spPr>
-        <p:style>
-          <a:lnRef idx="1">
-            <a:schemeClr val="accent1"/>
-          </a:lnRef>
-          <a:fillRef idx="3">
-            <a:schemeClr val="accent1"/>
-          </a:fillRef>
-          <a:effectRef idx="2">
-            <a:schemeClr val="accent1"/>
-          </a:effectRef>
-          <a:fontRef idx="minor">
-            <a:schemeClr val="lt1"/>
-          </a:fontRef>
-        </p:style>
-        <p:txBody>
-          <a:bodyPr rtlCol="0" anchor="ctr"/>
-          <a:lstStyle/>
-          <a:p>
-            <a:pPr algn="ctr"/>
-          </a:p>
-        </p:txBody>
-      </p:sp>
-      <p:sp>
-        <p:nvSpPr>
-          <p:cNvPr id="4" name="TextBox 3"/>
-          <p:cNvSpPr txBox="1"/>
-          <p:nvPr/>
-        </p:nvSpPr>
-        <p:spPr>
-          <a:xfrm>
-            <a:off x="548640" y="1371600"/>
-            <a:ext cx="11064240" cy="4846320"/>
-          </a:xfrm>
-          <a:prstGeom prst="rect">
-            <a:avLst/>
-          </a:prstGeom>
-          <a:noFill/>
-        </p:spPr>
-        <p:txBody>
-          <a:bodyPr wrap="square">
-            <a:spAutoFit/>
-          </a:bodyPr>
-          <a:lstStyle/>
-          <a:p>
-            <a:pPr>
-              <a:spcAft>
-                <a:spcPts val="1200"/>
-              </a:spcAft>
-              <a:defRPr>
-                <a:latin typeface="Calibri"/>
-              </a:defRPr>
-            </a:pPr>
-            <a:r>
-              <a:rPr sz="1550">
-                <a:solidFill>
-                  <a:srgbClr val="1C1F26"/>
-                </a:solidFill>
-              </a:rPr>
-              <a:t>11. Wire the ServiceNow native Approval record as the actual gate.</a:t>
-            </a:r>
-          </a:p>
-          <a:p>
-            <a:pPr>
-              <a:spcAft>
-                <a:spcPts val="1200"/>
-              </a:spcAft>
-              <a:defRPr>
-                <a:latin typeface="Calibri"/>
-              </a:defRPr>
-            </a:pPr>
-            <a:r>
-              <a:rPr sz="1550">
-                <a:solidFill>
-                  <a:srgbClr val="1C1F26"/>
-                </a:solidFill>
-              </a:rPr>
-              <a:t>12. Build mandatory dry-run per Tier 2 agent — Batfish becomes the Network agent's verification engine.</a:t>
-            </a:r>
-          </a:p>
-          <a:p>
-            <a:pPr>
-              <a:spcAft>
-                <a:spcPts val="1200"/>
-              </a:spcAft>
-              <a:defRPr>
-                <a:latin typeface="Calibri"/>
-              </a:defRPr>
-            </a:pPr>
-            <a:r>
-              <a:rPr sz="1550">
-                <a:solidFill>
-                  <a:srgbClr val="1C1F26"/>
-                </a:solidFill>
-              </a:rPr>
-              <a:t>13. Bring Tier 2 agents online one at a time behind the approval gate.</a:t>
-            </a:r>
-          </a:p>
-          <a:p>
-            <a:pPr>
-              <a:spcAft>
-                <a:spcPts val="1200"/>
-              </a:spcAft>
-              <a:defRPr>
-                <a:latin typeface="Calibri"/>
-              </a:defRPr>
-            </a:pPr>
-            <a:r>
-              <a:rPr sz="1550">
-                <a:solidFill>
-                  <a:srgbClr val="1C1F26"/>
-                </a:solidFill>
-              </a:rPr>
-              <a:t>14. Onboard Cisco ISE (Identity NAC) and Nexus Dashboard (DC fabric) — same burn-in discipline.</a:t>
-            </a:r>
-          </a:p>
-          <a:p>
-            <a:pPr>
-              <a:spcAft>
-                <a:spcPts val="1200"/>
-              </a:spcAft>
-              <a:defRPr>
-                <a:latin typeface="Calibri"/>
-              </a:defRPr>
-            </a:pPr>
-            <a:r>
-              <a:rPr sz="1550">
-                <a:solidFill>
-                  <a:srgbClr val="1C1F26"/>
-                </a:solidFill>
-              </a:rPr>
-              <a:t>15. Build Platform Ops last, once the framework has a track record.</a:t>
-            </a:r>
-          </a:p>
-          <a:p>
-            <a:pPr>
-              <a:spcAft>
-                <a:spcPts val="1200"/>
-              </a:spcAft>
-              <a:defRPr>
-                <a:latin typeface="Calibri"/>
-              </a:defRPr>
-            </a:pPr>
-            <a:r>
-              <a:rPr sz="1550">
-                <a:solidFill>
-                  <a:srgbClr val="1C1F26"/>
-                </a:solidFill>
-              </a:rPr>
-              <a:t>16. Formalize two-person approval for Tier 3 and the arbitration flow.</a:t>
-            </a:r>
-          </a:p>
-          <a:p>
-            <a:pPr>
-              <a:spcAft>
-                <a:spcPts val="1200"/>
-              </a:spcAft>
-              <a:defRPr>
-                <a:latin typeface="Calibri"/>
-              </a:defRPr>
-            </a:pPr>
-            <a:r>
-              <a:rPr sz="1550">
-                <a:solidFill>
-                  <a:srgbClr val="1C1F26"/>
-                </a:solidFill>
-              </a:rPr>
-              <a:t>17. Establish a recurring (monthly) audit of auto-executed Tier 0–1 actions against the log.</a:t>
-            </a:r>
-          </a:p>
-        </p:txBody>
-      </p:sp>
-    </p:spTree>
-  </p:cSld>
-  <p:clrMapOvr>
-    <a:masterClrMapping/>
-  </p:clrMapOvr>
-</p:sld>
-</file>
-
-<file path=ppt/slides/slide14.xml><?xml version="1.0" encoding="utf-8"?>
-<p:sld xmlns:a="http://schemas.openxmlformats.org/drawingml/2006/main" xmlns:p="http://schemas.openxmlformats.org/presentationml/2006/main" xmlns:r="http://schemas.openxmlformats.org/officeDocument/2006/relationships">
-  <p:cSld>
-    <p:bg>
-      <p:bgPr>
-        <a:solidFill>
-          <a:srgbClr val="FFFFFF"/>
-        </a:solidFill>
-        <a:effectLst/>
-      </p:bgPr>
-    </p:bg>
-    <p:spTree>
-      <p:nvGrpSpPr>
-        <p:cNvPr id="1" name=""/>
-        <p:cNvGrpSpPr/>
-        <p:nvPr/>
-      </p:nvGrpSpPr>
-      <p:grpSpPr/>
-      <p:sp>
-        <p:nvSpPr>
-          <p:cNvPr id="2" name="TextBox 1"/>
-          <p:cNvSpPr txBox="1"/>
-          <p:nvPr/>
-        </p:nvSpPr>
-        <p:spPr>
-          <a:xfrm>
-            <a:off x="548640" y="365760"/>
-            <a:ext cx="11064240" cy="914400"/>
-          </a:xfrm>
-          <a:prstGeom prst="rect">
-            <a:avLst/>
-          </a:prstGeom>
-          <a:noFill/>
-        </p:spPr>
-        <p:txBody>
-          <a:bodyPr wrap="square">
-            <a:spAutoFit/>
-          </a:bodyPr>
-          <a:lstStyle/>
-          <a:p>
-            <a:r>
-              <a:rPr sz="3200" b="1">
-                <a:solidFill>
-                  <a:srgbClr val="1C1F26"/>
-                </a:solidFill>
-                <a:latin typeface="Calibri"/>
-              </a:rPr>
-              <a:t>What this is and isn't</a:t>
-            </a:r>
-          </a:p>
-        </p:txBody>
-      </p:sp>
-      <p:sp>
-        <p:nvSpPr>
-          <p:cNvPr id="3" name="Rectangle 2"/>
-          <p:cNvSpPr/>
-          <p:nvPr/>
-        </p:nvSpPr>
-        <p:spPr>
-          <a:xfrm>
-            <a:off x="548640" y="1143000"/>
-            <a:ext cx="2743200" cy="27940"/>
-          </a:xfrm>
-          <a:prstGeom prst="rect">
-            <a:avLst/>
-          </a:prstGeom>
-          <a:solidFill>
-            <a:srgbClr val="C96343"/>
-          </a:solidFill>
-          <a:ln>
-            <a:noFill/>
-          </a:ln>
-        </p:spPr>
-        <p:style>
-          <a:lnRef idx="1">
-            <a:schemeClr val="accent1"/>
-          </a:lnRef>
-          <a:fillRef idx="3">
-            <a:schemeClr val="accent1"/>
-          </a:fillRef>
-          <a:effectRef idx="2">
-            <a:schemeClr val="accent1"/>
-          </a:effectRef>
-          <a:fontRef idx="minor">
-            <a:schemeClr val="lt1"/>
-          </a:fontRef>
-        </p:style>
-        <p:txBody>
-          <a:bodyPr rtlCol="0" anchor="ctr"/>
-          <a:lstStyle/>
-          <a:p>
-            <a:pPr algn="ctr"/>
-          </a:p>
-        </p:txBody>
-      </p:sp>
-      <p:sp>
-        <p:nvSpPr>
-          <p:cNvPr id="4" name="TextBox 3"/>
-          <p:cNvSpPr txBox="1"/>
-          <p:nvPr/>
-        </p:nvSpPr>
-        <p:spPr>
-          <a:xfrm>
-            <a:off x="548640" y="1554480"/>
-            <a:ext cx="11064240" cy="4846320"/>
-          </a:xfrm>
-          <a:prstGeom prst="rect">
-            <a:avLst/>
-          </a:prstGeom>
-          <a:noFill/>
-        </p:spPr>
-        <p:txBody>
-          <a:bodyPr wrap="square">
-            <a:spAutoFit/>
-          </a:bodyPr>
-          <a:lstStyle/>
-          <a:p>
-            <a:pPr>
-              <a:spcAft>
-                <a:spcPts val="1200"/>
-              </a:spcAft>
-              <a:defRPr>
-                <a:latin typeface="Calibri"/>
-              </a:defRPr>
-            </a:pPr>
-            <a:r>
-              <a:rPr b="1" sz="1900">
-                <a:solidFill>
-                  <a:srgbClr val="C96343"/>
-                </a:solidFill>
-              </a:rPr>
-              <a:t>This is:  </a:t>
-            </a:r>
-            <a:r>
-              <a:rPr sz="1900">
-                <a:solidFill>
-                  <a:srgbClr val="1C1F26"/>
-                </a:solidFill>
-              </a:rPr>
-              <a:t>an architecture blueprint — the shape of the system, trust boundaries, and checkpoints, worked out on paper first.</a:t>
-            </a:r>
-          </a:p>
-          <a:p>
-            <a:pPr>
-              <a:spcAft>
-                <a:spcPts val="1200"/>
-              </a:spcAft>
-              <a:defRPr>
-                <a:latin typeface="Calibri"/>
-              </a:defRPr>
-            </a:pPr>
-            <a:r>
-              <a:rPr b="1" sz="1900">
-                <a:solidFill>
-                  <a:srgbClr val="C96343"/>
-                </a:solidFill>
-              </a:rPr>
-              <a:t>This isn't:  </a:t>
-            </a:r>
-            <a:r>
-              <a:rPr sz="1900">
-                <a:solidFill>
-                  <a:srgbClr val="1C1F26"/>
-                </a:solidFill>
-              </a:rPr>
-              <a:t>a running deployment. No ServiceNow tenant, no Cisco/AD/VMware credentials, no reachable enterprise network here.</a:t>
-            </a:r>
-          </a:p>
-          <a:p>
-            <a:pPr>
-              <a:spcAft>
-                <a:spcPts val="1200"/>
-              </a:spcAft>
-              <a:defRPr>
-                <a:latin typeface="Calibri"/>
-              </a:defRPr>
-            </a:pPr>
-            <a:r>
-              <a:rPr b="1" sz="1900">
-                <a:solidFill>
-                  <a:srgbClr val="C96343"/>
-                </a:solidFill>
-              </a:rPr>
-              <a:t>Standing up live write-access  </a:t>
-            </a:r>
-            <a:r>
-              <a:rPr sz="1900">
-                <a:solidFill>
-                  <a:srgbClr val="1C1F26"/>
-                </a:solidFill>
-              </a:rPr>
-              <a:t>to someone's routers, directory, and hypervisors is a real person's decision, made deliberately, with real scoped credentials they grant.</a:t>
-            </a:r>
-          </a:p>
-        </p:txBody>
-      </p:sp>
-    </p:spTree>
-  </p:cSld>
-  <p:clrMapOvr>
-    <a:masterClrMapping/>
-  </p:clrMapOvr>
-</p:sld>
-</file>
-
-<file path=ppt/slides/slide15.xml><?xml version="1.0" encoding="utf-8"?>
-<p:sld xmlns:a="http://schemas.openxmlformats.org/drawingml/2006/main" xmlns:p="http://schemas.openxmlformats.org/presentationml/2006/main" xmlns:r="http://schemas.openxmlformats.org/officeDocument/2006/relationships">
-  <p:cSld>
-    <p:bg>
-      <p:bgPr>
-        <a:solidFill>
-          <a:srgbClr val="1C1F26"/>
-        </a:solidFill>
-        <a:effectLst/>
-      </p:bgPr>
-    </p:bg>
-    <p:spTree>
-      <p:nvGrpSpPr>
-        <p:cNvPr id="1" name=""/>
-        <p:cNvGrpSpPr/>
-        <p:nvPr/>
-      </p:nvGrpSpPr>
-      <p:grpSpPr/>
-      <p:sp>
-        <p:nvSpPr>
-          <p:cNvPr id="2" name="TextBox 1"/>
-          <p:cNvSpPr txBox="1"/>
-          <p:nvPr/>
-        </p:nvSpPr>
-        <p:spPr>
-          <a:xfrm>
-            <a:off x="914400" y="2377440"/>
-            <a:ext cx="10332720" cy="1097280"/>
-          </a:xfrm>
-          <a:prstGeom prst="rect">
-            <a:avLst/>
-          </a:prstGeom>
-          <a:noFill/>
-        </p:spPr>
-        <p:txBody>
-          <a:bodyPr wrap="square">
-            <a:spAutoFit/>
-          </a:bodyPr>
-          <a:lstStyle/>
-          <a:p>
-            <a:pPr algn="ctr"/>
-            <a:r>
-              <a:rPr sz="3400" b="1">
-                <a:solidFill>
-                  <a:srgbClr val="FFFFFF"/>
-                </a:solidFill>
-                <a:latin typeface="Calibri"/>
-              </a:rPr>
-              <a:t>Take it further</a:t>
-            </a:r>
-          </a:p>
-        </p:txBody>
-      </p:sp>
-      <p:sp>
-        <p:nvSpPr>
-          <p:cNvPr id="3" name="TextBox 2"/>
-          <p:cNvSpPr txBox="1"/>
-          <p:nvPr/>
-        </p:nvSpPr>
-        <p:spPr>
-          <a:xfrm>
-            <a:off x="1371600" y="3474720"/>
-            <a:ext cx="9418320" cy="2286000"/>
-          </a:xfrm>
-          <a:prstGeom prst="rect">
-            <a:avLst/>
-          </a:prstGeom>
-          <a:noFill/>
-        </p:spPr>
-        <p:txBody>
-          <a:bodyPr wrap="square">
-            <a:spAutoFit/>
-          </a:bodyPr>
-          <a:lstStyle/>
-          <a:p>
-            <a:pPr algn="ctr">
-              <a:spcAft>
-                <a:spcPts val="1000"/>
-              </a:spcAft>
-            </a:pPr>
-            <a:r>
-              <a:rPr sz="1600">
-                <a:solidFill>
-                  <a:srgbClr val="C8C0B0"/>
-                </a:solidFill>
-                <a:latin typeface="Calibri"/>
-              </a:rPr>
-              <a:t>Full architecture page: beaconwake.com/service-desk.html</a:t>
-            </a:r>
-          </a:p>
-          <a:p>
-            <a:pPr algn="ctr">
-              <a:spcAft>
-                <a:spcPts val="1000"/>
-              </a:spcAft>
-            </a:pPr>
-            <a:r>
-              <a:rPr sz="1600">
-                <a:solidFill>
-                  <a:srgbClr val="C8C0B0"/>
-                </a:solidFill>
-                <a:latin typeface="Calibri"/>
-              </a:rPr>
-              <a:t>Screen-by-screen mockup: beaconwake.com/service-desk-mockup.html</a:t>
-            </a:r>
-          </a:p>
-          <a:p>
-            <a:pPr algn="ctr">
-              <a:spcAft>
-                <a:spcPts val="1000"/>
-              </a:spcAft>
-            </a:pPr>
-            <a:r>
-              <a:rPr sz="1600">
-                <a:solidFill>
-                  <a:srgbClr val="C8C0B0"/>
-                </a:solidFill>
-                <a:latin typeface="Calibri"/>
-              </a:rPr>
-              <a:t>This deck &amp; the PDF guide: free, no signup</a:t>
-            </a:r>
-          </a:p>
-        </p:txBody>
-      </p:sp>
-    </p:spTree>
-  </p:cSld>
-  <p:clrMapOvr>
-    <a:masterClrMapping/>
-  </p:clrMapOvr>
-</p:sld>
-</file>
-
-<file path=ppt/slides/slide16.xml><?xml version="1.0" encoding="utf-8"?>
-<p:sld xmlns:a="http://schemas.openxmlformats.org/drawingml/2006/main" xmlns:p="http://schemas.openxmlformats.org/presentationml/2006/main" xmlns:r="http://schemas.openxmlformats.org/officeDocument/2006/relationships">
-  <p:cSld>
     <p:spTree>
       <p:nvGrpSpPr>
         <p:cNvPr id="1" name=""/>
@@ -5115,7 +3994,7 @@
 </p:sld>
 </file>
 
-<file path=ppt/slides/slide2.xml><?xml version="1.0" encoding="utf-8"?>
+<file path=ppt/slides/slide12.xml><?xml version="1.0" encoding="utf-8"?>
 <p:sld xmlns:a="http://schemas.openxmlformats.org/drawingml/2006/main" xmlns:p="http://schemas.openxmlformats.org/presentationml/2006/main" xmlns:r="http://schemas.openxmlformats.org/officeDocument/2006/relationships">
   <p:cSld>
     <p:bg>
@@ -5162,7 +4041,7 @@
                 </a:solidFill>
                 <a:latin typeface="Calibri"/>
               </a:rPr>
-              <a:t>Why a human still approves everything</a:t>
+              <a:t>Guardrails that make broad autonomy survivable</a:t>
             </a:r>
           </a:p>
         </p:txBody>
@@ -5218,7 +4097,7 @@
         </p:nvSpPr>
         <p:spPr>
           <a:xfrm>
-            <a:off x="548640" y="1463040"/>
+            <a:off x="548640" y="1417320"/>
             <a:ext cx="11064240" cy="4846320"/>
           </a:xfrm>
           <a:prstGeom prst="rect">
@@ -5241,20 +4120,20 @@
               </a:defRPr>
             </a:pPr>
             <a:r>
-              <a:rPr b="1" sz="1800">
+              <a:rPr b="1" sz="1600">
                 <a:solidFill>
                   <a:srgbClr val="C96343"/>
                 </a:solidFill>
               </a:rPr>
-              <a:t>Load-bearing, not decorative:  </a:t>
-            </a:r>
-            <a:r>
-              <a:rPr sz="1800">
+              <a:t>Least privilege, per domain:  </a:t>
+            </a:r>
+            <a:r>
+              <a:rPr sz="1600">
                 <a:solidFill>
                   <a:srgbClr val="1C1F26"/>
                 </a:solidFill>
               </a:rPr>
-              <a:t>"as autonomous as possible" and "only human interaction is to approve or arbitrate" are the same goal stated twice.</a:t>
+              <a:t>no standing domain-admin/enable-15/root credential — just-in-time from a vault.</a:t>
             </a:r>
           </a:p>
           <a:p>
@@ -5267,20 +4146,20 @@
               </a:defRPr>
             </a:pPr>
             <a:r>
-              <a:rPr b="1" sz="1800">
+              <a:rPr b="1" sz="1600">
                 <a:solidFill>
                   <a:srgbClr val="C96343"/>
                 </a:solidFill>
               </a:rPr>
-              <a:t>Every domain agent  </a:t>
-            </a:r>
-            <a:r>
-              <a:rPr sz="1800">
+              <a:t>Mandatory dry-run for Tier ≥2:  </a:t>
+            </a:r>
+            <a:r>
+              <a:rPr sz="1600">
                 <a:solidFill>
                   <a:srgbClr val="1C1F26"/>
                 </a:solidFill>
               </a:rPr>
-              <a:t>can read, plan, and propose without limit — none can commit a change without a plan that already passed the gate.</a:t>
+              <a:t>a real config diff, not a text description of intent.</a:t>
             </a:r>
           </a:p>
           <a:p>
@@ -5293,20 +4172,20 @@
               </a:defRPr>
             </a:pPr>
             <a:r>
-              <a:rPr b="1" sz="1800">
+              <a:rPr b="1" sz="1600">
                 <a:solidFill>
                   <a:srgbClr val="C96343"/>
                 </a:solidFill>
               </a:rPr>
-              <a:t>Blast radius:  </a:t>
-            </a:r>
-            <a:r>
-              <a:rPr sz="1800">
+              <a:t>Immutable audit log:  </a:t>
+            </a:r>
+            <a:r>
+              <a:rPr sz="1600">
                 <a:solidFill>
                   <a:srgbClr val="1C1F26"/>
                 </a:solidFill>
               </a:rPr>
-              <a:t>on infrastructure this broad (routers, firewalls, AD, hypervisors, call control), one wrong autonomous write can be a multi-day, multi-team incident.</a:t>
+              <a:t>every plan, approval, action, and verification result, appended, never edited.</a:t>
             </a:r>
           </a:p>
           <a:p>
@@ -5319,20 +4198,72 @@
               </a:defRPr>
             </a:pPr>
             <a:r>
-              <a:rPr b="1" sz="1800">
+              <a:rPr b="1" sz="1600">
                 <a:solidFill>
                   <a:srgbClr val="C96343"/>
                 </a:solidFill>
               </a:rPr>
-              <a:t>Same rule this project runs under:  </a:t>
-            </a:r>
-            <a:r>
-              <a:rPr sz="1800">
+              <a:t>Required rollback plan:  </a:t>
+            </a:r>
+            <a:r>
+              <a:rPr sz="1600">
                 <a:solidFill>
                   <a:srgbClr val="1C1F26"/>
                 </a:solidFill>
               </a:rPr>
-              <a:t>"anything irreversible, legally gray, or strange → write it down and wait," scaled from one agent to a team managing a real enterprise.</a:t>
+              <a:t>no mutating action ships without a paired undo step.</a:t>
+            </a:r>
+          </a:p>
+          <a:p>
+            <a:pPr>
+              <a:spcAft>
+                <a:spcPts val="1200"/>
+              </a:spcAft>
+              <a:defRPr>
+                <a:latin typeface="Calibri"/>
+              </a:defRPr>
+            </a:pPr>
+            <a:r>
+              <a:rPr b="1" sz="1600">
+                <a:solidFill>
+                  <a:srgbClr val="C96343"/>
+                </a:solidFill>
+              </a:rPr>
+              <a:t>Circuit breakers:  </a:t>
+            </a:r>
+            <a:r>
+              <a:rPr sz="1600">
+                <a:solidFill>
+                  <a:srgbClr val="1C1F26"/>
+                </a:solidFill>
+              </a:rPr>
+              <a:t>hard caps on actions-per-hour and blast-radius-per-action.</a:t>
+            </a:r>
+          </a:p>
+          <a:p>
+            <a:pPr>
+              <a:spcAft>
+                <a:spcPts val="1200"/>
+              </a:spcAft>
+              <a:defRPr>
+                <a:latin typeface="Calibri"/>
+              </a:defRPr>
+            </a:pPr>
+            <a:r>
+              <a:rPr b="1" sz="1600">
+                <a:solidFill>
+                  <a:srgbClr val="C96343"/>
+                </a:solidFill>
+              </a:rPr>
+              <a:t>Hard deny-list:  </a:t>
+            </a:r>
+            <a:r>
+              <a:rPr sz="1600">
+                <a:solidFill>
+                  <a:srgbClr val="1C1F26"/>
+                </a:solidFill>
+              </a:rPr>
+              <a:t>a small set of actions no tier and no approval can unlock.</a:t>
             </a:r>
           </a:p>
         </p:txBody>
@@ -5345,7 +4276,7 @@
 </p:sld>
 </file>
 
-<file path=ppt/slides/slide3.xml><?xml version="1.0" encoding="utf-8"?>
+<file path=ppt/slides/slide13.xml><?xml version="1.0" encoding="utf-8"?>
 <p:sld xmlns:a="http://schemas.openxmlformats.org/drawingml/2006/main" xmlns:p="http://schemas.openxmlformats.org/presentationml/2006/main" xmlns:r="http://schemas.openxmlformats.org/officeDocument/2006/relationships">
   <p:cSld>
     <p:bg>
@@ -5386,13 +4317,13 @@
           <a:lstStyle/>
           <a:p>
             <a:r>
-              <a:rPr sz="3000" b="1">
+              <a:rPr sz="2600" b="1">
                 <a:solidFill>
                   <a:srgbClr val="1C1F26"/>
                 </a:solidFill>
                 <a:latin typeface="Calibri"/>
               </a:rPr>
-              <a:t>High-level architecture</a:t>
+              <a:t>Deployment guide — Phase 0 &amp; 1</a:t>
             </a:r>
           </a:p>
         </p:txBody>
@@ -5440,24 +4371,1589 @@
           </a:p>
         </p:txBody>
       </p:sp>
+      <p:sp>
+        <p:nvSpPr>
+          <p:cNvPr id="4" name="TextBox 3"/>
+          <p:cNvSpPr txBox="1"/>
+          <p:nvPr/>
+        </p:nvSpPr>
+        <p:spPr>
+          <a:xfrm>
+            <a:off x="548640" y="1371600"/>
+            <a:ext cx="11064240" cy="4846320"/>
+          </a:xfrm>
+          <a:prstGeom prst="rect">
+            <a:avLst/>
+          </a:prstGeom>
+          <a:noFill/>
+        </p:spPr>
+        <p:txBody>
+          <a:bodyPr wrap="square">
+            <a:spAutoFit/>
+          </a:bodyPr>
+          <a:lstStyle/>
+          <a:p>
+            <a:pPr>
+              <a:spcAft>
+                <a:spcPts val="1200"/>
+              </a:spcAft>
+              <a:defRPr>
+                <a:latin typeface="Calibri"/>
+              </a:defRPr>
+            </a:pPr>
+            <a:r>
+              <a:rPr sz="1550">
+                <a:solidFill>
+                  <a:srgbClr val="1C1F26"/>
+                </a:solidFill>
+              </a:rPr>
+              <a:t>1. Stand up the audit log store first, before any agent code runs.</a:t>
+            </a:r>
+          </a:p>
+          <a:p>
+            <a:pPr>
+              <a:spcAft>
+                <a:spcPts val="1200"/>
+              </a:spcAft>
+              <a:defRPr>
+                <a:latin typeface="Calibri"/>
+              </a:defRPr>
+            </a:pPr>
+            <a:r>
+              <a:rPr sz="1550">
+                <a:solidFill>
+                  <a:srgbClr val="1C1F26"/>
+                </a:solidFill>
+              </a:rPr>
+              <a:t>2. Stand up NetBox (inventory/IPAM) and Zabbix + Grafana (monitoring) — Platform Ops depends on both later.</a:t>
+            </a:r>
+          </a:p>
+          <a:p>
+            <a:pPr>
+              <a:spcAft>
+                <a:spcPts val="1200"/>
+              </a:spcAft>
+              <a:defRPr>
+                <a:latin typeface="Calibri"/>
+              </a:defRPr>
+            </a:pPr>
+            <a:r>
+              <a:rPr sz="1550">
+                <a:solidFill>
+                  <a:srgbClr val="1C1F26"/>
+                </a:solidFill>
+              </a:rPr>
+              <a:t>3. Wire ServiceNow: subscribe to tickets, scoped CMDB read access, Zabbix → Incident webhook.</a:t>
+            </a:r>
+          </a:p>
+          <a:p>
+            <a:pPr>
+              <a:spcAft>
+                <a:spcPts val="1200"/>
+              </a:spcAft>
+              <a:defRPr>
+                <a:latin typeface="Calibri"/>
+              </a:defRPr>
+            </a:pPr>
+            <a:r>
+              <a:rPr sz="1550">
+                <a:solidFill>
+                  <a:srgbClr val="1C1F26"/>
+                </a:solidFill>
+              </a:rPr>
+              <a:t>4. Build the orchestrator's intake, classification, and risk-tier scorer.</a:t>
+            </a:r>
+          </a:p>
+          <a:p>
+            <a:pPr>
+              <a:spcAft>
+                <a:spcPts val="1200"/>
+              </a:spcAft>
+              <a:defRPr>
+                <a:latin typeface="Calibri"/>
+              </a:defRPr>
+            </a:pPr>
+            <a:r>
+              <a:rPr sz="1550">
+                <a:solidFill>
+                  <a:srgbClr val="1C1F26"/>
+                </a:solidFill>
+              </a:rPr>
+              <a:t>5–6. Draft-only for 4–6 weeks, tuning against what humans actually did — no execution yet.</a:t>
+            </a:r>
+          </a:p>
+          <a:p>
+            <a:pPr>
+              <a:spcAft>
+                <a:spcPts val="1200"/>
+              </a:spcAft>
+              <a:defRPr>
+                <a:latin typeface="Calibri"/>
+              </a:defRPr>
+            </a:pPr>
+            <a:r>
+              <a:rPr sz="1550">
+                <a:solidFill>
+                  <a:srgbClr val="1C1F26"/>
+                </a:solidFill>
+              </a:rPr>
+              <a:t>7–8. Build Identity/AD password reset end-to-end; auto-execute Tier 0–1 only.</a:t>
+            </a:r>
+          </a:p>
+          <a:p>
+            <a:pPr>
+              <a:spcAft>
+                <a:spcPts val="1200"/>
+              </a:spcAft>
+              <a:defRPr>
+                <a:latin typeface="Calibri"/>
+              </a:defRPr>
+            </a:pPr>
+            <a:r>
+              <a:rPr sz="1550">
+                <a:solidFill>
+                  <a:srgbClr val="1C1F26"/>
+                </a:solidFill>
+              </a:rPr>
+              <a:t>9–10. Circuit breakers before unattended execution; bring remaining Tier 1 agents online one at a time.</a:t>
+            </a:r>
+          </a:p>
+        </p:txBody>
+      </p:sp>
+    </p:spTree>
+  </p:cSld>
+  <p:clrMapOvr>
+    <a:masterClrMapping/>
+  </p:clrMapOvr>
+</p:sld>
+</file>
+
+<file path=ppt/slides/slide14.xml><?xml version="1.0" encoding="utf-8"?>
+<p:sld xmlns:a="http://schemas.openxmlformats.org/drawingml/2006/main" xmlns:p="http://schemas.openxmlformats.org/presentationml/2006/main" xmlns:r="http://schemas.openxmlformats.org/officeDocument/2006/relationships">
+  <p:cSld>
+    <p:bg>
+      <p:bgPr>
+        <a:solidFill>
+          <a:srgbClr val="FFFFFF"/>
+        </a:solidFill>
+        <a:effectLst/>
+      </p:bgPr>
+    </p:bg>
+    <p:spTree>
+      <p:nvGrpSpPr>
+        <p:cNvPr id="1" name=""/>
+        <p:cNvGrpSpPr/>
+        <p:nvPr/>
+      </p:nvGrpSpPr>
+      <p:grpSpPr/>
+      <p:sp>
+        <p:nvSpPr>
+          <p:cNvPr id="2" name="TextBox 1"/>
+          <p:cNvSpPr txBox="1"/>
+          <p:nvPr/>
+        </p:nvSpPr>
+        <p:spPr>
+          <a:xfrm>
+            <a:off x="548640" y="365760"/>
+            <a:ext cx="11064240" cy="914400"/>
+          </a:xfrm>
+          <a:prstGeom prst="rect">
+            <a:avLst/>
+          </a:prstGeom>
+          <a:noFill/>
+        </p:spPr>
+        <p:txBody>
+          <a:bodyPr wrap="square">
+            <a:spAutoFit/>
+          </a:bodyPr>
+          <a:lstStyle/>
+          <a:p>
+            <a:r>
+              <a:rPr sz="2600" b="1">
+                <a:solidFill>
+                  <a:srgbClr val="1C1F26"/>
+                </a:solidFill>
+                <a:latin typeface="Calibri"/>
+              </a:rPr>
+              <a:t>Deployment guide — Phase 2 &amp; 3</a:t>
+            </a:r>
+          </a:p>
+        </p:txBody>
+      </p:sp>
+      <p:sp>
+        <p:nvSpPr>
+          <p:cNvPr id="3" name="Rectangle 2"/>
+          <p:cNvSpPr/>
+          <p:nvPr/>
+        </p:nvSpPr>
+        <p:spPr>
+          <a:xfrm>
+            <a:off x="548640" y="1143000"/>
+            <a:ext cx="2743200" cy="27940"/>
+          </a:xfrm>
+          <a:prstGeom prst="rect">
+            <a:avLst/>
+          </a:prstGeom>
+          <a:solidFill>
+            <a:srgbClr val="C96343"/>
+          </a:solidFill>
+          <a:ln>
+            <a:noFill/>
+          </a:ln>
+        </p:spPr>
+        <p:style>
+          <a:lnRef idx="1">
+            <a:schemeClr val="accent1"/>
+          </a:lnRef>
+          <a:fillRef idx="3">
+            <a:schemeClr val="accent1"/>
+          </a:fillRef>
+          <a:effectRef idx="2">
+            <a:schemeClr val="accent1"/>
+          </a:effectRef>
+          <a:fontRef idx="minor">
+            <a:schemeClr val="lt1"/>
+          </a:fontRef>
+        </p:style>
+        <p:txBody>
+          <a:bodyPr rtlCol="0" anchor="ctr"/>
+          <a:lstStyle/>
+          <a:p>
+            <a:pPr algn="ctr"/>
+          </a:p>
+        </p:txBody>
+      </p:sp>
+      <p:sp>
+        <p:nvSpPr>
+          <p:cNvPr id="4" name="TextBox 3"/>
+          <p:cNvSpPr txBox="1"/>
+          <p:nvPr/>
+        </p:nvSpPr>
+        <p:spPr>
+          <a:xfrm>
+            <a:off x="548640" y="1371600"/>
+            <a:ext cx="11064240" cy="4846320"/>
+          </a:xfrm>
+          <a:prstGeom prst="rect">
+            <a:avLst/>
+          </a:prstGeom>
+          <a:noFill/>
+        </p:spPr>
+        <p:txBody>
+          <a:bodyPr wrap="square">
+            <a:spAutoFit/>
+          </a:bodyPr>
+          <a:lstStyle/>
+          <a:p>
+            <a:pPr>
+              <a:spcAft>
+                <a:spcPts val="1200"/>
+              </a:spcAft>
+              <a:defRPr>
+                <a:latin typeface="Calibri"/>
+              </a:defRPr>
+            </a:pPr>
+            <a:r>
+              <a:rPr sz="1550">
+                <a:solidFill>
+                  <a:srgbClr val="1C1F26"/>
+                </a:solidFill>
+              </a:rPr>
+              <a:t>11. Wire the ServiceNow native Approval record as the actual gate.</a:t>
+            </a:r>
+          </a:p>
+          <a:p>
+            <a:pPr>
+              <a:spcAft>
+                <a:spcPts val="1200"/>
+              </a:spcAft>
+              <a:defRPr>
+                <a:latin typeface="Calibri"/>
+              </a:defRPr>
+            </a:pPr>
+            <a:r>
+              <a:rPr sz="1550">
+                <a:solidFill>
+                  <a:srgbClr val="1C1F26"/>
+                </a:solidFill>
+              </a:rPr>
+              <a:t>12. Build mandatory dry-run per Tier 2 agent — Batfish becomes the Network agent's verification engine.</a:t>
+            </a:r>
+          </a:p>
+          <a:p>
+            <a:pPr>
+              <a:spcAft>
+                <a:spcPts val="1200"/>
+              </a:spcAft>
+              <a:defRPr>
+                <a:latin typeface="Calibri"/>
+              </a:defRPr>
+            </a:pPr>
+            <a:r>
+              <a:rPr sz="1550">
+                <a:solidFill>
+                  <a:srgbClr val="1C1F26"/>
+                </a:solidFill>
+              </a:rPr>
+              <a:t>13. Bring Tier 2 agents online one at a time behind the approval gate.</a:t>
+            </a:r>
+          </a:p>
+          <a:p>
+            <a:pPr>
+              <a:spcAft>
+                <a:spcPts val="1200"/>
+              </a:spcAft>
+              <a:defRPr>
+                <a:latin typeface="Calibri"/>
+              </a:defRPr>
+            </a:pPr>
+            <a:r>
+              <a:rPr sz="1550">
+                <a:solidFill>
+                  <a:srgbClr val="1C1F26"/>
+                </a:solidFill>
+              </a:rPr>
+              <a:t>14. Onboard Cisco ISE (Identity NAC) and Nexus Dashboard (DC fabric) — same burn-in discipline.</a:t>
+            </a:r>
+          </a:p>
+          <a:p>
+            <a:pPr>
+              <a:spcAft>
+                <a:spcPts val="1200"/>
+              </a:spcAft>
+              <a:defRPr>
+                <a:latin typeface="Calibri"/>
+              </a:defRPr>
+            </a:pPr>
+            <a:r>
+              <a:rPr sz="1550">
+                <a:solidFill>
+                  <a:srgbClr val="1C1F26"/>
+                </a:solidFill>
+              </a:rPr>
+              <a:t>15. Build Platform Ops last, once the framework has a track record.</a:t>
+            </a:r>
+          </a:p>
+          <a:p>
+            <a:pPr>
+              <a:spcAft>
+                <a:spcPts val="1200"/>
+              </a:spcAft>
+              <a:defRPr>
+                <a:latin typeface="Calibri"/>
+              </a:defRPr>
+            </a:pPr>
+            <a:r>
+              <a:rPr sz="1550">
+                <a:solidFill>
+                  <a:srgbClr val="1C1F26"/>
+                </a:solidFill>
+              </a:rPr>
+              <a:t>16. Formalize two-person approval for Tier 3 and the arbitration flow.</a:t>
+            </a:r>
+          </a:p>
+          <a:p>
+            <a:pPr>
+              <a:spcAft>
+                <a:spcPts val="1200"/>
+              </a:spcAft>
+              <a:defRPr>
+                <a:latin typeface="Calibri"/>
+              </a:defRPr>
+            </a:pPr>
+            <a:r>
+              <a:rPr sz="1550">
+                <a:solidFill>
+                  <a:srgbClr val="1C1F26"/>
+                </a:solidFill>
+              </a:rPr>
+              <a:t>17. Establish a recurring (monthly) audit of auto-executed Tier 0–1 actions against the log.</a:t>
+            </a:r>
+          </a:p>
+        </p:txBody>
+      </p:sp>
+    </p:spTree>
+  </p:cSld>
+  <p:clrMapOvr>
+    <a:masterClrMapping/>
+  </p:clrMapOvr>
+</p:sld>
+</file>
+
+<file path=ppt/slides/slide15.xml><?xml version="1.0" encoding="utf-8"?>
+<p:sld xmlns:a="http://schemas.openxmlformats.org/drawingml/2006/main" xmlns:p="http://schemas.openxmlformats.org/presentationml/2006/main" xmlns:r="http://schemas.openxmlformats.org/officeDocument/2006/relationships">
+  <p:cSld>
+    <p:bg>
+      <p:bgPr>
+        <a:solidFill>
+          <a:srgbClr val="FFFFFF"/>
+        </a:solidFill>
+        <a:effectLst/>
+      </p:bgPr>
+    </p:bg>
+    <p:spTree>
+      <p:nvGrpSpPr>
+        <p:cNvPr id="1" name=""/>
+        <p:cNvGrpSpPr/>
+        <p:nvPr/>
+      </p:nvGrpSpPr>
+      <p:grpSpPr/>
+      <p:sp>
+        <p:nvSpPr>
+          <p:cNvPr id="2" name="TextBox 1"/>
+          <p:cNvSpPr txBox="1"/>
+          <p:nvPr/>
+        </p:nvSpPr>
+        <p:spPr>
+          <a:xfrm>
+            <a:off x="548640" y="365760"/>
+            <a:ext cx="11064240" cy="914400"/>
+          </a:xfrm>
+          <a:prstGeom prst="rect">
+            <a:avLst/>
+          </a:prstGeom>
+          <a:noFill/>
+        </p:spPr>
+        <p:txBody>
+          <a:bodyPr wrap="square">
+            <a:spAutoFit/>
+          </a:bodyPr>
+          <a:lstStyle/>
+          <a:p>
+            <a:r>
+              <a:rPr sz="3200" b="1">
+                <a:solidFill>
+                  <a:srgbClr val="1C1F26"/>
+                </a:solidFill>
+                <a:latin typeface="Calibri"/>
+              </a:rPr>
+              <a:t>What this is and isn't</a:t>
+            </a:r>
+          </a:p>
+        </p:txBody>
+      </p:sp>
+      <p:sp>
+        <p:nvSpPr>
+          <p:cNvPr id="3" name="Rectangle 2"/>
+          <p:cNvSpPr/>
+          <p:nvPr/>
+        </p:nvSpPr>
+        <p:spPr>
+          <a:xfrm>
+            <a:off x="548640" y="1143000"/>
+            <a:ext cx="2743200" cy="27940"/>
+          </a:xfrm>
+          <a:prstGeom prst="rect">
+            <a:avLst/>
+          </a:prstGeom>
+          <a:solidFill>
+            <a:srgbClr val="C96343"/>
+          </a:solidFill>
+          <a:ln>
+            <a:noFill/>
+          </a:ln>
+        </p:spPr>
+        <p:style>
+          <a:lnRef idx="1">
+            <a:schemeClr val="accent1"/>
+          </a:lnRef>
+          <a:fillRef idx="3">
+            <a:schemeClr val="accent1"/>
+          </a:fillRef>
+          <a:effectRef idx="2">
+            <a:schemeClr val="accent1"/>
+          </a:effectRef>
+          <a:fontRef idx="minor">
+            <a:schemeClr val="lt1"/>
+          </a:fontRef>
+        </p:style>
+        <p:txBody>
+          <a:bodyPr rtlCol="0" anchor="ctr"/>
+          <a:lstStyle/>
+          <a:p>
+            <a:pPr algn="ctr"/>
+          </a:p>
+        </p:txBody>
+      </p:sp>
+      <p:sp>
+        <p:nvSpPr>
+          <p:cNvPr id="4" name="TextBox 3"/>
+          <p:cNvSpPr txBox="1"/>
+          <p:nvPr/>
+        </p:nvSpPr>
+        <p:spPr>
+          <a:xfrm>
+            <a:off x="548640" y="1554480"/>
+            <a:ext cx="11064240" cy="4846320"/>
+          </a:xfrm>
+          <a:prstGeom prst="rect">
+            <a:avLst/>
+          </a:prstGeom>
+          <a:noFill/>
+        </p:spPr>
+        <p:txBody>
+          <a:bodyPr wrap="square">
+            <a:spAutoFit/>
+          </a:bodyPr>
+          <a:lstStyle/>
+          <a:p>
+            <a:pPr>
+              <a:spcAft>
+                <a:spcPts val="1200"/>
+              </a:spcAft>
+              <a:defRPr>
+                <a:latin typeface="Calibri"/>
+              </a:defRPr>
+            </a:pPr>
+            <a:r>
+              <a:rPr b="1" sz="1900">
+                <a:solidFill>
+                  <a:srgbClr val="C96343"/>
+                </a:solidFill>
+              </a:rPr>
+              <a:t>This is:  </a:t>
+            </a:r>
+            <a:r>
+              <a:rPr sz="1900">
+                <a:solidFill>
+                  <a:srgbClr val="1C1F26"/>
+                </a:solidFill>
+              </a:rPr>
+              <a:t>an architecture blueprint — the shape of the system, trust boundaries, and checkpoints, worked out on paper first.</a:t>
+            </a:r>
+          </a:p>
+          <a:p>
+            <a:pPr>
+              <a:spcAft>
+                <a:spcPts val="1200"/>
+              </a:spcAft>
+              <a:defRPr>
+                <a:latin typeface="Calibri"/>
+              </a:defRPr>
+            </a:pPr>
+            <a:r>
+              <a:rPr b="1" sz="1900">
+                <a:solidFill>
+                  <a:srgbClr val="C96343"/>
+                </a:solidFill>
+              </a:rPr>
+              <a:t>This isn't:  </a:t>
+            </a:r>
+            <a:r>
+              <a:rPr sz="1900">
+                <a:solidFill>
+                  <a:srgbClr val="1C1F26"/>
+                </a:solidFill>
+              </a:rPr>
+              <a:t>a running deployment. No ServiceNow tenant, no Cisco/AD/VMware credentials, no reachable enterprise network here.</a:t>
+            </a:r>
+          </a:p>
+          <a:p>
+            <a:pPr>
+              <a:spcAft>
+                <a:spcPts val="1200"/>
+              </a:spcAft>
+              <a:defRPr>
+                <a:latin typeface="Calibri"/>
+              </a:defRPr>
+            </a:pPr>
+            <a:r>
+              <a:rPr b="1" sz="1900">
+                <a:solidFill>
+                  <a:srgbClr val="C96343"/>
+                </a:solidFill>
+              </a:rPr>
+              <a:t>Standing up live write-access  </a:t>
+            </a:r>
+            <a:r>
+              <a:rPr sz="1900">
+                <a:solidFill>
+                  <a:srgbClr val="1C1F26"/>
+                </a:solidFill>
+              </a:rPr>
+              <a:t>to someone's routers, directory, and hypervisors is a real person's decision, made deliberately, with real scoped credentials they grant.</a:t>
+            </a:r>
+          </a:p>
+        </p:txBody>
+      </p:sp>
+    </p:spTree>
+  </p:cSld>
+  <p:clrMapOvr>
+    <a:masterClrMapping/>
+  </p:clrMapOvr>
+</p:sld>
+</file>
+
+<file path=ppt/slides/slide16.xml><?xml version="1.0" encoding="utf-8"?>
+<p:sld xmlns:a="http://schemas.openxmlformats.org/drawingml/2006/main" xmlns:p="http://schemas.openxmlformats.org/presentationml/2006/main" xmlns:r="http://schemas.openxmlformats.org/officeDocument/2006/relationships">
+  <p:cSld>
+    <p:bg>
+      <p:bgPr>
+        <a:solidFill>
+          <a:srgbClr val="1C1F26"/>
+        </a:solidFill>
+        <a:effectLst/>
+      </p:bgPr>
+    </p:bg>
+    <p:spTree>
+      <p:nvGrpSpPr>
+        <p:cNvPr id="1" name=""/>
+        <p:cNvGrpSpPr/>
+        <p:nvPr/>
+      </p:nvGrpSpPr>
+      <p:grpSpPr/>
+      <p:sp>
+        <p:nvSpPr>
+          <p:cNvPr id="2" name="TextBox 1"/>
+          <p:cNvSpPr txBox="1"/>
+          <p:nvPr/>
+        </p:nvSpPr>
+        <p:spPr>
+          <a:xfrm>
+            <a:off x="914400" y="2377440"/>
+            <a:ext cx="10332720" cy="1097280"/>
+          </a:xfrm>
+          <a:prstGeom prst="rect">
+            <a:avLst/>
+          </a:prstGeom>
+          <a:noFill/>
+        </p:spPr>
+        <p:txBody>
+          <a:bodyPr wrap="square">
+            <a:spAutoFit/>
+          </a:bodyPr>
+          <a:lstStyle/>
+          <a:p>
+            <a:pPr algn="ctr"/>
+            <a:r>
+              <a:rPr sz="3400" b="1">
+                <a:solidFill>
+                  <a:srgbClr val="FFFFFF"/>
+                </a:solidFill>
+                <a:latin typeface="Calibri"/>
+              </a:rPr>
+              <a:t>Take it further</a:t>
+            </a:r>
+          </a:p>
+        </p:txBody>
+      </p:sp>
+      <p:sp>
+        <p:nvSpPr>
+          <p:cNvPr id="3" name="TextBox 2"/>
+          <p:cNvSpPr txBox="1"/>
+          <p:nvPr/>
+        </p:nvSpPr>
+        <p:spPr>
+          <a:xfrm>
+            <a:off x="1371600" y="3474720"/>
+            <a:ext cx="9418320" cy="2286000"/>
+          </a:xfrm>
+          <a:prstGeom prst="rect">
+            <a:avLst/>
+          </a:prstGeom>
+          <a:noFill/>
+        </p:spPr>
+        <p:txBody>
+          <a:bodyPr wrap="square">
+            <a:spAutoFit/>
+          </a:bodyPr>
+          <a:lstStyle/>
+          <a:p>
+            <a:pPr algn="ctr">
+              <a:spcAft>
+                <a:spcPts val="1000"/>
+              </a:spcAft>
+            </a:pPr>
+            <a:r>
+              <a:rPr sz="1600">
+                <a:solidFill>
+                  <a:srgbClr val="C8C0B0"/>
+                </a:solidFill>
+                <a:latin typeface="Calibri"/>
+              </a:rPr>
+              <a:t>Full architecture page: beaconwake.com/service-desk.html</a:t>
+            </a:r>
+          </a:p>
+          <a:p>
+            <a:pPr algn="ctr">
+              <a:spcAft>
+                <a:spcPts val="1000"/>
+              </a:spcAft>
+            </a:pPr>
+            <a:r>
+              <a:rPr sz="1600">
+                <a:solidFill>
+                  <a:srgbClr val="C8C0B0"/>
+                </a:solidFill>
+                <a:latin typeface="Calibri"/>
+              </a:rPr>
+              <a:t>Screen-by-screen mockup: beaconwake.com/service-desk-mockup.html</a:t>
+            </a:r>
+          </a:p>
+          <a:p>
+            <a:pPr algn="ctr">
+              <a:spcAft>
+                <a:spcPts val="1000"/>
+              </a:spcAft>
+            </a:pPr>
+            <a:r>
+              <a:rPr sz="1600">
+                <a:solidFill>
+                  <a:srgbClr val="C8C0B0"/>
+                </a:solidFill>
+                <a:latin typeface="Calibri"/>
+              </a:rPr>
+              <a:t>This deck &amp; the PDF guide: free, no signup</a:t>
+            </a:r>
+          </a:p>
+        </p:txBody>
+      </p:sp>
+    </p:spTree>
+  </p:cSld>
+  <p:clrMapOvr>
+    <a:masterClrMapping/>
+  </p:clrMapOvr>
+</p:sld>
+</file>
+
+<file path=ppt/slides/slide17.xml><?xml version="1.0" encoding="utf-8"?>
+<p:sld xmlns:a="http://schemas.openxmlformats.org/drawingml/2006/main" xmlns:p="http://schemas.openxmlformats.org/presentationml/2006/main" xmlns:r="http://schemas.openxmlformats.org/officeDocument/2006/relationships">
+  <p:cSld>
+    <p:spTree>
+      <p:nvGrpSpPr>
+        <p:cNvPr id="1" name=""/>
+        <p:cNvGrpSpPr/>
+        <p:nvPr/>
+      </p:nvGrpSpPr>
+      <p:grpSpPr/>
+      <p:sp>
+        <p:nvSpPr>
+          <p:cNvPr id="2" name="TextBox 1"/>
+          <p:cNvSpPr txBox="1"/>
+          <p:nvPr/>
+        </p:nvSpPr>
+        <p:spPr>
+          <a:xfrm>
+            <a:off x="548640" y="365760"/>
+            <a:ext cx="11064240" cy="914400"/>
+          </a:xfrm>
+          <a:prstGeom prst="rect">
+            <a:avLst/>
+          </a:prstGeom>
+          <a:noFill/>
+        </p:spPr>
+        <p:txBody>
+          <a:bodyPr wrap="none">
+            <a:spAutoFit/>
+          </a:bodyPr>
+          <a:lstStyle/>
+          <a:p>
+            <a:r>
+              <a:rPr sz="2500" b="1">
+                <a:solidFill>
+                  <a:srgbClr val="1C1F26"/>
+                </a:solidFill>
+              </a:rPr>
+              <a:t>Supporting systems (continued) — network, security, cloud &amp; endpoint consoles</a:t>
+            </a:r>
+          </a:p>
+        </p:txBody>
+      </p:sp>
+      <p:sp>
+        <p:nvSpPr>
+          <p:cNvPr id="3" name="Rectangle 2"/>
+          <p:cNvSpPr/>
+          <p:nvPr/>
+        </p:nvSpPr>
+        <p:spPr>
+          <a:xfrm>
+            <a:off x="548640" y="1143000"/>
+            <a:ext cx="2743200" cy="27940"/>
+          </a:xfrm>
+          <a:prstGeom prst="rect">
+            <a:avLst/>
+          </a:prstGeom>
+          <a:solidFill>
+            <a:srgbClr val="C96343"/>
+          </a:solidFill>
+          <a:ln>
+            <a:noFill/>
+          </a:ln>
+        </p:spPr>
+        <p:style>
+          <a:lnRef idx="1">
+            <a:schemeClr val="accent1"/>
+          </a:lnRef>
+          <a:fillRef idx="3">
+            <a:schemeClr val="accent1"/>
+          </a:fillRef>
+          <a:effectRef idx="2">
+            <a:schemeClr val="accent1"/>
+          </a:effectRef>
+          <a:fontRef idx="minor">
+            <a:schemeClr val="lt1"/>
+          </a:fontRef>
+        </p:style>
+        <p:txBody>
+          <a:bodyPr rtlCol="0" anchor="ctr"/>
+          <a:lstStyle/>
+          <a:p>
+            <a:pPr algn="ctr"/>
+          </a:p>
+        </p:txBody>
+      </p:sp>
+      <p:graphicFrame>
+        <p:nvGraphicFramePr>
+          <p:cNvPr id="4" name="Table 3"/>
+          <p:cNvGraphicFramePr>
+            <a:graphicFrameLocks noGrp="1"/>
+          </p:cNvGraphicFramePr>
+          <p:nvPr/>
+        </p:nvGraphicFramePr>
+        <p:xfrm>
+          <a:off x="548640" y="1417320"/>
+          <a:ext cx="11064240" cy="4023360"/>
+        </p:xfrm>
+        <a:graphic>
+          <a:graphicData uri="http://schemas.openxmlformats.org/drawingml/2006/table">
+            <a:tbl>
+              <a:tblPr firstRow="1" bandRow="1">
+                <a:tableStyleId>{5C22544A-7EE6-4342-B048-85BDC9FD1C3A}</a:tableStyleId>
+                <a:tableStyleId>{5C22544A-7EE6-4342-B048-85BDC9FD1C3A}</a:tableStyleId>
+              </a:tblPr>
+              <a:tblGrid>
+                <a:gridCol w="2011680"/>
+                <a:gridCol w="5120640"/>
+                <a:gridCol w="3931920"/>
+              </a:tblGrid>
+              <a:tr h="502920">
+                <a:tc>
+                  <a:txBody>
+                    <a:bodyPr/>
+                    <a:lstStyle/>
+                    <a:p>
+                      <a:r>
+                        <a:rPr sz="1300" b="1">
+                          <a:solidFill>
+                            <a:srgbClr val="FFFFFF"/>
+                          </a:solidFill>
+                        </a:rPr>
+                        <a:t>System</a:t>
+                      </a:r>
+                    </a:p>
+                  </a:txBody>
+                  <a:tcPr/>
+                </a:tc>
+                <a:tc>
+                  <a:txBody>
+                    <a:bodyPr/>
+                    <a:lstStyle/>
+                    <a:p>
+                      <a:r>
+                        <a:rPr sz="1300" b="1">
+                          <a:solidFill>
+                            <a:srgbClr val="FFFFFF"/>
+                          </a:solidFill>
+                        </a:rPr>
+                        <a:t>Role</a:t>
+                      </a:r>
+                    </a:p>
+                  </a:txBody>
+                  <a:tcPr/>
+                </a:tc>
+                <a:tc>
+                  <a:txBody>
+                    <a:bodyPr/>
+                    <a:lstStyle/>
+                    <a:p>
+                      <a:r>
+                        <a:rPr sz="1300" b="1">
+                          <a:solidFill>
+                            <a:srgbClr val="FFFFFF"/>
+                          </a:solidFill>
+                        </a:rPr>
+                        <a:t>Feeds / used by</a:t>
+                      </a:r>
+                    </a:p>
+                  </a:txBody>
+                  <a:tcPr/>
+                </a:tc>
+              </a:tr>
+              <a:tr h="502920">
+                <a:tc>
+                  <a:txBody>
+                    <a:bodyPr/>
+                    <a:lstStyle/>
+                    <a:p>
+                      <a:r>
+                        <a:rPr sz="1300" b="1"/>
+                        <a:t>Cisco Firepower Mgmt. Center</a:t>
+                      </a:r>
+                    </a:p>
+                  </a:txBody>
+                  <a:tcPr/>
+                </a:tc>
+                <a:tc>
+                  <a:txBody>
+                    <a:bodyPr/>
+                    <a:lstStyle/>
+                    <a:p>
+                      <a:r>
+                        <a:rPr sz="1300" b="0"/>
+                        <a:t>Centralized policy for Cisco FTD/ASA firewalls</a:t>
+                      </a:r>
+                    </a:p>
+                  </a:txBody>
+                  <a:tcPr/>
+                </a:tc>
+                <a:tc>
+                  <a:txBody>
+                    <a:bodyPr/>
+                    <a:lstStyle/>
+                    <a:p>
+                      <a:r>
+                        <a:rPr sz="1300" b="0"/>
+                        <a:t>Firewall agent — fleet-wide policy push/rollback</a:t>
+                      </a:r>
+                    </a:p>
+                  </a:txBody>
+                  <a:tcPr/>
+                </a:tc>
+              </a:tr>
+              <a:tr h="502920">
+                <a:tc>
+                  <a:txBody>
+                    <a:bodyPr/>
+                    <a:lstStyle/>
+                    <a:p>
+                      <a:r>
+                        <a:rPr sz="1300" b="1"/>
+                        <a:t>Cisco Catalyst Center</a:t>
+                      </a:r>
+                    </a:p>
+                  </a:txBody>
+                  <a:tcPr/>
+                </a:tc>
+                <a:tc>
+                  <a:txBody>
+                    <a:bodyPr/>
+                    <a:lstStyle/>
+                    <a:p>
+                      <a:r>
+                        <a:rPr sz="1300" b="0"/>
+                        <a:t>SD-Access campus/branch automation &amp; assurance</a:t>
+                      </a:r>
+                    </a:p>
+                  </a:txBody>
+                  <a:tcPr/>
+                </a:tc>
+                <a:tc>
+                  <a:txBody>
+                    <a:bodyPr/>
+                    <a:lstStyle/>
+                    <a:p>
+                      <a:r>
+                        <a:rPr sz="1300" b="0"/>
+                        <a:t>Network agent — campus/branch counterpart to Nexus Dashboard</a:t>
+                      </a:r>
+                    </a:p>
+                  </a:txBody>
+                  <a:tcPr/>
+                </a:tc>
+              </a:tr>
+              <a:tr h="502920">
+                <a:tc>
+                  <a:txBody>
+                    <a:bodyPr/>
+                    <a:lstStyle/>
+                    <a:p>
+                      <a:r>
+                        <a:rPr sz="1300" b="1"/>
+                        <a:t>VMware Aria</a:t>
+                      </a:r>
+                    </a:p>
+                  </a:txBody>
+                  <a:tcPr/>
+                </a:tc>
+                <a:tc>
+                  <a:txBody>
+                    <a:bodyPr/>
+                    <a:lstStyle/>
+                    <a:p>
+                      <a:r>
+                        <a:rPr sz="1300" b="0"/>
+                        <a:t>Capacity analytics (Operations) &amp; automation (formerly vRealize)</a:t>
+                      </a:r>
+                    </a:p>
+                  </a:txBody>
+                  <a:tcPr/>
+                </a:tc>
+                <a:tc>
+                  <a:txBody>
+                    <a:bodyPr/>
+                    <a:lstStyle/>
+                    <a:p>
+                      <a:r>
+                        <a:rPr sz="1300" b="0"/>
+                        <a:t>VMware agent — trend-based capacity planning</a:t>
+                      </a:r>
+                    </a:p>
+                  </a:txBody>
+                  <a:tcPr/>
+                </a:tc>
+              </a:tr>
+              <a:tr h="502920">
+                <a:tc>
+                  <a:txBody>
+                    <a:bodyPr/>
+                    <a:lstStyle/>
+                    <a:p>
+                      <a:r>
+                        <a:rPr sz="1300" b="1"/>
+                        <a:t>Microsoft SCOM</a:t>
+                      </a:r>
+                    </a:p>
+                  </a:txBody>
+                  <a:tcPr/>
+                </a:tc>
+                <a:tc>
+                  <a:txBody>
+                    <a:bodyPr/>
+                    <a:lstStyle/>
+                    <a:p>
+                      <a:r>
+                        <a:rPr sz="1300" b="0"/>
+                        <a:t>On-prem infrastructure/app monitoring via management packs</a:t>
+                      </a:r>
+                    </a:p>
+                  </a:txBody>
+                  <a:tcPr/>
+                </a:tc>
+                <a:tc>
+                  <a:txBody>
+                    <a:bodyPr/>
+                    <a:lstStyle/>
+                    <a:p>
+                      <a:r>
+                        <a:rPr sz="1300" b="0"/>
+                        <a:t>Platform Ops, alongside Zabbix</a:t>
+                      </a:r>
+                    </a:p>
+                  </a:txBody>
+                  <a:tcPr/>
+                </a:tc>
+              </a:tr>
+              <a:tr h="502920">
+                <a:tc>
+                  <a:txBody>
+                    <a:bodyPr/>
+                    <a:lstStyle/>
+                    <a:p>
+                      <a:r>
+                        <a:rPr sz="1300" b="1"/>
+                        <a:t>Azure Monitor</a:t>
+                      </a:r>
+                    </a:p>
+                  </a:txBody>
+                  <a:tcPr/>
+                </a:tc>
+                <a:tc>
+                  <a:txBody>
+                    <a:bodyPr/>
+                    <a:lstStyle/>
+                    <a:p>
+                      <a:r>
+                        <a:rPr sz="1300" b="0"/>
+                        <a:t>Cloud-native metrics, logs &amp; alerting for Azure/Arc resources</a:t>
+                      </a:r>
+                    </a:p>
+                  </a:txBody>
+                  <a:tcPr/>
+                </a:tc>
+                <a:tc>
+                  <a:txBody>
+                    <a:bodyPr/>
+                    <a:lstStyle/>
+                    <a:p>
+                      <a:r>
+                        <a:rPr sz="1300" b="0"/>
+                        <a:t>Platform Ops — cloud counterpart to SCOM/Zabbix</a:t>
+                      </a:r>
+                    </a:p>
+                  </a:txBody>
+                  <a:tcPr/>
+                </a:tc>
+              </a:tr>
+              <a:tr h="502920">
+                <a:tc>
+                  <a:txBody>
+                    <a:bodyPr/>
+                    <a:lstStyle/>
+                    <a:p>
+                      <a:r>
+                        <a:rPr sz="1300" b="1"/>
+                        <a:t>Microsoft MECM</a:t>
+                      </a:r>
+                    </a:p>
+                  </a:txBody>
+                  <a:tcPr/>
+                </a:tc>
+                <a:tc>
+                  <a:txBody>
+                    <a:bodyPr/>
+                    <a:lstStyle/>
+                    <a:p>
+                      <a:r>
+                        <a:rPr sz="1300" b="0"/>
+                        <a:t>On-prem endpoint lifecycle mgmt (formerly SCCM)</a:t>
+                      </a:r>
+                    </a:p>
+                  </a:txBody>
+                  <a:tcPr/>
+                </a:tc>
+                <a:tc>
+                  <a:txBody>
+                    <a:bodyPr/>
+                    <a:lstStyle/>
+                    <a:p>
+                      <a:r>
+                        <a:rPr sz="1300" b="0"/>
+                        <a:t>Desktop agent — on-prem/co-managed Windows half</a:t>
+                      </a:r>
+                    </a:p>
+                  </a:txBody>
+                  <a:tcPr/>
+                </a:tc>
+              </a:tr>
+              <a:tr h="502920">
+                <a:tc>
+                  <a:txBody>
+                    <a:bodyPr/>
+                    <a:lstStyle/>
+                    <a:p>
+                      <a:r>
+                        <a:rPr sz="1300" b="1"/>
+                        <a:t>Red Hat Satellite</a:t>
+                      </a:r>
+                    </a:p>
+                  </a:txBody>
+                  <a:tcPr/>
+                </a:tc>
+                <a:tc>
+                  <a:txBody>
+                    <a:bodyPr/>
+                    <a:lstStyle/>
+                    <a:p>
+                      <a:r>
+                        <a:rPr sz="1300" b="0"/>
+                        <a:t>Fleet-wide RHEL patch/content/subscription lifecycle</a:t>
+                      </a:r>
+                    </a:p>
+                  </a:txBody>
+                  <a:tcPr/>
+                </a:tc>
+                <a:tc>
+                  <a:txBody>
+                    <a:bodyPr/>
+                    <a:lstStyle/>
+                    <a:p>
+                      <a:r>
+                        <a:rPr sz="1300" b="0"/>
+                        <a:t>Linux Server agent — RHEL analogue of MECM</a:t>
+                      </a:r>
+                    </a:p>
+                  </a:txBody>
+                  <a:tcPr/>
+                </a:tc>
+              </a:tr>
+            </a:tbl>
+          </a:graphicData>
+        </a:graphic>
+      </p:graphicFrame>
+      <p:sp>
+        <p:nvSpPr>
+          <p:cNvPr id="5" name="TextBox 4"/>
+          <p:cNvSpPr txBox="1"/>
+          <p:nvPr/>
+        </p:nvSpPr>
+        <p:spPr>
+          <a:xfrm>
+            <a:off x="548640" y="5623560"/>
+            <a:ext cx="11064240" cy="914400"/>
+          </a:xfrm>
+          <a:prstGeom prst="rect">
+            <a:avLst/>
+          </a:prstGeom>
+          <a:noFill/>
+        </p:spPr>
+        <p:txBody>
+          <a:bodyPr wrap="none">
+            <a:spAutoFit/>
+          </a:bodyPr>
+          <a:lstStyle/>
+          <a:p>
+            <a:r>
+              <a:rPr sz="1200">
+                <a:solidFill>
+                  <a:srgbClr val="5B6270"/>
+                </a:solidFill>
+              </a:rPr>
+              <a:t>Each extends one existing domain agent or Platform Ops from the architecture page — no eleventh agent, no new credential class, same tier and approval rules as everything else.</a:t>
+            </a:r>
+          </a:p>
+        </p:txBody>
+      </p:sp>
+    </p:spTree>
+  </p:cSld>
+  <p:clrMapOvr>
+    <a:masterClrMapping/>
+  </p:clrMapOvr>
+</p:sld>
+</file>
+
+<file path=ppt/slides/slide2.xml><?xml version="1.0" encoding="utf-8"?>
+<p:sld xmlns:a="http://schemas.openxmlformats.org/drawingml/2006/main" xmlns:p="http://schemas.openxmlformats.org/presentationml/2006/main" xmlns:r="http://schemas.openxmlformats.org/officeDocument/2006/relationships">
+  <p:cSld>
+    <p:bg>
+      <p:bgPr>
+        <a:solidFill>
+          <a:srgbClr val="FFFFFF"/>
+        </a:solidFill>
+        <a:effectLst/>
+      </p:bgPr>
+    </p:bg>
+    <p:spTree>
+      <p:nvGrpSpPr>
+        <p:cNvPr id="1" name=""/>
+        <p:cNvGrpSpPr/>
+        <p:nvPr/>
+      </p:nvGrpSpPr>
+      <p:grpSpPr/>
+      <p:sp>
+        <p:nvSpPr>
+          <p:cNvPr id="2" name="TextBox 1"/>
+          <p:cNvSpPr txBox="1"/>
+          <p:nvPr/>
+        </p:nvSpPr>
+        <p:spPr>
+          <a:xfrm>
+            <a:off x="548640" y="365760"/>
+            <a:ext cx="11064240" cy="914400"/>
+          </a:xfrm>
+          <a:prstGeom prst="rect">
+            <a:avLst/>
+          </a:prstGeom>
+          <a:noFill/>
+        </p:spPr>
+        <p:txBody>
+          <a:bodyPr wrap="square">
+            <a:spAutoFit/>
+          </a:bodyPr>
+          <a:lstStyle/>
+          <a:p>
+            <a:r>
+              <a:rPr sz="3200" b="1">
+                <a:solidFill>
+                  <a:srgbClr val="1C1F26"/>
+                </a:solidFill>
+                <a:latin typeface="Calibri"/>
+              </a:rPr>
+              <a:t>Why a human still approves everything</a:t>
+            </a:r>
+          </a:p>
+        </p:txBody>
+      </p:sp>
+      <p:sp>
+        <p:nvSpPr>
+          <p:cNvPr id="3" name="Rectangle 2"/>
+          <p:cNvSpPr/>
+          <p:nvPr/>
+        </p:nvSpPr>
+        <p:spPr>
+          <a:xfrm>
+            <a:off x="548640" y="1143000"/>
+            <a:ext cx="2743200" cy="27940"/>
+          </a:xfrm>
+          <a:prstGeom prst="rect">
+            <a:avLst/>
+          </a:prstGeom>
+          <a:solidFill>
+            <a:srgbClr val="C96343"/>
+          </a:solidFill>
+          <a:ln>
+            <a:noFill/>
+          </a:ln>
+        </p:spPr>
+        <p:style>
+          <a:lnRef idx="1">
+            <a:schemeClr val="accent1"/>
+          </a:lnRef>
+          <a:fillRef idx="3">
+            <a:schemeClr val="accent1"/>
+          </a:fillRef>
+          <a:effectRef idx="2">
+            <a:schemeClr val="accent1"/>
+          </a:effectRef>
+          <a:fontRef idx="minor">
+            <a:schemeClr val="lt1"/>
+          </a:fontRef>
+        </p:style>
+        <p:txBody>
+          <a:bodyPr rtlCol="0" anchor="ctr"/>
+          <a:lstStyle/>
+          <a:p>
+            <a:pPr algn="ctr"/>
+          </a:p>
+        </p:txBody>
+      </p:sp>
+      <p:sp>
+        <p:nvSpPr>
+          <p:cNvPr id="4" name="TextBox 3"/>
+          <p:cNvSpPr txBox="1"/>
+          <p:nvPr/>
+        </p:nvSpPr>
+        <p:spPr>
+          <a:xfrm>
+            <a:off x="548640" y="1463040"/>
+            <a:ext cx="11064240" cy="4846320"/>
+          </a:xfrm>
+          <a:prstGeom prst="rect">
+            <a:avLst/>
+          </a:prstGeom>
+          <a:noFill/>
+        </p:spPr>
+        <p:txBody>
+          <a:bodyPr wrap="square">
+            <a:spAutoFit/>
+          </a:bodyPr>
+          <a:lstStyle/>
+          <a:p>
+            <a:pPr>
+              <a:spcAft>
+                <a:spcPts val="1200"/>
+              </a:spcAft>
+              <a:defRPr>
+                <a:latin typeface="Calibri"/>
+              </a:defRPr>
+            </a:pPr>
+            <a:r>
+              <a:rPr b="1" sz="1800">
+                <a:solidFill>
+                  <a:srgbClr val="C96343"/>
+                </a:solidFill>
+              </a:rPr>
+              <a:t>Load-bearing, not decorative:  </a:t>
+            </a:r>
+            <a:r>
+              <a:rPr sz="1800">
+                <a:solidFill>
+                  <a:srgbClr val="1C1F26"/>
+                </a:solidFill>
+              </a:rPr>
+              <a:t>"as autonomous as possible" and "only human interaction is to approve or arbitrate" are the same goal stated twice.</a:t>
+            </a:r>
+          </a:p>
+          <a:p>
+            <a:pPr>
+              <a:spcAft>
+                <a:spcPts val="1200"/>
+              </a:spcAft>
+              <a:defRPr>
+                <a:latin typeface="Calibri"/>
+              </a:defRPr>
+            </a:pPr>
+            <a:r>
+              <a:rPr b="1" sz="1800">
+                <a:solidFill>
+                  <a:srgbClr val="C96343"/>
+                </a:solidFill>
+              </a:rPr>
+              <a:t>Every domain agent  </a:t>
+            </a:r>
+            <a:r>
+              <a:rPr sz="1800">
+                <a:solidFill>
+                  <a:srgbClr val="1C1F26"/>
+                </a:solidFill>
+              </a:rPr>
+              <a:t>can read, plan, and propose without limit — none can commit a change without a plan that already passed the gate.</a:t>
+            </a:r>
+          </a:p>
+          <a:p>
+            <a:pPr>
+              <a:spcAft>
+                <a:spcPts val="1200"/>
+              </a:spcAft>
+              <a:defRPr>
+                <a:latin typeface="Calibri"/>
+              </a:defRPr>
+            </a:pPr>
+            <a:r>
+              <a:rPr b="1" sz="1800">
+                <a:solidFill>
+                  <a:srgbClr val="C96343"/>
+                </a:solidFill>
+              </a:rPr>
+              <a:t>Blast radius:  </a:t>
+            </a:r>
+            <a:r>
+              <a:rPr sz="1800">
+                <a:solidFill>
+                  <a:srgbClr val="1C1F26"/>
+                </a:solidFill>
+              </a:rPr>
+              <a:t>on infrastructure this broad (routers, firewalls, AD, hypervisors, call control), one wrong autonomous write can be a multi-day, multi-team incident.</a:t>
+            </a:r>
+          </a:p>
+          <a:p>
+            <a:pPr>
+              <a:spcAft>
+                <a:spcPts val="1200"/>
+              </a:spcAft>
+              <a:defRPr>
+                <a:latin typeface="Calibri"/>
+              </a:defRPr>
+            </a:pPr>
+            <a:r>
+              <a:rPr b="1" sz="1800">
+                <a:solidFill>
+                  <a:srgbClr val="C96343"/>
+                </a:solidFill>
+              </a:rPr>
+              <a:t>Same rule this project runs under:  </a:t>
+            </a:r>
+            <a:r>
+              <a:rPr sz="1800">
+                <a:solidFill>
+                  <a:srgbClr val="1C1F26"/>
+                </a:solidFill>
+              </a:rPr>
+              <a:t>"anything irreversible, legally gray, or strange → write it down and wait," scaled from one agent to a team managing a real enterprise.</a:t>
+            </a:r>
+          </a:p>
+        </p:txBody>
+      </p:sp>
+    </p:spTree>
+  </p:cSld>
+  <p:clrMapOvr>
+    <a:masterClrMapping/>
+  </p:clrMapOvr>
+</p:sld>
+</file>
+
+<file path=ppt/slides/slide3.xml><?xml version="1.0" encoding="utf-8"?>
+<p:sld xmlns:a="http://schemas.openxmlformats.org/drawingml/2006/main" xmlns:p="http://schemas.openxmlformats.org/presentationml/2006/main" xmlns:r="http://schemas.openxmlformats.org/officeDocument/2006/relationships">
+  <p:cSld>
+    <p:bg>
+      <p:bgPr>
+        <a:solidFill>
+          <a:srgbClr val="FFFFFF"/>
+        </a:solidFill>
+        <a:effectLst/>
+      </p:bgPr>
+    </p:bg>
+    <p:spTree>
+      <p:nvGrpSpPr>
+        <p:cNvPr id="1" name=""/>
+        <p:cNvGrpSpPr/>
+        <p:nvPr/>
+      </p:nvGrpSpPr>
+      <p:grpSpPr/>
+      <p:sp>
+        <p:nvSpPr>
+          <p:cNvPr id="2" name="TextBox 1"/>
+          <p:cNvSpPr txBox="1"/>
+          <p:nvPr/>
+        </p:nvSpPr>
+        <p:spPr>
+          <a:xfrm>
+            <a:off x="548640" y="365760"/>
+            <a:ext cx="11064240" cy="914400"/>
+          </a:xfrm>
+          <a:prstGeom prst="rect">
+            <a:avLst/>
+          </a:prstGeom>
+          <a:noFill/>
+        </p:spPr>
+        <p:txBody>
+          <a:bodyPr wrap="square">
+            <a:spAutoFit/>
+          </a:bodyPr>
+          <a:lstStyle/>
+          <a:p>
+            <a:r>
+              <a:rPr sz="3000" b="1">
+                <a:solidFill>
+                  <a:srgbClr val="1C1F26"/>
+                </a:solidFill>
+                <a:latin typeface="Calibri"/>
+              </a:rPr>
+              <a:t>High-level architecture</a:t>
+            </a:r>
+          </a:p>
+        </p:txBody>
+      </p:sp>
+      <p:sp>
+        <p:nvSpPr>
+          <p:cNvPr id="3" name="Rectangle 2"/>
+          <p:cNvSpPr/>
+          <p:nvPr/>
+        </p:nvSpPr>
+        <p:spPr>
+          <a:xfrm>
+            <a:off x="548640" y="1143000"/>
+            <a:ext cx="2743200" cy="27940"/>
+          </a:xfrm>
+          <a:prstGeom prst="rect">
+            <a:avLst/>
+          </a:prstGeom>
+          <a:solidFill>
+            <a:srgbClr val="C96343"/>
+          </a:solidFill>
+          <a:ln>
+            <a:noFill/>
+          </a:ln>
+        </p:spPr>
+        <p:style>
+          <a:lnRef idx="1">
+            <a:schemeClr val="accent1"/>
+          </a:lnRef>
+          <a:fillRef idx="3">
+            <a:schemeClr val="accent1"/>
+          </a:fillRef>
+          <a:effectRef idx="2">
+            <a:schemeClr val="accent1"/>
+          </a:effectRef>
+          <a:fontRef idx="minor">
+            <a:schemeClr val="lt1"/>
+          </a:fontRef>
+        </p:style>
+        <p:txBody>
+          <a:bodyPr rtlCol="0" anchor="ctr"/>
+          <a:lstStyle/>
+          <a:p>
+            <a:pPr algn="ctr"/>
+          </a:p>
+        </p:txBody>
+      </p:sp>
       <p:pic>
         <p:nvPicPr>
-          <p:cNvPr id="4" name="Picture 3" descr="arch.png"/>
+          <p:cNvPr id="4" name="Picture 3" descr="arch_diagram_print.png"/>
           <p:cNvPicPr>
             <a:picLocks noChangeAspect="1"/>
           </p:cNvPicPr>
           <p:nvPr/>
         </p:nvPicPr>
         <p:blipFill>
-          <a:blip r:embed="rId2"/>
+          <a:blip r:embed="rId3"/>
           <a:stretch>
             <a:fillRect/>
           </a:stretch>
         </p:blipFill>
         <p:spPr>
           <a:xfrm>
-            <a:off x="1031478" y="1371600"/>
-            <a:ext cx="10128738" cy="5120640"/>
+            <a:off x="1491100" y="1371600"/>
+            <a:ext cx="9209495" cy="5186400"/>
           </a:xfrm>
           <a:prstGeom prst="rect">
             <a:avLst/>
@@ -5729,7 +6225,7 @@
                         <a:rPr sz="1300">
                           <a:latin typeface="Calibri"/>
                         </a:rPr>
-                        <a:t>IOS/NX-OS, Ansible, NetBox, Batfish, Nexus Dashboard</a:t>
+                        <a:t>IOS/NX-OS, Ansible, NetBox, Batfish, Nexus Dashboard, Catalyst Center</a:t>
                       </a:r>
                     </a:p>
                   </a:txBody>
@@ -5963,7 +6459,7 @@
                         <a:rPr sz="1300">
                           <a:latin typeface="Calibri"/>
                         </a:rPr>
-                        <a:t>SSH, Ansible</a:t>
+                        <a:t>SSH, Ansible, Red Hat Satellite</a:t>
                       </a:r>
                     </a:p>
                   </a:txBody>
@@ -6119,7 +6615,7 @@
                         <a:rPr sz="1300">
                           <a:latin typeface="Calibri"/>
                         </a:rPr>
-                        <a:t>Vendor REST API (Palo Alto/Fortinet/ASA)</a:t>
+                        <a:t>Vendor REST API (Palo Alto/Fortinet/ASA), Cisco FMC</a:t>
                       </a:r>
                     </a:p>
                   </a:txBody>
@@ -6275,7 +6771,7 @@
                         <a:rPr sz="1300">
                           <a:latin typeface="Calibri"/>
                         </a:rPr>
-                        <a:t>vCenter API / PowerCLI</a:t>
+                        <a:t>vCenter API / PowerCLI, VMware Aria</a:t>
                       </a:r>
                     </a:p>
                   </a:txBody>
@@ -6353,7 +6849,7 @@
                         <a:rPr sz="1300">
                           <a:latin typeface="Calibri"/>
                         </a:rPr>
-                        <a:t>Intune / Jamf APIs</a:t>
+                        <a:t>Intune / Jamf APIs, Microsoft MECM</a:t>
                       </a:r>
                     </a:p>
                   </a:txBody>

</xml_diff>

<commit_message>
Add operations model & SOP, and APC power management to service-desk architecture
Per josh's request: a new day-two operations model (roles, on-call, incident
response lifecycle with a redrawn diagram, change/maintenance windows, backup/DR,
security ops, and a periodic review cadence) at operations-sop.html, plus APC
power management (UPS/PDU) added as the 15th supporting system across the
architecture page, integration guide, both PDFs, and the pptx.

Co-Authored-By: Claude Sonnet 5 <noreply@anthropic.com>
</commit_message>
<xml_diff>
--- a/website/service-desk-architecture.pptx
+++ b/website/service-desk-architecture.pptx
@@ -3311,13 +3311,13 @@
           <a:lstStyle/>
           <a:p>
             <a:r>
-              <a:rPr sz="2600" b="1">
+              <a:rPr sz="3000" b="1">
                 <a:solidFill>
                   <a:srgbClr val="1C1F26"/>
                 </a:solidFill>
                 <a:latin typeface="Calibri"/>
               </a:rPr>
-              <a:t>Self-healing, self-patching, self-maintaining</a:t>
+              <a:t>Phased rollout</a:t>
             </a:r>
           </a:p>
         </p:txBody>
@@ -3365,6 +3365,133 @@
           </a:p>
         </p:txBody>
       </p:sp>
+      <p:pic>
+        <p:nvPicPr>
+          <p:cNvPr id="4" name="Picture 3" descr="phases.png"/>
+          <p:cNvPicPr>
+            <a:picLocks noChangeAspect="1"/>
+          </p:cNvPicPr>
+          <p:nvPr/>
+        </p:nvPicPr>
+        <p:blipFill>
+          <a:blip r:embed="rId2"/>
+          <a:stretch>
+            <a:fillRect/>
+          </a:stretch>
+        </p:blipFill>
+        <p:spPr>
+          <a:xfrm>
+            <a:off x="472287" y="2377440"/>
+            <a:ext cx="11247120" cy="1624584"/>
+          </a:xfrm>
+          <a:prstGeom prst="rect">
+            <a:avLst/>
+          </a:prstGeom>
+        </p:spPr>
+      </p:pic>
+    </p:spTree>
+  </p:cSld>
+  <p:clrMapOvr>
+    <a:masterClrMapping/>
+  </p:clrMapOvr>
+</p:sld>
+</file>
+
+<file path=ppt/slides/slide11.xml><?xml version="1.0" encoding="utf-8"?>
+<p:sld xmlns:a="http://schemas.openxmlformats.org/drawingml/2006/main" xmlns:p="http://schemas.openxmlformats.org/presentationml/2006/main" xmlns:r="http://schemas.openxmlformats.org/officeDocument/2006/relationships">
+  <p:cSld>
+    <p:bg>
+      <p:bgPr>
+        <a:solidFill>
+          <a:srgbClr val="FFFFFF"/>
+        </a:solidFill>
+        <a:effectLst/>
+      </p:bgPr>
+    </p:bg>
+    <p:spTree>
+      <p:nvGrpSpPr>
+        <p:cNvPr id="1" name=""/>
+        <p:cNvGrpSpPr/>
+        <p:nvPr/>
+      </p:nvGrpSpPr>
+      <p:grpSpPr/>
+      <p:sp>
+        <p:nvSpPr>
+          <p:cNvPr id="2" name="TextBox 1"/>
+          <p:cNvSpPr txBox="1"/>
+          <p:nvPr/>
+        </p:nvSpPr>
+        <p:spPr>
+          <a:xfrm>
+            <a:off x="548640" y="365760"/>
+            <a:ext cx="11064240" cy="914400"/>
+          </a:xfrm>
+          <a:prstGeom prst="rect">
+            <a:avLst/>
+          </a:prstGeom>
+          <a:noFill/>
+        </p:spPr>
+        <p:txBody>
+          <a:bodyPr wrap="square">
+            <a:spAutoFit/>
+          </a:bodyPr>
+          <a:lstStyle/>
+          <a:p>
+            <a:r>
+              <a:rPr sz="2600" b="1">
+                <a:solidFill>
+                  <a:srgbClr val="1C1F26"/>
+                </a:solidFill>
+                <a:latin typeface="Calibri"/>
+              </a:rPr>
+              <a:t>Self-healing, self-patching, self-maintaining</a:t>
+            </a:r>
+          </a:p>
+        </p:txBody>
+      </p:sp>
+      <p:sp>
+        <p:nvSpPr>
+          <p:cNvPr id="3" name="Rectangle 2"/>
+          <p:cNvSpPr/>
+          <p:nvPr/>
+        </p:nvSpPr>
+        <p:spPr>
+          <a:xfrm>
+            <a:off x="548640" y="1143000"/>
+            <a:ext cx="2743200" cy="27940"/>
+          </a:xfrm>
+          <a:prstGeom prst="rect">
+            <a:avLst/>
+          </a:prstGeom>
+          <a:solidFill>
+            <a:srgbClr val="C96343"/>
+          </a:solidFill>
+          <a:ln>
+            <a:noFill/>
+          </a:ln>
+        </p:spPr>
+        <p:style>
+          <a:lnRef idx="1">
+            <a:schemeClr val="accent1"/>
+          </a:lnRef>
+          <a:fillRef idx="3">
+            <a:schemeClr val="accent1"/>
+          </a:fillRef>
+          <a:effectRef idx="2">
+            <a:schemeClr val="accent1"/>
+          </a:effectRef>
+          <a:fontRef idx="minor">
+            <a:schemeClr val="lt1"/>
+          </a:fontRef>
+        </p:style>
+        <p:txBody>
+          <a:bodyPr rtlCol="0" anchor="ctr"/>
+          <a:lstStyle/>
+          <a:p>
+            <a:pPr algn="ctr"/>
+          </a:p>
+        </p:txBody>
+      </p:sp>
       <p:graphicFrame>
         <p:nvGraphicFramePr>
           <p:cNvPr id="4" name="Table 3"/>
@@ -3751,6 +3878,65 @@
                   </a:tcPr>
                 </a:tc>
               </a:tr>
+              <a:tr h="502920">
+                <a:tc>
+                  <a:txBody>
+                    <a:bodyPr/>
+                    <a:lstStyle/>
+                    <a:p>
+                      <a:r>
+                        <a:rPr sz="1300">
+                          <a:latin typeface="Calibri"/>
+                        </a:rPr>
+                        <a:t>APC UPS on-battery, runtime under threshold</a:t>
+                      </a:r>
+                    </a:p>
+                  </a:txBody>
+                  <a:tcPr marL="73152" marR="73152" marT="36576" marB="36576" anchor="ctr">
+                    <a:solidFill>
+                      <a:srgbClr val="FFFFFF"/>
+                    </a:solidFill>
+                  </a:tcPr>
+                </a:tc>
+                <a:tc>
+                  <a:txBody>
+                    <a:bodyPr/>
+                    <a:lstStyle/>
+                    <a:p>
+                      <a:r>
+                        <a:rPr sz="1300">
+                          <a:latin typeface="Calibri"/>
+                        </a:rPr>
+                        <a:t>Trigger graceful shutdown sequence (VMware, then Windows/Linux Server agents) before battery exhausts</a:t>
+                      </a:r>
+                    </a:p>
+                  </a:txBody>
+                  <a:tcPr marL="73152" marR="73152" marT="36576" marB="36576" anchor="ctr">
+                    <a:solidFill>
+                      <a:srgbClr val="FFFFFF"/>
+                    </a:solidFill>
+                  </a:tcPr>
+                </a:tc>
+                <a:tc>
+                  <a:txBody>
+                    <a:bodyPr/>
+                    <a:lstStyle/>
+                    <a:p>
+                      <a:r>
+                        <a:rPr sz="1300">
+                          <a:latin typeface="Calibri"/>
+                        </a:rPr>
+                        <a:t>Tier 1</a:t>
+                      </a:r>
+                    </a:p>
+                  </a:txBody>
+                  <a:tcPr marL="73152" marR="73152" marT="36576" marB="36576" anchor="ctr">
+                    <a:solidFill>
+                      <a:srgbClr val="FFFFFF"/>
+                    </a:solidFill>
+                  </a:tcPr>
+                </a:tc>
+              </a:tr>
             </a:tbl>
           </a:graphicData>
         </a:graphic>
@@ -3797,7 +3983,7 @@
 </p:sld>
 </file>
 
-<file path=ppt/slides/slide11.xml><?xml version="1.0" encoding="utf-8"?>
+<file path=ppt/slides/slide12.xml><?xml version="1.0" encoding="utf-8"?>
 <p:sld xmlns:a="http://schemas.openxmlformats.org/drawingml/2006/main" xmlns:p="http://schemas.openxmlformats.org/presentationml/2006/main" xmlns:r="http://schemas.openxmlformats.org/officeDocument/2006/relationships">
   <p:cSld>
     <p:spTree>
@@ -3994,7 +4180,7 @@
 </p:sld>
 </file>
 
-<file path=ppt/slides/slide12.xml><?xml version="1.0" encoding="utf-8"?>
+<file path=ppt/slides/slide13.xml><?xml version="1.0" encoding="utf-8"?>
 <p:sld xmlns:a="http://schemas.openxmlformats.org/drawingml/2006/main" xmlns:p="http://schemas.openxmlformats.org/presentationml/2006/main" xmlns:r="http://schemas.openxmlformats.org/officeDocument/2006/relationships">
   <p:cSld>
     <p:bg>
@@ -4276,7 +4462,7 @@
 </p:sld>
 </file>
 
-<file path=ppt/slides/slide13.xml><?xml version="1.0" encoding="utf-8"?>
+<file path=ppt/slides/slide14.xml><?xml version="1.0" encoding="utf-8"?>
 <p:sld xmlns:a="http://schemas.openxmlformats.org/drawingml/2006/main" xmlns:p="http://schemas.openxmlformats.org/presentationml/2006/main" xmlns:r="http://schemas.openxmlformats.org/officeDocument/2006/relationships">
   <p:cSld>
     <p:bg>
@@ -4528,7 +4714,7 @@
 </p:sld>
 </file>
 
-<file path=ppt/slides/slide14.xml><?xml version="1.0" encoding="utf-8"?>
+<file path=ppt/slides/slide15.xml><?xml version="1.0" encoding="utf-8"?>
 <p:sld xmlns:a="http://schemas.openxmlformats.org/drawingml/2006/main" xmlns:p="http://schemas.openxmlformats.org/presentationml/2006/main" xmlns:r="http://schemas.openxmlformats.org/officeDocument/2006/relationships">
   <p:cSld>
     <p:bg>
@@ -4780,7 +4966,7 @@
 </p:sld>
 </file>
 
-<file path=ppt/slides/slide15.xml><?xml version="1.0" encoding="utf-8"?>
+<file path=ppt/slides/slide16.xml><?xml version="1.0" encoding="utf-8"?>
 <p:sld xmlns:a="http://schemas.openxmlformats.org/drawingml/2006/main" xmlns:p="http://schemas.openxmlformats.org/presentationml/2006/main" xmlns:r="http://schemas.openxmlformats.org/officeDocument/2006/relationships">
   <p:cSld>
     <p:bg>
@@ -4984,7 +5170,7 @@
 </p:sld>
 </file>
 
-<file path=ppt/slides/slide16.xml><?xml version="1.0" encoding="utf-8"?>
+<file path=ppt/slides/slide17.xml><?xml version="1.0" encoding="utf-8"?>
 <p:sld xmlns:a="http://schemas.openxmlformats.org/drawingml/2006/main" xmlns:p="http://schemas.openxmlformats.org/presentationml/2006/main" xmlns:r="http://schemas.openxmlformats.org/officeDocument/2006/relationships">
   <p:cSld>
     <p:bg>
@@ -5116,9 +5302,17 @@
 </p:sld>
 </file>
 
-<file path=ppt/slides/slide17.xml><?xml version="1.0" encoding="utf-8"?>
+<file path=ppt/slides/slide2.xml><?xml version="1.0" encoding="utf-8"?>
 <p:sld xmlns:a="http://schemas.openxmlformats.org/drawingml/2006/main" xmlns:p="http://schemas.openxmlformats.org/presentationml/2006/main" xmlns:r="http://schemas.openxmlformats.org/officeDocument/2006/relationships">
   <p:cSld>
+    <p:bg>
+      <p:bgPr>
+        <a:solidFill>
+          <a:srgbClr val="FFFFFF"/>
+        </a:solidFill>
+        <a:effectLst/>
+      </p:bgPr>
+    </p:bg>
     <p:spTree>
       <p:nvGrpSpPr>
         <p:cNvPr id="1" name=""/>
@@ -5143,18 +5337,19 @@
           <a:noFill/>
         </p:spPr>
         <p:txBody>
-          <a:bodyPr wrap="none">
+          <a:bodyPr wrap="square">
             <a:spAutoFit/>
           </a:bodyPr>
           <a:lstStyle/>
           <a:p>
             <a:r>
-              <a:rPr sz="2500" b="1">
+              <a:rPr sz="3200" b="1">
                 <a:solidFill>
                   <a:srgbClr val="1C1F26"/>
                 </a:solidFill>
+                <a:latin typeface="Calibri"/>
               </a:rPr>
-              <a:t>Supporting systems (continued) — network, security, cloud &amp; endpoint consoles</a:t>
+              <a:t>Why a human still approves everything</a:t>
             </a:r>
           </a:p>
         </p:txBody>
@@ -5202,384 +5397,16 @@
           </a:p>
         </p:txBody>
       </p:sp>
-      <p:graphicFrame>
-        <p:nvGraphicFramePr>
-          <p:cNvPr id="4" name="Table 3"/>
-          <p:cNvGraphicFramePr>
-            <a:graphicFrameLocks noGrp="1"/>
-          </p:cNvGraphicFramePr>
-          <p:nvPr/>
-        </p:nvGraphicFramePr>
-        <p:xfrm>
-          <a:off x="548640" y="1417320"/>
-          <a:ext cx="11064240" cy="4023360"/>
-        </p:xfrm>
-        <a:graphic>
-          <a:graphicData uri="http://schemas.openxmlformats.org/drawingml/2006/table">
-            <a:tbl>
-              <a:tblPr firstRow="1" bandRow="1">
-                <a:tableStyleId>{5C22544A-7EE6-4342-B048-85BDC9FD1C3A}</a:tableStyleId>
-                <a:tableStyleId>{5C22544A-7EE6-4342-B048-85BDC9FD1C3A}</a:tableStyleId>
-              </a:tblPr>
-              <a:tblGrid>
-                <a:gridCol w="2011680"/>
-                <a:gridCol w="5120640"/>
-                <a:gridCol w="3931920"/>
-              </a:tblGrid>
-              <a:tr h="502920">
-                <a:tc>
-                  <a:txBody>
-                    <a:bodyPr/>
-                    <a:lstStyle/>
-                    <a:p>
-                      <a:r>
-                        <a:rPr sz="1300" b="1">
-                          <a:solidFill>
-                            <a:srgbClr val="FFFFFF"/>
-                          </a:solidFill>
-                        </a:rPr>
-                        <a:t>System</a:t>
-                      </a:r>
-                    </a:p>
-                  </a:txBody>
-                  <a:tcPr/>
-                </a:tc>
-                <a:tc>
-                  <a:txBody>
-                    <a:bodyPr/>
-                    <a:lstStyle/>
-                    <a:p>
-                      <a:r>
-                        <a:rPr sz="1300" b="1">
-                          <a:solidFill>
-                            <a:srgbClr val="FFFFFF"/>
-                          </a:solidFill>
-                        </a:rPr>
-                        <a:t>Role</a:t>
-                      </a:r>
-                    </a:p>
-                  </a:txBody>
-                  <a:tcPr/>
-                </a:tc>
-                <a:tc>
-                  <a:txBody>
-                    <a:bodyPr/>
-                    <a:lstStyle/>
-                    <a:p>
-                      <a:r>
-                        <a:rPr sz="1300" b="1">
-                          <a:solidFill>
-                            <a:srgbClr val="FFFFFF"/>
-                          </a:solidFill>
-                        </a:rPr>
-                        <a:t>Feeds / used by</a:t>
-                      </a:r>
-                    </a:p>
-                  </a:txBody>
-                  <a:tcPr/>
-                </a:tc>
-              </a:tr>
-              <a:tr h="502920">
-                <a:tc>
-                  <a:txBody>
-                    <a:bodyPr/>
-                    <a:lstStyle/>
-                    <a:p>
-                      <a:r>
-                        <a:rPr sz="1300" b="1"/>
-                        <a:t>Cisco Firepower Mgmt. Center</a:t>
-                      </a:r>
-                    </a:p>
-                  </a:txBody>
-                  <a:tcPr/>
-                </a:tc>
-                <a:tc>
-                  <a:txBody>
-                    <a:bodyPr/>
-                    <a:lstStyle/>
-                    <a:p>
-                      <a:r>
-                        <a:rPr sz="1300" b="0"/>
-                        <a:t>Centralized policy for Cisco FTD/ASA firewalls</a:t>
-                      </a:r>
-                    </a:p>
-                  </a:txBody>
-                  <a:tcPr/>
-                </a:tc>
-                <a:tc>
-                  <a:txBody>
-                    <a:bodyPr/>
-                    <a:lstStyle/>
-                    <a:p>
-                      <a:r>
-                        <a:rPr sz="1300" b="0"/>
-                        <a:t>Firewall agent — fleet-wide policy push/rollback</a:t>
-                      </a:r>
-                    </a:p>
-                  </a:txBody>
-                  <a:tcPr/>
-                </a:tc>
-              </a:tr>
-              <a:tr h="502920">
-                <a:tc>
-                  <a:txBody>
-                    <a:bodyPr/>
-                    <a:lstStyle/>
-                    <a:p>
-                      <a:r>
-                        <a:rPr sz="1300" b="1"/>
-                        <a:t>Cisco Catalyst Center</a:t>
-                      </a:r>
-                    </a:p>
-                  </a:txBody>
-                  <a:tcPr/>
-                </a:tc>
-                <a:tc>
-                  <a:txBody>
-                    <a:bodyPr/>
-                    <a:lstStyle/>
-                    <a:p>
-                      <a:r>
-                        <a:rPr sz="1300" b="0"/>
-                        <a:t>SD-Access campus/branch automation &amp; assurance</a:t>
-                      </a:r>
-                    </a:p>
-                  </a:txBody>
-                  <a:tcPr/>
-                </a:tc>
-                <a:tc>
-                  <a:txBody>
-                    <a:bodyPr/>
-                    <a:lstStyle/>
-                    <a:p>
-                      <a:r>
-                        <a:rPr sz="1300" b="0"/>
-                        <a:t>Network agent — campus/branch counterpart to Nexus Dashboard</a:t>
-                      </a:r>
-                    </a:p>
-                  </a:txBody>
-                  <a:tcPr/>
-                </a:tc>
-              </a:tr>
-              <a:tr h="502920">
-                <a:tc>
-                  <a:txBody>
-                    <a:bodyPr/>
-                    <a:lstStyle/>
-                    <a:p>
-                      <a:r>
-                        <a:rPr sz="1300" b="1"/>
-                        <a:t>VMware Aria</a:t>
-                      </a:r>
-                    </a:p>
-                  </a:txBody>
-                  <a:tcPr/>
-                </a:tc>
-                <a:tc>
-                  <a:txBody>
-                    <a:bodyPr/>
-                    <a:lstStyle/>
-                    <a:p>
-                      <a:r>
-                        <a:rPr sz="1300" b="0"/>
-                        <a:t>Capacity analytics (Operations) &amp; automation (formerly vRealize)</a:t>
-                      </a:r>
-                    </a:p>
-                  </a:txBody>
-                  <a:tcPr/>
-                </a:tc>
-                <a:tc>
-                  <a:txBody>
-                    <a:bodyPr/>
-                    <a:lstStyle/>
-                    <a:p>
-                      <a:r>
-                        <a:rPr sz="1300" b="0"/>
-                        <a:t>VMware agent — trend-based capacity planning</a:t>
-                      </a:r>
-                    </a:p>
-                  </a:txBody>
-                  <a:tcPr/>
-                </a:tc>
-              </a:tr>
-              <a:tr h="502920">
-                <a:tc>
-                  <a:txBody>
-                    <a:bodyPr/>
-                    <a:lstStyle/>
-                    <a:p>
-                      <a:r>
-                        <a:rPr sz="1300" b="1"/>
-                        <a:t>Microsoft SCOM</a:t>
-                      </a:r>
-                    </a:p>
-                  </a:txBody>
-                  <a:tcPr/>
-                </a:tc>
-                <a:tc>
-                  <a:txBody>
-                    <a:bodyPr/>
-                    <a:lstStyle/>
-                    <a:p>
-                      <a:r>
-                        <a:rPr sz="1300" b="0"/>
-                        <a:t>On-prem infrastructure/app monitoring via management packs</a:t>
-                      </a:r>
-                    </a:p>
-                  </a:txBody>
-                  <a:tcPr/>
-                </a:tc>
-                <a:tc>
-                  <a:txBody>
-                    <a:bodyPr/>
-                    <a:lstStyle/>
-                    <a:p>
-                      <a:r>
-                        <a:rPr sz="1300" b="0"/>
-                        <a:t>Platform Ops, alongside Zabbix</a:t>
-                      </a:r>
-                    </a:p>
-                  </a:txBody>
-                  <a:tcPr/>
-                </a:tc>
-              </a:tr>
-              <a:tr h="502920">
-                <a:tc>
-                  <a:txBody>
-                    <a:bodyPr/>
-                    <a:lstStyle/>
-                    <a:p>
-                      <a:r>
-                        <a:rPr sz="1300" b="1"/>
-                        <a:t>Azure Monitor</a:t>
-                      </a:r>
-                    </a:p>
-                  </a:txBody>
-                  <a:tcPr/>
-                </a:tc>
-                <a:tc>
-                  <a:txBody>
-                    <a:bodyPr/>
-                    <a:lstStyle/>
-                    <a:p>
-                      <a:r>
-                        <a:rPr sz="1300" b="0"/>
-                        <a:t>Cloud-native metrics, logs &amp; alerting for Azure/Arc resources</a:t>
-                      </a:r>
-                    </a:p>
-                  </a:txBody>
-                  <a:tcPr/>
-                </a:tc>
-                <a:tc>
-                  <a:txBody>
-                    <a:bodyPr/>
-                    <a:lstStyle/>
-                    <a:p>
-                      <a:r>
-                        <a:rPr sz="1300" b="0"/>
-                        <a:t>Platform Ops — cloud counterpart to SCOM/Zabbix</a:t>
-                      </a:r>
-                    </a:p>
-                  </a:txBody>
-                  <a:tcPr/>
-                </a:tc>
-              </a:tr>
-              <a:tr h="502920">
-                <a:tc>
-                  <a:txBody>
-                    <a:bodyPr/>
-                    <a:lstStyle/>
-                    <a:p>
-                      <a:r>
-                        <a:rPr sz="1300" b="1"/>
-                        <a:t>Microsoft MECM</a:t>
-                      </a:r>
-                    </a:p>
-                  </a:txBody>
-                  <a:tcPr/>
-                </a:tc>
-                <a:tc>
-                  <a:txBody>
-                    <a:bodyPr/>
-                    <a:lstStyle/>
-                    <a:p>
-                      <a:r>
-                        <a:rPr sz="1300" b="0"/>
-                        <a:t>On-prem endpoint lifecycle mgmt (formerly SCCM)</a:t>
-                      </a:r>
-                    </a:p>
-                  </a:txBody>
-                  <a:tcPr/>
-                </a:tc>
-                <a:tc>
-                  <a:txBody>
-                    <a:bodyPr/>
-                    <a:lstStyle/>
-                    <a:p>
-                      <a:r>
-                        <a:rPr sz="1300" b="0"/>
-                        <a:t>Desktop agent — on-prem/co-managed Windows half</a:t>
-                      </a:r>
-                    </a:p>
-                  </a:txBody>
-                  <a:tcPr/>
-                </a:tc>
-              </a:tr>
-              <a:tr h="502920">
-                <a:tc>
-                  <a:txBody>
-                    <a:bodyPr/>
-                    <a:lstStyle/>
-                    <a:p>
-                      <a:r>
-                        <a:rPr sz="1300" b="1"/>
-                        <a:t>Red Hat Satellite</a:t>
-                      </a:r>
-                    </a:p>
-                  </a:txBody>
-                  <a:tcPr/>
-                </a:tc>
-                <a:tc>
-                  <a:txBody>
-                    <a:bodyPr/>
-                    <a:lstStyle/>
-                    <a:p>
-                      <a:r>
-                        <a:rPr sz="1300" b="0"/>
-                        <a:t>Fleet-wide RHEL patch/content/subscription lifecycle</a:t>
-                      </a:r>
-                    </a:p>
-                  </a:txBody>
-                  <a:tcPr/>
-                </a:tc>
-                <a:tc>
-                  <a:txBody>
-                    <a:bodyPr/>
-                    <a:lstStyle/>
-                    <a:p>
-                      <a:r>
-                        <a:rPr sz="1300" b="0"/>
-                        <a:t>Linux Server agent — RHEL analogue of MECM</a:t>
-                      </a:r>
-                    </a:p>
-                  </a:txBody>
-                  <a:tcPr/>
-                </a:tc>
-              </a:tr>
-            </a:tbl>
-          </a:graphicData>
-        </a:graphic>
-      </p:graphicFrame>
-      <p:sp>
-        <p:nvSpPr>
-          <p:cNvPr id="5" name="TextBox 4"/>
+      <p:sp>
+        <p:nvSpPr>
+          <p:cNvPr id="4" name="TextBox 3"/>
           <p:cNvSpPr txBox="1"/>
           <p:nvPr/>
         </p:nvSpPr>
         <p:spPr>
           <a:xfrm>
-            <a:off x="548640" y="5623560"/>
-            <a:ext cx="11064240" cy="914400"/>
+            <a:off x="548640" y="1463040"/>
+            <a:ext cx="11064240" cy="4846320"/>
           </a:xfrm>
           <a:prstGeom prst="rect">
             <a:avLst/>
@@ -5587,18 +5414,112 @@
           <a:noFill/>
         </p:spPr>
         <p:txBody>
-          <a:bodyPr wrap="none">
+          <a:bodyPr wrap="square">
             <a:spAutoFit/>
           </a:bodyPr>
           <a:lstStyle/>
           <a:p>
-            <a:r>
-              <a:rPr sz="1200">
-                <a:solidFill>
-                  <a:srgbClr val="5B6270"/>
+            <a:pPr>
+              <a:spcAft>
+                <a:spcPts val="1200"/>
+              </a:spcAft>
+              <a:defRPr>
+                <a:latin typeface="Calibri"/>
+              </a:defRPr>
+            </a:pPr>
+            <a:r>
+              <a:rPr b="1" sz="1800">
+                <a:solidFill>
+                  <a:srgbClr val="C96343"/>
                 </a:solidFill>
               </a:rPr>
-              <a:t>Each extends one existing domain agent or Platform Ops from the architecture page — no eleventh agent, no new credential class, same tier and approval rules as everything else.</a:t>
+              <a:t>Load-bearing, not decorative:  </a:t>
+            </a:r>
+            <a:r>
+              <a:rPr sz="1800">
+                <a:solidFill>
+                  <a:srgbClr val="1C1F26"/>
+                </a:solidFill>
+              </a:rPr>
+              <a:t>"as autonomous as possible" and "only human interaction is to approve or arbitrate" are the same goal stated twice.</a:t>
+            </a:r>
+          </a:p>
+          <a:p>
+            <a:pPr>
+              <a:spcAft>
+                <a:spcPts val="1200"/>
+              </a:spcAft>
+              <a:defRPr>
+                <a:latin typeface="Calibri"/>
+              </a:defRPr>
+            </a:pPr>
+            <a:r>
+              <a:rPr b="1" sz="1800">
+                <a:solidFill>
+                  <a:srgbClr val="C96343"/>
+                </a:solidFill>
+              </a:rPr>
+              <a:t>Every domain agent  </a:t>
+            </a:r>
+            <a:r>
+              <a:rPr sz="1800">
+                <a:solidFill>
+                  <a:srgbClr val="1C1F26"/>
+                </a:solidFill>
+              </a:rPr>
+              <a:t>can read, plan, and propose without limit — none can commit a change without a plan that already passed the gate.</a:t>
+            </a:r>
+          </a:p>
+          <a:p>
+            <a:pPr>
+              <a:spcAft>
+                <a:spcPts val="1200"/>
+              </a:spcAft>
+              <a:defRPr>
+                <a:latin typeface="Calibri"/>
+              </a:defRPr>
+            </a:pPr>
+            <a:r>
+              <a:rPr b="1" sz="1800">
+                <a:solidFill>
+                  <a:srgbClr val="C96343"/>
+                </a:solidFill>
+              </a:rPr>
+              <a:t>Blast radius:  </a:t>
+            </a:r>
+            <a:r>
+              <a:rPr sz="1800">
+                <a:solidFill>
+                  <a:srgbClr val="1C1F26"/>
+                </a:solidFill>
+              </a:rPr>
+              <a:t>on infrastructure this broad (routers, firewalls, AD, hypervisors, call control), one wrong autonomous write can be a multi-day, multi-team incident.</a:t>
+            </a:r>
+          </a:p>
+          <a:p>
+            <a:pPr>
+              <a:spcAft>
+                <a:spcPts val="1200"/>
+              </a:spcAft>
+              <a:defRPr>
+                <a:latin typeface="Calibri"/>
+              </a:defRPr>
+            </a:pPr>
+            <a:r>
+              <a:rPr b="1" sz="1800">
+                <a:solidFill>
+                  <a:srgbClr val="C96343"/>
+                </a:solidFill>
+              </a:rPr>
+              <a:t>Same rule this project runs under:  </a:t>
+            </a:r>
+            <a:r>
+              <a:rPr sz="1800">
+                <a:solidFill>
+                  <a:srgbClr val="1C1F26"/>
+                </a:solidFill>
+              </a:rPr>
+              <a:t>"anything irreversible, legally gray, or strange → write it down and wait," scaled from one agent to a team managing a real enterprise.</a:t>
             </a:r>
           </a:p>
         </p:txBody>
@@ -5611,7 +5532,7 @@
 </p:sld>
 </file>
 
-<file path=ppt/slides/slide2.xml><?xml version="1.0" encoding="utf-8"?>
+<file path=ppt/slides/slide3.xml><?xml version="1.0" encoding="utf-8"?>
 <p:sld xmlns:a="http://schemas.openxmlformats.org/drawingml/2006/main" xmlns:p="http://schemas.openxmlformats.org/presentationml/2006/main" xmlns:r="http://schemas.openxmlformats.org/officeDocument/2006/relationships">
   <p:cSld>
     <p:bg>
@@ -5652,13 +5573,13 @@
           <a:lstStyle/>
           <a:p>
             <a:r>
-              <a:rPr sz="3200" b="1">
+              <a:rPr sz="3000" b="1">
                 <a:solidFill>
                   <a:srgbClr val="1C1F26"/>
                 </a:solidFill>
                 <a:latin typeface="Calibri"/>
               </a:rPr>
-              <a:t>Why a human still approves everything</a:t>
+              <a:t>High-level architecture</a:t>
             </a:r>
           </a:p>
         </p:txBody>
@@ -5706,246 +5627,16 @@
           </a:p>
         </p:txBody>
       </p:sp>
-      <p:sp>
-        <p:nvSpPr>
-          <p:cNvPr id="4" name="TextBox 3"/>
-          <p:cNvSpPr txBox="1"/>
-          <p:nvPr/>
-        </p:nvSpPr>
-        <p:spPr>
-          <a:xfrm>
-            <a:off x="548640" y="1463040"/>
-            <a:ext cx="11064240" cy="4846320"/>
-          </a:xfrm>
-          <a:prstGeom prst="rect">
-            <a:avLst/>
-          </a:prstGeom>
-          <a:noFill/>
-        </p:spPr>
-        <p:txBody>
-          <a:bodyPr wrap="square">
-            <a:spAutoFit/>
-          </a:bodyPr>
-          <a:lstStyle/>
-          <a:p>
-            <a:pPr>
-              <a:spcAft>
-                <a:spcPts val="1200"/>
-              </a:spcAft>
-              <a:defRPr>
-                <a:latin typeface="Calibri"/>
-              </a:defRPr>
-            </a:pPr>
-            <a:r>
-              <a:rPr b="1" sz="1800">
-                <a:solidFill>
-                  <a:srgbClr val="C96343"/>
-                </a:solidFill>
-              </a:rPr>
-              <a:t>Load-bearing, not decorative:  </a:t>
-            </a:r>
-            <a:r>
-              <a:rPr sz="1800">
-                <a:solidFill>
-                  <a:srgbClr val="1C1F26"/>
-                </a:solidFill>
-              </a:rPr>
-              <a:t>"as autonomous as possible" and "only human interaction is to approve or arbitrate" are the same goal stated twice.</a:t>
-            </a:r>
-          </a:p>
-          <a:p>
-            <a:pPr>
-              <a:spcAft>
-                <a:spcPts val="1200"/>
-              </a:spcAft>
-              <a:defRPr>
-                <a:latin typeface="Calibri"/>
-              </a:defRPr>
-            </a:pPr>
-            <a:r>
-              <a:rPr b="1" sz="1800">
-                <a:solidFill>
-                  <a:srgbClr val="C96343"/>
-                </a:solidFill>
-              </a:rPr>
-              <a:t>Every domain agent  </a:t>
-            </a:r>
-            <a:r>
-              <a:rPr sz="1800">
-                <a:solidFill>
-                  <a:srgbClr val="1C1F26"/>
-                </a:solidFill>
-              </a:rPr>
-              <a:t>can read, plan, and propose without limit — none can commit a change without a plan that already passed the gate.</a:t>
-            </a:r>
-          </a:p>
-          <a:p>
-            <a:pPr>
-              <a:spcAft>
-                <a:spcPts val="1200"/>
-              </a:spcAft>
-              <a:defRPr>
-                <a:latin typeface="Calibri"/>
-              </a:defRPr>
-            </a:pPr>
-            <a:r>
-              <a:rPr b="1" sz="1800">
-                <a:solidFill>
-                  <a:srgbClr val="C96343"/>
-                </a:solidFill>
-              </a:rPr>
-              <a:t>Blast radius:  </a:t>
-            </a:r>
-            <a:r>
-              <a:rPr sz="1800">
-                <a:solidFill>
-                  <a:srgbClr val="1C1F26"/>
-                </a:solidFill>
-              </a:rPr>
-              <a:t>on infrastructure this broad (routers, firewalls, AD, hypervisors, call control), one wrong autonomous write can be a multi-day, multi-team incident.</a:t>
-            </a:r>
-          </a:p>
-          <a:p>
-            <a:pPr>
-              <a:spcAft>
-                <a:spcPts val="1200"/>
-              </a:spcAft>
-              <a:defRPr>
-                <a:latin typeface="Calibri"/>
-              </a:defRPr>
-            </a:pPr>
-            <a:r>
-              <a:rPr b="1" sz="1800">
-                <a:solidFill>
-                  <a:srgbClr val="C96343"/>
-                </a:solidFill>
-              </a:rPr>
-              <a:t>Same rule this project runs under:  </a:t>
-            </a:r>
-            <a:r>
-              <a:rPr sz="1800">
-                <a:solidFill>
-                  <a:srgbClr val="1C1F26"/>
-                </a:solidFill>
-              </a:rPr>
-              <a:t>"anything irreversible, legally gray, or strange → write it down and wait," scaled from one agent to a team managing a real enterprise.</a:t>
-            </a:r>
-          </a:p>
-        </p:txBody>
-      </p:sp>
-    </p:spTree>
-  </p:cSld>
-  <p:clrMapOvr>
-    <a:masterClrMapping/>
-  </p:clrMapOvr>
-</p:sld>
-</file>
-
-<file path=ppt/slides/slide3.xml><?xml version="1.0" encoding="utf-8"?>
-<p:sld xmlns:a="http://schemas.openxmlformats.org/drawingml/2006/main" xmlns:p="http://schemas.openxmlformats.org/presentationml/2006/main" xmlns:r="http://schemas.openxmlformats.org/officeDocument/2006/relationships">
-  <p:cSld>
-    <p:bg>
-      <p:bgPr>
-        <a:solidFill>
-          <a:srgbClr val="FFFFFF"/>
-        </a:solidFill>
-        <a:effectLst/>
-      </p:bgPr>
-    </p:bg>
-    <p:spTree>
-      <p:nvGrpSpPr>
-        <p:cNvPr id="1" name=""/>
-        <p:cNvGrpSpPr/>
-        <p:nvPr/>
-      </p:nvGrpSpPr>
-      <p:grpSpPr/>
-      <p:sp>
-        <p:nvSpPr>
-          <p:cNvPr id="2" name="TextBox 1"/>
-          <p:cNvSpPr txBox="1"/>
-          <p:nvPr/>
-        </p:nvSpPr>
-        <p:spPr>
-          <a:xfrm>
-            <a:off x="548640" y="365760"/>
-            <a:ext cx="11064240" cy="914400"/>
-          </a:xfrm>
-          <a:prstGeom prst="rect">
-            <a:avLst/>
-          </a:prstGeom>
-          <a:noFill/>
-        </p:spPr>
-        <p:txBody>
-          <a:bodyPr wrap="square">
-            <a:spAutoFit/>
-          </a:bodyPr>
-          <a:lstStyle/>
-          <a:p>
-            <a:r>
-              <a:rPr sz="3000" b="1">
-                <a:solidFill>
-                  <a:srgbClr val="1C1F26"/>
-                </a:solidFill>
-                <a:latin typeface="Calibri"/>
-              </a:rPr>
-              <a:t>High-level architecture</a:t>
-            </a:r>
-          </a:p>
-        </p:txBody>
-      </p:sp>
-      <p:sp>
-        <p:nvSpPr>
-          <p:cNvPr id="3" name="Rectangle 2"/>
-          <p:cNvSpPr/>
-          <p:nvPr/>
-        </p:nvSpPr>
-        <p:spPr>
-          <a:xfrm>
-            <a:off x="548640" y="1143000"/>
-            <a:ext cx="2743200" cy="27940"/>
-          </a:xfrm>
-          <a:prstGeom prst="rect">
-            <a:avLst/>
-          </a:prstGeom>
-          <a:solidFill>
-            <a:srgbClr val="C96343"/>
-          </a:solidFill>
-          <a:ln>
-            <a:noFill/>
-          </a:ln>
-        </p:spPr>
-        <p:style>
-          <a:lnRef idx="1">
-            <a:schemeClr val="accent1"/>
-          </a:lnRef>
-          <a:fillRef idx="3">
-            <a:schemeClr val="accent1"/>
-          </a:fillRef>
-          <a:effectRef idx="2">
-            <a:schemeClr val="accent1"/>
-          </a:effectRef>
-          <a:fontRef idx="minor">
-            <a:schemeClr val="lt1"/>
-          </a:fontRef>
-        </p:style>
-        <p:txBody>
-          <a:bodyPr rtlCol="0" anchor="ctr"/>
-          <a:lstStyle/>
-          <a:p>
-            <a:pPr algn="ctr"/>
-          </a:p>
-        </p:txBody>
-      </p:sp>
       <p:pic>
         <p:nvPicPr>
-          <p:cNvPr id="4" name="Picture 3" descr="arch_diagram_print.png"/>
+          <p:cNvPr id="4" name="Picture 3" descr="arch_diagram.png"/>
           <p:cNvPicPr>
             <a:picLocks noChangeAspect="1"/>
           </p:cNvPicPr>
           <p:nvPr/>
         </p:nvPicPr>
         <p:blipFill>
-          <a:blip r:embed="rId3"/>
+          <a:blip r:embed="rId4"/>
           <a:stretch>
             <a:fillRect/>
           </a:stretch>
@@ -7539,6 +7230,542 @@
 <file path=ppt/slides/slide6.xml><?xml version="1.0" encoding="utf-8"?>
 <p:sld xmlns:a="http://schemas.openxmlformats.org/drawingml/2006/main" xmlns:p="http://schemas.openxmlformats.org/presentationml/2006/main" xmlns:r="http://schemas.openxmlformats.org/officeDocument/2006/relationships">
   <p:cSld>
+    <p:spTree>
+      <p:nvGrpSpPr>
+        <p:cNvPr id="1" name=""/>
+        <p:cNvGrpSpPr/>
+        <p:nvPr/>
+      </p:nvGrpSpPr>
+      <p:grpSpPr/>
+      <p:sp>
+        <p:nvSpPr>
+          <p:cNvPr id="2" name="TextBox 1"/>
+          <p:cNvSpPr txBox="1"/>
+          <p:nvPr/>
+        </p:nvSpPr>
+        <p:spPr>
+          <a:xfrm>
+            <a:off x="548640" y="365760"/>
+            <a:ext cx="11064240" cy="914400"/>
+          </a:xfrm>
+          <a:prstGeom prst="rect">
+            <a:avLst/>
+          </a:prstGeom>
+          <a:noFill/>
+        </p:spPr>
+        <p:txBody>
+          <a:bodyPr wrap="none">
+            <a:spAutoFit/>
+          </a:bodyPr>
+          <a:lstStyle/>
+          <a:p>
+            <a:r>
+              <a:rPr sz="2500" b="1">
+                <a:solidFill>
+                  <a:srgbClr val="1C1F26"/>
+                </a:solidFill>
+              </a:rPr>
+              <a:t>Supporting systems (continued) — network, security, cloud &amp; endpoint consoles</a:t>
+            </a:r>
+          </a:p>
+        </p:txBody>
+      </p:sp>
+      <p:sp>
+        <p:nvSpPr>
+          <p:cNvPr id="3" name="Rectangle 2"/>
+          <p:cNvSpPr/>
+          <p:nvPr/>
+        </p:nvSpPr>
+        <p:spPr>
+          <a:xfrm>
+            <a:off x="548640" y="1143000"/>
+            <a:ext cx="2743200" cy="27940"/>
+          </a:xfrm>
+          <a:prstGeom prst="rect">
+            <a:avLst/>
+          </a:prstGeom>
+          <a:solidFill>
+            <a:srgbClr val="C96343"/>
+          </a:solidFill>
+          <a:ln>
+            <a:noFill/>
+          </a:ln>
+        </p:spPr>
+        <p:style>
+          <a:lnRef idx="1">
+            <a:schemeClr val="accent1"/>
+          </a:lnRef>
+          <a:fillRef idx="3">
+            <a:schemeClr val="accent1"/>
+          </a:fillRef>
+          <a:effectRef idx="2">
+            <a:schemeClr val="accent1"/>
+          </a:effectRef>
+          <a:fontRef idx="minor">
+            <a:schemeClr val="lt1"/>
+          </a:fontRef>
+        </p:style>
+        <p:txBody>
+          <a:bodyPr rtlCol="0" anchor="ctr"/>
+          <a:lstStyle/>
+          <a:p>
+            <a:pPr algn="ctr"/>
+          </a:p>
+        </p:txBody>
+      </p:sp>
+      <p:graphicFrame>
+        <p:nvGraphicFramePr>
+          <p:cNvPr id="4" name="Table 3"/>
+          <p:cNvGraphicFramePr>
+            <a:graphicFrameLocks noGrp="1"/>
+          </p:cNvGraphicFramePr>
+          <p:nvPr/>
+        </p:nvGraphicFramePr>
+        <p:xfrm>
+          <a:off x="548640" y="1417320"/>
+          <a:ext cx="11064240" cy="4206240"/>
+        </p:xfrm>
+        <a:graphic>
+          <a:graphicData uri="http://schemas.openxmlformats.org/drawingml/2006/table">
+            <a:tbl>
+              <a:tblPr firstRow="1" bandRow="1">
+                <a:tableStyleId>{5C22544A-7EE6-4342-B048-85BDC9FD1C3A}</a:tableStyleId>
+                <a:tableStyleId>{5C22544A-7EE6-4342-B048-85BDC9FD1C3A}</a:tableStyleId>
+              </a:tblPr>
+              <a:tblGrid>
+                <a:gridCol w="2011680"/>
+                <a:gridCol w="5120640"/>
+                <a:gridCol w="3931920"/>
+              </a:tblGrid>
+              <a:tr h="467360">
+                <a:tc>
+                  <a:txBody>
+                    <a:bodyPr/>
+                    <a:lstStyle/>
+                    <a:p>
+                      <a:r>
+                        <a:rPr sz="1300" b="1">
+                          <a:solidFill>
+                            <a:srgbClr val="FFFFFF"/>
+                          </a:solidFill>
+                        </a:rPr>
+                        <a:t>System</a:t>
+                      </a:r>
+                    </a:p>
+                  </a:txBody>
+                  <a:tcPr/>
+                </a:tc>
+                <a:tc>
+                  <a:txBody>
+                    <a:bodyPr/>
+                    <a:lstStyle/>
+                    <a:p>
+                      <a:r>
+                        <a:rPr sz="1300" b="1">
+                          <a:solidFill>
+                            <a:srgbClr val="FFFFFF"/>
+                          </a:solidFill>
+                        </a:rPr>
+                        <a:t>Role</a:t>
+                      </a:r>
+                    </a:p>
+                  </a:txBody>
+                  <a:tcPr/>
+                </a:tc>
+                <a:tc>
+                  <a:txBody>
+                    <a:bodyPr/>
+                    <a:lstStyle/>
+                    <a:p>
+                      <a:r>
+                        <a:rPr sz="1300" b="1">
+                          <a:solidFill>
+                            <a:srgbClr val="FFFFFF"/>
+                          </a:solidFill>
+                        </a:rPr>
+                        <a:t>Feeds / used by</a:t>
+                      </a:r>
+                    </a:p>
+                  </a:txBody>
+                  <a:tcPr/>
+                </a:tc>
+              </a:tr>
+              <a:tr h="467360">
+                <a:tc>
+                  <a:txBody>
+                    <a:bodyPr/>
+                    <a:lstStyle/>
+                    <a:p>
+                      <a:r>
+                        <a:rPr sz="1300" b="1"/>
+                        <a:t>Cisco Firepower Mgmt. Center</a:t>
+                      </a:r>
+                    </a:p>
+                  </a:txBody>
+                  <a:tcPr/>
+                </a:tc>
+                <a:tc>
+                  <a:txBody>
+                    <a:bodyPr/>
+                    <a:lstStyle/>
+                    <a:p>
+                      <a:r>
+                        <a:rPr sz="1300" b="0"/>
+                        <a:t>Centralized policy for Cisco FTD/ASA firewalls</a:t>
+                      </a:r>
+                    </a:p>
+                  </a:txBody>
+                  <a:tcPr/>
+                </a:tc>
+                <a:tc>
+                  <a:txBody>
+                    <a:bodyPr/>
+                    <a:lstStyle/>
+                    <a:p>
+                      <a:r>
+                        <a:rPr sz="1300" b="0"/>
+                        <a:t>Firewall agent — fleet-wide policy push/rollback</a:t>
+                      </a:r>
+                    </a:p>
+                  </a:txBody>
+                  <a:tcPr/>
+                </a:tc>
+              </a:tr>
+              <a:tr h="467360">
+                <a:tc>
+                  <a:txBody>
+                    <a:bodyPr/>
+                    <a:lstStyle/>
+                    <a:p>
+                      <a:r>
+                        <a:rPr sz="1300" b="1"/>
+                        <a:t>Cisco Catalyst Center</a:t>
+                      </a:r>
+                    </a:p>
+                  </a:txBody>
+                  <a:tcPr/>
+                </a:tc>
+                <a:tc>
+                  <a:txBody>
+                    <a:bodyPr/>
+                    <a:lstStyle/>
+                    <a:p>
+                      <a:r>
+                        <a:rPr sz="1300" b="0"/>
+                        <a:t>SD-Access campus/branch automation &amp; assurance</a:t>
+                      </a:r>
+                    </a:p>
+                  </a:txBody>
+                  <a:tcPr/>
+                </a:tc>
+                <a:tc>
+                  <a:txBody>
+                    <a:bodyPr/>
+                    <a:lstStyle/>
+                    <a:p>
+                      <a:r>
+                        <a:rPr sz="1300" b="0"/>
+                        <a:t>Network agent — campus/branch counterpart to Nexus Dashboard</a:t>
+                      </a:r>
+                    </a:p>
+                  </a:txBody>
+                  <a:tcPr/>
+                </a:tc>
+              </a:tr>
+              <a:tr h="467360">
+                <a:tc>
+                  <a:txBody>
+                    <a:bodyPr/>
+                    <a:lstStyle/>
+                    <a:p>
+                      <a:r>
+                        <a:rPr sz="1300" b="1"/>
+                        <a:t>VMware Aria</a:t>
+                      </a:r>
+                    </a:p>
+                  </a:txBody>
+                  <a:tcPr/>
+                </a:tc>
+                <a:tc>
+                  <a:txBody>
+                    <a:bodyPr/>
+                    <a:lstStyle/>
+                    <a:p>
+                      <a:r>
+                        <a:rPr sz="1300" b="0"/>
+                        <a:t>Capacity analytics (Operations) &amp; automation (formerly vRealize)</a:t>
+                      </a:r>
+                    </a:p>
+                  </a:txBody>
+                  <a:tcPr/>
+                </a:tc>
+                <a:tc>
+                  <a:txBody>
+                    <a:bodyPr/>
+                    <a:lstStyle/>
+                    <a:p>
+                      <a:r>
+                        <a:rPr sz="1300" b="0"/>
+                        <a:t>VMware agent — trend-based capacity planning</a:t>
+                      </a:r>
+                    </a:p>
+                  </a:txBody>
+                  <a:tcPr/>
+                </a:tc>
+              </a:tr>
+              <a:tr h="467360">
+                <a:tc>
+                  <a:txBody>
+                    <a:bodyPr/>
+                    <a:lstStyle/>
+                    <a:p>
+                      <a:r>
+                        <a:rPr sz="1300" b="1"/>
+                        <a:t>Microsoft SCOM</a:t>
+                      </a:r>
+                    </a:p>
+                  </a:txBody>
+                  <a:tcPr/>
+                </a:tc>
+                <a:tc>
+                  <a:txBody>
+                    <a:bodyPr/>
+                    <a:lstStyle/>
+                    <a:p>
+                      <a:r>
+                        <a:rPr sz="1300" b="0"/>
+                        <a:t>On-prem infrastructure/app monitoring via management packs</a:t>
+                      </a:r>
+                    </a:p>
+                  </a:txBody>
+                  <a:tcPr/>
+                </a:tc>
+                <a:tc>
+                  <a:txBody>
+                    <a:bodyPr/>
+                    <a:lstStyle/>
+                    <a:p>
+                      <a:r>
+                        <a:rPr sz="1300" b="0"/>
+                        <a:t>Platform Ops, alongside Zabbix</a:t>
+                      </a:r>
+                    </a:p>
+                  </a:txBody>
+                  <a:tcPr/>
+                </a:tc>
+              </a:tr>
+              <a:tr h="467360">
+                <a:tc>
+                  <a:txBody>
+                    <a:bodyPr/>
+                    <a:lstStyle/>
+                    <a:p>
+                      <a:r>
+                        <a:rPr sz="1300" b="1"/>
+                        <a:t>Azure Monitor</a:t>
+                      </a:r>
+                    </a:p>
+                  </a:txBody>
+                  <a:tcPr/>
+                </a:tc>
+                <a:tc>
+                  <a:txBody>
+                    <a:bodyPr/>
+                    <a:lstStyle/>
+                    <a:p>
+                      <a:r>
+                        <a:rPr sz="1300" b="0"/>
+                        <a:t>Cloud-native metrics, logs &amp; alerting for Azure/Arc resources</a:t>
+                      </a:r>
+                    </a:p>
+                  </a:txBody>
+                  <a:tcPr/>
+                </a:tc>
+                <a:tc>
+                  <a:txBody>
+                    <a:bodyPr/>
+                    <a:lstStyle/>
+                    <a:p>
+                      <a:r>
+                        <a:rPr sz="1300" b="0"/>
+                        <a:t>Platform Ops — cloud counterpart to SCOM/Zabbix</a:t>
+                      </a:r>
+                    </a:p>
+                  </a:txBody>
+                  <a:tcPr/>
+                </a:tc>
+              </a:tr>
+              <a:tr h="467360">
+                <a:tc>
+                  <a:txBody>
+                    <a:bodyPr/>
+                    <a:lstStyle/>
+                    <a:p>
+                      <a:r>
+                        <a:rPr sz="1300" b="1"/>
+                        <a:t>Microsoft MECM</a:t>
+                      </a:r>
+                    </a:p>
+                  </a:txBody>
+                  <a:tcPr/>
+                </a:tc>
+                <a:tc>
+                  <a:txBody>
+                    <a:bodyPr/>
+                    <a:lstStyle/>
+                    <a:p>
+                      <a:r>
+                        <a:rPr sz="1300" b="0"/>
+                        <a:t>On-prem endpoint lifecycle mgmt (formerly SCCM)</a:t>
+                      </a:r>
+                    </a:p>
+                  </a:txBody>
+                  <a:tcPr/>
+                </a:tc>
+                <a:tc>
+                  <a:txBody>
+                    <a:bodyPr/>
+                    <a:lstStyle/>
+                    <a:p>
+                      <a:r>
+                        <a:rPr sz="1300" b="0"/>
+                        <a:t>Desktop agent — on-prem/co-managed Windows half</a:t>
+                      </a:r>
+                    </a:p>
+                  </a:txBody>
+                  <a:tcPr/>
+                </a:tc>
+              </a:tr>
+              <a:tr h="467360">
+                <a:tc>
+                  <a:txBody>
+                    <a:bodyPr/>
+                    <a:lstStyle/>
+                    <a:p>
+                      <a:r>
+                        <a:rPr sz="1300" b="1"/>
+                        <a:t>Red Hat Satellite</a:t>
+                      </a:r>
+                    </a:p>
+                  </a:txBody>
+                  <a:tcPr/>
+                </a:tc>
+                <a:tc>
+                  <a:txBody>
+                    <a:bodyPr/>
+                    <a:lstStyle/>
+                    <a:p>
+                      <a:r>
+                        <a:rPr sz="1300" b="0"/>
+                        <a:t>Fleet-wide RHEL patch/content/subscription lifecycle</a:t>
+                      </a:r>
+                    </a:p>
+                  </a:txBody>
+                  <a:tcPr/>
+                </a:tc>
+                <a:tc>
+                  <a:txBody>
+                    <a:bodyPr/>
+                    <a:lstStyle/>
+                    <a:p>
+                      <a:r>
+                        <a:rPr sz="1300" b="0"/>
+                        <a:t>Linux Server agent — RHEL analogue of MECM</a:t>
+                      </a:r>
+                    </a:p>
+                  </a:txBody>
+                  <a:tcPr/>
+                </a:tc>
+              </a:tr>
+              <a:tr h="467360">
+                <a:tc>
+                  <a:txBody>
+                    <a:bodyPr/>
+                    <a:lstStyle/>
+                    <a:p>
+                      <a:r>
+                        <a:rPr sz="1300" b="1"/>
+                        <a:t>APC power management</a:t>
+                      </a:r>
+                    </a:p>
+                  </a:txBody>
+                  <a:tcPr/>
+                </a:tc>
+                <a:tc>
+                  <a:txBody>
+                    <a:bodyPr/>
+                    <a:lstStyle/>
+                    <a:p>
+                      <a:r>
+                        <a:rPr sz="1300" b="0"/>
+                        <a:t>UPS/PDU telemetry &amp; control via Network Management Cards and StruxureWare/EcoStruxure IT</a:t>
+                      </a:r>
+                    </a:p>
+                  </a:txBody>
+                  <a:tcPr/>
+                </a:tc>
+                <a:tc>
+                  <a:txBody>
+                    <a:bodyPr/>
+                    <a:lstStyle/>
+                    <a:p>
+                      <a:r>
+                        <a:rPr sz="1300" b="0"/>
+                        <a:t>Platform Ops — facilities-layer health source; triggers orderly power-loss shutdown sequence</a:t>
+                      </a:r>
+                    </a:p>
+                  </a:txBody>
+                  <a:tcPr/>
+                </a:tc>
+              </a:tr>
+            </a:tbl>
+          </a:graphicData>
+        </a:graphic>
+      </p:graphicFrame>
+      <p:sp>
+        <p:nvSpPr>
+          <p:cNvPr id="5" name="TextBox 4"/>
+          <p:cNvSpPr txBox="1"/>
+          <p:nvPr/>
+        </p:nvSpPr>
+        <p:spPr>
+          <a:xfrm>
+            <a:off x="548640" y="5623560"/>
+            <a:ext cx="11064240" cy="914400"/>
+          </a:xfrm>
+          <a:prstGeom prst="rect">
+            <a:avLst/>
+          </a:prstGeom>
+          <a:noFill/>
+        </p:spPr>
+        <p:txBody>
+          <a:bodyPr wrap="none">
+            <a:spAutoFit/>
+          </a:bodyPr>
+          <a:lstStyle/>
+          <a:p>
+            <a:r>
+              <a:rPr sz="1200">
+                <a:solidFill>
+                  <a:srgbClr val="5B6270"/>
+                </a:solidFill>
+              </a:rPr>
+              <a:t>Each extends one existing domain agent or Platform Ops from the architecture page — no eleventh agent, no new credential class, same tier and approval rules as everything else.</a:t>
+            </a:r>
+          </a:p>
+        </p:txBody>
+      </p:sp>
+    </p:spTree>
+  </p:cSld>
+  <p:clrMapOvr>
+    <a:masterClrMapping/>
+  </p:clrMapOvr>
+</p:sld>
+</file>
+
+<file path=ppt/slides/slide7.xml><?xml version="1.0" encoding="utf-8"?>
+<p:sld xmlns:a="http://schemas.openxmlformats.org/drawingml/2006/main" xmlns:p="http://schemas.openxmlformats.org/presentationml/2006/main" xmlns:r="http://schemas.openxmlformats.org/officeDocument/2006/relationships">
+  <p:cSld>
     <p:bg>
       <p:bgPr>
         <a:solidFill>
@@ -7663,7 +7890,7 @@
 </p:sld>
 </file>
 
-<file path=ppt/slides/slide7.xml><?xml version="1.0" encoding="utf-8"?>
+<file path=ppt/slides/slide8.xml><?xml version="1.0" encoding="utf-8"?>
 <p:sld xmlns:a="http://schemas.openxmlformats.org/drawingml/2006/main" xmlns:p="http://schemas.openxmlformats.org/presentationml/2006/main" xmlns:r="http://schemas.openxmlformats.org/officeDocument/2006/relationships">
   <p:cSld>
     <p:bg>
@@ -8131,7 +8358,7 @@
 </p:sld>
 </file>
 
-<file path=ppt/slides/slide8.xml><?xml version="1.0" encoding="utf-8"?>
+<file path=ppt/slides/slide9.xml><?xml version="1.0" encoding="utf-8"?>
 <p:sld xmlns:a="http://schemas.openxmlformats.org/drawingml/2006/main" xmlns:p="http://schemas.openxmlformats.org/presentationml/2006/main" xmlns:r="http://schemas.openxmlformats.org/officeDocument/2006/relationships">
   <p:cSld>
     <p:bg>
@@ -8327,133 +8554,6 @@
           </a:p>
         </p:txBody>
       </p:sp>
-    </p:spTree>
-  </p:cSld>
-  <p:clrMapOvr>
-    <a:masterClrMapping/>
-  </p:clrMapOvr>
-</p:sld>
-</file>
-
-<file path=ppt/slides/slide9.xml><?xml version="1.0" encoding="utf-8"?>
-<p:sld xmlns:a="http://schemas.openxmlformats.org/drawingml/2006/main" xmlns:p="http://schemas.openxmlformats.org/presentationml/2006/main" xmlns:r="http://schemas.openxmlformats.org/officeDocument/2006/relationships">
-  <p:cSld>
-    <p:bg>
-      <p:bgPr>
-        <a:solidFill>
-          <a:srgbClr val="FFFFFF"/>
-        </a:solidFill>
-        <a:effectLst/>
-      </p:bgPr>
-    </p:bg>
-    <p:spTree>
-      <p:nvGrpSpPr>
-        <p:cNvPr id="1" name=""/>
-        <p:cNvGrpSpPr/>
-        <p:nvPr/>
-      </p:nvGrpSpPr>
-      <p:grpSpPr/>
-      <p:sp>
-        <p:nvSpPr>
-          <p:cNvPr id="2" name="TextBox 1"/>
-          <p:cNvSpPr txBox="1"/>
-          <p:nvPr/>
-        </p:nvSpPr>
-        <p:spPr>
-          <a:xfrm>
-            <a:off x="548640" y="365760"/>
-            <a:ext cx="11064240" cy="914400"/>
-          </a:xfrm>
-          <a:prstGeom prst="rect">
-            <a:avLst/>
-          </a:prstGeom>
-          <a:noFill/>
-        </p:spPr>
-        <p:txBody>
-          <a:bodyPr wrap="square">
-            <a:spAutoFit/>
-          </a:bodyPr>
-          <a:lstStyle/>
-          <a:p>
-            <a:r>
-              <a:rPr sz="3000" b="1">
-                <a:solidFill>
-                  <a:srgbClr val="1C1F26"/>
-                </a:solidFill>
-                <a:latin typeface="Calibri"/>
-              </a:rPr>
-              <a:t>Phased rollout</a:t>
-            </a:r>
-          </a:p>
-        </p:txBody>
-      </p:sp>
-      <p:sp>
-        <p:nvSpPr>
-          <p:cNvPr id="3" name="Rectangle 2"/>
-          <p:cNvSpPr/>
-          <p:nvPr/>
-        </p:nvSpPr>
-        <p:spPr>
-          <a:xfrm>
-            <a:off x="548640" y="1143000"/>
-            <a:ext cx="2743200" cy="27940"/>
-          </a:xfrm>
-          <a:prstGeom prst="rect">
-            <a:avLst/>
-          </a:prstGeom>
-          <a:solidFill>
-            <a:srgbClr val="C96343"/>
-          </a:solidFill>
-          <a:ln>
-            <a:noFill/>
-          </a:ln>
-        </p:spPr>
-        <p:style>
-          <a:lnRef idx="1">
-            <a:schemeClr val="accent1"/>
-          </a:lnRef>
-          <a:fillRef idx="3">
-            <a:schemeClr val="accent1"/>
-          </a:fillRef>
-          <a:effectRef idx="2">
-            <a:schemeClr val="accent1"/>
-          </a:effectRef>
-          <a:fontRef idx="minor">
-            <a:schemeClr val="lt1"/>
-          </a:fontRef>
-        </p:style>
-        <p:txBody>
-          <a:bodyPr rtlCol="0" anchor="ctr"/>
-          <a:lstStyle/>
-          <a:p>
-            <a:pPr algn="ctr"/>
-          </a:p>
-        </p:txBody>
-      </p:sp>
-      <p:pic>
-        <p:nvPicPr>
-          <p:cNvPr id="4" name="Picture 3" descr="phases.png"/>
-          <p:cNvPicPr>
-            <a:picLocks noChangeAspect="1"/>
-          </p:cNvPicPr>
-          <p:nvPr/>
-        </p:nvPicPr>
-        <p:blipFill>
-          <a:blip r:embed="rId2"/>
-          <a:stretch>
-            <a:fillRect/>
-          </a:stretch>
-        </p:blipFill>
-        <p:spPr>
-          <a:xfrm>
-            <a:off x="472287" y="2377440"/>
-            <a:ext cx="11247120" cy="1624584"/>
-          </a:xfrm>
-          <a:prstGeom prst="rect">
-            <a:avLst/>
-          </a:prstGeom>
-        </p:spPr>
-      </p:pic>
     </p:spTree>
   </p:cSld>
   <p:clrMapOvr>

</xml_diff>

<commit_message>
Add CyberArk, CrowdStrike, Splunk, storage & backup to the service-desk architecture
Sevens new supporting systems (CyberArk PAM, CrowdStrike Falcon EDR,
Splunk SIEM, NetApp ONTAP + Dell storage, Dell PowerSwitch top-of-rack,
and a backup/recovery platform) threaded through the architecture page,
integration guide, operations SOP, all three PDFs, and the pptx per
josh's Telegram request. Supporting-system count 15 -> 22.

Co-Authored-By: Claude Sonnet 5 <noreply@anthropic.com>
</commit_message>
<xml_diff>
--- a/website/service-desk-architecture.pptx
+++ b/website/service-desk-architecture.pptx
@@ -11,6 +11,7 @@
     <p:sldId id="259" r:id="rId10"/>
     <p:sldId id="260" r:id="rId11"/>
     <p:sldId id="272" r:id="rId23"/>
+    <p:sldId id="273" r:id="rId24"/>
     <p:sldId id="261" r:id="rId12"/>
     <p:sldId id="262" r:id="rId13"/>
     <p:sldId id="263" r:id="rId14"/>
@@ -3583,7 +3584,7 @@
                   </a:tcPr>
                 </a:tc>
               </a:tr>
-              <a:tr h="502920">
+              <a:tr h="352044">
                 <a:tc>
                   <a:txBody>
                     <a:bodyPr/>
@@ -3642,7 +3643,7 @@
                   </a:tcPr>
                 </a:tc>
               </a:tr>
-              <a:tr h="502920">
+              <a:tr h="352044">
                 <a:tc>
                   <a:txBody>
                     <a:bodyPr/>
@@ -3701,7 +3702,7 @@
                   </a:tcPr>
                 </a:tc>
               </a:tr>
-              <a:tr h="502920">
+              <a:tr h="352044">
                 <a:tc>
                   <a:txBody>
                     <a:bodyPr/>
@@ -3760,7 +3761,7 @@
                   </a:tcPr>
                 </a:tc>
               </a:tr>
-              <a:tr h="502920">
+              <a:tr h="352044">
                 <a:tc>
                   <a:txBody>
                     <a:bodyPr/>
@@ -3819,7 +3820,7 @@
                   </a:tcPr>
                 </a:tc>
               </a:tr>
-              <a:tr h="502920">
+              <a:tr h="352044">
                 <a:tc>
                   <a:txBody>
                     <a:bodyPr/>
@@ -3878,7 +3879,7 @@
                   </a:tcPr>
                 </a:tc>
               </a:tr>
-              <a:tr h="502920">
+              <a:tr h="352044">
                 <a:tc>
                   <a:txBody>
                     <a:bodyPr/>
@@ -3927,6 +3928,242 @@
                           <a:latin typeface="Calibri"/>
                         </a:rPr>
                         <a:t>Tier 1</a:t>
+                      </a:r>
+                    </a:p>
+                  </a:txBody>
+                  <a:tcPr marL="73152" marR="73152" marT="36576" marB="36576" anchor="ctr">
+                    <a:solidFill>
+                      <a:srgbClr val="FFFFFF"/>
+                    </a:solidFill>
+                  </a:tcPr>
+                </a:tc>
+              </a:tr>
+              <a:tr h="352044">
+                <a:tc>
+                  <a:txBody>
+                    <a:bodyPr/>
+                    <a:lstStyle/>
+                    <a:p>
+                      <a:r>
+                        <a:rPr sz="1300">
+                          <a:latin typeface="Calibri"/>
+                        </a:rPr>
+                        <a:t>Backup job failed, or a restore-test did not pass</a:t>
+                      </a:r>
+                    </a:p>
+                  </a:txBody>
+                  <a:tcPr marL="73152" marR="73152" marT="36576" marB="36576" anchor="ctr">
+                    <a:solidFill>
+                      <a:srgbClr val="FFFFFF"/>
+                    </a:solidFill>
+                  </a:tcPr>
+                </a:tc>
+                <a:tc>
+                  <a:txBody>
+                    <a:bodyPr/>
+                    <a:lstStyle/>
+                    <a:p>
+                      <a:r>
+                        <a:rPr sz="1300">
+                          <a:latin typeface="Calibri"/>
+                        </a:rPr>
+                        <a:t>Re-queue once; on a second failure open an Incident and page — never deletes a backup or shortens retention (deny-list)</a:t>
+                      </a:r>
+                    </a:p>
+                  </a:txBody>
+                  <a:tcPr marL="73152" marR="73152" marT="36576" marB="36576" anchor="ctr">
+                    <a:solidFill>
+                      <a:srgbClr val="FFFFFF"/>
+                    </a:solidFill>
+                  </a:tcPr>
+                </a:tc>
+                <a:tc>
+                  <a:txBody>
+                    <a:bodyPr/>
+                    <a:lstStyle/>
+                    <a:p>
+                      <a:r>
+                        <a:rPr sz="1300">
+                          <a:latin typeface="Calibri"/>
+                        </a:rPr>
+                        <a:t>Tier 1</a:t>
+                      </a:r>
+                    </a:p>
+                  </a:txBody>
+                  <a:tcPr marL="73152" marR="73152" marT="36576" marB="36576" anchor="ctr">
+                    <a:solidFill>
+                      <a:srgbClr val="FFFFFF"/>
+                    </a:solidFill>
+                  </a:tcPr>
+                </a:tc>
+              </a:tr>
+              <a:tr h="352044">
+                <a:tc>
+                  <a:txBody>
+                    <a:bodyPr/>
+                    <a:lstStyle/>
+                    <a:p>
+                      <a:r>
+                        <a:rPr sz="1300">
+                          <a:latin typeface="Calibri"/>
+                        </a:rPr>
+                        <a:t>CrowdStrike sensor stopped reporting on a host</a:t>
+                      </a:r>
+                    </a:p>
+                  </a:txBody>
+                  <a:tcPr marL="73152" marR="73152" marT="36576" marB="36576" anchor="ctr">
+                    <a:solidFill>
+                      <a:srgbClr val="FFFFFF"/>
+                    </a:solidFill>
+                  </a:tcPr>
+                </a:tc>
+                <a:tc>
+                  <a:txBody>
+                    <a:bodyPr/>
+                    <a:lstStyle/>
+                    <a:p>
+                      <a:r>
+                        <a:rPr sz="1300">
+                          <a:latin typeface="Calibri"/>
+                        </a:rPr>
+                        <a:t>Flag the coverage gap read-only; re-deploy via the host's own domain agent on the normal Change path</a:t>
+                      </a:r>
+                    </a:p>
+                  </a:txBody>
+                  <a:tcPr marL="73152" marR="73152" marT="36576" marB="36576" anchor="ctr">
+                    <a:solidFill>
+                      <a:srgbClr val="FFFFFF"/>
+                    </a:solidFill>
+                  </a:tcPr>
+                </a:tc>
+                <a:tc>
+                  <a:txBody>
+                    <a:bodyPr/>
+                    <a:lstStyle/>
+                    <a:p>
+                      <a:r>
+                        <a:rPr sz="1300">
+                          <a:latin typeface="Calibri"/>
+                        </a:rPr>
+                        <a:t>Tier 0 / 2</a:t>
+                      </a:r>
+                    </a:p>
+                  </a:txBody>
+                  <a:tcPr marL="73152" marR="73152" marT="36576" marB="36576" anchor="ctr">
+                    <a:solidFill>
+                      <a:srgbClr val="FFFFFF"/>
+                    </a:solidFill>
+                  </a:tcPr>
+                </a:tc>
+              </a:tr>
+              <a:tr h="352044">
+                <a:tc>
+                  <a:txBody>
+                    <a:bodyPr/>
+                    <a:lstStyle/>
+                    <a:p>
+                      <a:r>
+                        <a:rPr sz="1300">
+                          <a:latin typeface="Calibri"/>
+                        </a:rPr>
+                        <a:t>CyberArk lease failed to revoke after its task</a:t>
+                      </a:r>
+                    </a:p>
+                  </a:txBody>
+                  <a:tcPr marL="73152" marR="73152" marT="36576" marB="36576" anchor="ctr">
+                    <a:solidFill>
+                      <a:srgbClr val="FFFFFF"/>
+                    </a:solidFill>
+                  </a:tcPr>
+                </a:tc>
+                <a:tc>
+                  <a:txBody>
+                    <a:bodyPr/>
+                    <a:lstStyle/>
+                    <a:p>
+                      <a:r>
+                        <a:rPr sz="1300">
+                          <a:latin typeface="Calibri"/>
+                        </a:rPr>
+                        <a:t>Force-revoke and alert — a lease that outlives its task is a security event, not routine cleanup</a:t>
+                      </a:r>
+                    </a:p>
+                  </a:txBody>
+                  <a:tcPr marL="73152" marR="73152" marT="36576" marB="36576" anchor="ctr">
+                    <a:solidFill>
+                      <a:srgbClr val="FFFFFF"/>
+                    </a:solidFill>
+                  </a:tcPr>
+                </a:tc>
+                <a:tc>
+                  <a:txBody>
+                    <a:bodyPr/>
+                    <a:lstStyle/>
+                    <a:p>
+                      <a:r>
+                        <a:rPr sz="1300">
+                          <a:latin typeface="Calibri"/>
+                        </a:rPr>
+                        <a:t>Tier 1</a:t>
+                      </a:r>
+                    </a:p>
+                  </a:txBody>
+                  <a:tcPr marL="73152" marR="73152" marT="36576" marB="36576" anchor="ctr">
+                    <a:solidFill>
+                      <a:srgbClr val="FFFFFF"/>
+                    </a:solidFill>
+                  </a:tcPr>
+                </a:tc>
+              </a:tr>
+              <a:tr h="352044">
+                <a:tc>
+                  <a:txBody>
+                    <a:bodyPr/>
+                    <a:lstStyle/>
+                    <a:p>
+                      <a:r>
+                        <a:rPr sz="1300">
+                          <a:latin typeface="Calibri"/>
+                        </a:rPr>
+                        <a:t>Storage volume (NetApp/Dell) over capacity threshold</a:t>
+                      </a:r>
+                    </a:p>
+                  </a:txBody>
+                  <a:tcPr marL="73152" marR="73152" marT="36576" marB="36576" anchor="ctr">
+                    <a:solidFill>
+                      <a:srgbClr val="FFFFFF"/>
+                    </a:solidFill>
+                  </a:tcPr>
+                </a:tc>
+                <a:tc>
+                  <a:txBody>
+                    <a:bodyPr/>
+                    <a:lstStyle/>
+                    <a:p>
+                      <a:r>
+                        <a:rPr sz="1300">
+                          <a:latin typeface="Calibri"/>
+                        </a:rPr>
+                        <a:t>Alert and open a capacity Incident; expansion is a Tier 2 Change via the owning agent, never an auto-grow</a:t>
+                      </a:r>
+                    </a:p>
+                  </a:txBody>
+                  <a:tcPr marL="73152" marR="73152" marT="36576" marB="36576" anchor="ctr">
+                    <a:solidFill>
+                      <a:srgbClr val="FFFFFF"/>
+                    </a:solidFill>
+                  </a:tcPr>
+                </a:tc>
+                <a:tc>
+                  <a:txBody>
+                    <a:bodyPr/>
+                    <a:lstStyle/>
+                    <a:p>
+                      <a:r>
+                        <a:rPr sz="1300">
+                          <a:latin typeface="Calibri"/>
+                        </a:rPr>
+                        <a:t>Tier 0</a:t>
                       </a:r>
                     </a:p>
                   </a:txBody>
@@ -5302,17 +5539,9 @@
 </p:sld>
 </file>
 
-<file path=ppt/slides/slide2.xml><?xml version="1.0" encoding="utf-8"?>
+<file path=ppt/slides/slide18.xml><?xml version="1.0" encoding="utf-8"?>
 <p:sld xmlns:a="http://schemas.openxmlformats.org/drawingml/2006/main" xmlns:p="http://schemas.openxmlformats.org/presentationml/2006/main" xmlns:r="http://schemas.openxmlformats.org/officeDocument/2006/relationships">
   <p:cSld>
-    <p:bg>
-      <p:bgPr>
-        <a:solidFill>
-          <a:srgbClr val="FFFFFF"/>
-        </a:solidFill>
-        <a:effectLst/>
-      </p:bgPr>
-    </p:bg>
     <p:spTree>
       <p:nvGrpSpPr>
         <p:cNvPr id="1" name=""/>
@@ -5337,19 +5566,18 @@
           <a:noFill/>
         </p:spPr>
         <p:txBody>
-          <a:bodyPr wrap="square">
+          <a:bodyPr wrap="none">
             <a:spAutoFit/>
           </a:bodyPr>
           <a:lstStyle/>
           <a:p>
             <a:r>
-              <a:rPr sz="3200" b="1">
+              <a:rPr sz="2500" b="1">
                 <a:solidFill>
                   <a:srgbClr val="1C1F26"/>
                 </a:solidFill>
-                <a:latin typeface="Calibri"/>
               </a:rPr>
-              <a:t>Why a human still approves everything</a:t>
+              <a:t>Supporting systems (continued 2) — security, storage &amp; backup</a:t>
             </a:r>
           </a:p>
         </p:txBody>
@@ -5397,16 +5625,384 @@
           </a:p>
         </p:txBody>
       </p:sp>
-      <p:sp>
-        <p:nvSpPr>
-          <p:cNvPr id="4" name="TextBox 3"/>
+      <p:graphicFrame>
+        <p:nvGraphicFramePr>
+          <p:cNvPr id="4" name="Table 3"/>
+          <p:cNvGraphicFramePr>
+            <a:graphicFrameLocks noGrp="1"/>
+          </p:cNvGraphicFramePr>
+          <p:nvPr/>
+        </p:nvGraphicFramePr>
+        <p:xfrm>
+          <a:off x="548640" y="1417320"/>
+          <a:ext cx="11064240" cy="4206240"/>
+        </p:xfrm>
+        <a:graphic>
+          <a:graphicData uri="http://schemas.openxmlformats.org/drawingml/2006/table">
+            <a:tbl>
+              <a:tblPr firstRow="1" bandRow="1">
+                <a:tableStyleId>{5C22544A-7EE6-4342-B048-85BDC9FD1C3A}</a:tableStyleId>
+                <a:tableStyleId>{5C22544A-7EE6-4342-B048-85BDC9FD1C3A}</a:tableStyleId>
+              </a:tblPr>
+              <a:tblGrid>
+                <a:gridCol w="2011680"/>
+                <a:gridCol w="5120640"/>
+                <a:gridCol w="3931920"/>
+              </a:tblGrid>
+              <a:tr h="467360">
+                <a:tc>
+                  <a:txBody>
+                    <a:bodyPr/>
+                    <a:lstStyle/>
+                    <a:p>
+                      <a:r>
+                        <a:rPr sz="1300" b="1">
+                          <a:solidFill>
+                            <a:srgbClr val="FFFFFF"/>
+                          </a:solidFill>
+                        </a:rPr>
+                        <a:t>System</a:t>
+                      </a:r>
+                    </a:p>
+                  </a:txBody>
+                  <a:tcPr/>
+                </a:tc>
+                <a:tc>
+                  <a:txBody>
+                    <a:bodyPr/>
+                    <a:lstStyle/>
+                    <a:p>
+                      <a:r>
+                        <a:rPr sz="1300" b="1">
+                          <a:solidFill>
+                            <a:srgbClr val="FFFFFF"/>
+                          </a:solidFill>
+                        </a:rPr>
+                        <a:t>Role</a:t>
+                      </a:r>
+                    </a:p>
+                  </a:txBody>
+                  <a:tcPr/>
+                </a:tc>
+                <a:tc>
+                  <a:txBody>
+                    <a:bodyPr/>
+                    <a:lstStyle/>
+                    <a:p>
+                      <a:r>
+                        <a:rPr sz="1300" b="1">
+                          <a:solidFill>
+                            <a:srgbClr val="FFFFFF"/>
+                          </a:solidFill>
+                        </a:rPr>
+                        <a:t>Feeds / used by</a:t>
+                      </a:r>
+                    </a:p>
+                  </a:txBody>
+                  <a:tcPr/>
+                </a:tc>
+              </a:tr>
+              <a:tr h="467360">
+                <a:tc>
+                  <a:txBody>
+                    <a:bodyPr/>
+                    <a:lstStyle/>
+                    <a:p>
+                      <a:r>
+                        <a:rPr sz="1300" b="1"/>
+                        <a:t>CyberArk</a:t>
+                      </a:r>
+                    </a:p>
+                  </a:txBody>
+                  <a:tcPr/>
+                </a:tc>
+                <a:tc>
+                  <a:txBody>
+                    <a:bodyPr/>
+                    <a:lstStyle/>
+                    <a:p>
+                      <a:r>
+                        <a:rPr sz="1300" b="0"/>
+                        <a:t>Privileged access management — issues the short-lived scoped credential leases every agent checks out just-in-time; PSM session isolation/recording for human break-glass</a:t>
+                      </a:r>
+                    </a:p>
+                  </a:txBody>
+                  <a:tcPr/>
+                </a:tc>
+                <a:tc>
+                  <a:txBody>
+                    <a:bodyPr/>
+                    <a:lstStyle/>
+                    <a:p>
+                      <a:r>
+                        <a:rPr sz="1300" b="0"/>
+                        <a:t>Every domain agent + orchestrator — the concrete vault-checkout implementation; Platform Ops watches lease issuance/expiry</a:t>
+                      </a:r>
+                    </a:p>
+                  </a:txBody>
+                  <a:tcPr/>
+                </a:tc>
+              </a:tr>
+              <a:tr h="467360">
+                <a:tc>
+                  <a:txBody>
+                    <a:bodyPr/>
+                    <a:lstStyle/>
+                    <a:p>
+                      <a:r>
+                        <a:rPr sz="1300" b="1"/>
+                        <a:t>CrowdStrike Falcon</a:t>
+                      </a:r>
+                    </a:p>
+                  </a:txBody>
+                  <a:tcPr/>
+                </a:tc>
+                <a:tc>
+                  <a:txBody>
+                    <a:bodyPr/>
+                    <a:lstStyle/>
+                    <a:p>
+                      <a:r>
+                        <a:rPr sz="1300" b="0"/>
+                        <a:t>Endpoint detection &amp; response — sensor telemetry, threat detection, host containment across servers and desktops</a:t>
+                      </a:r>
+                    </a:p>
+                  </a:txBody>
+                  <a:tcPr/>
+                </a:tc>
+                <a:tc>
+                  <a:txBody>
+                    <a:bodyPr/>
+                    <a:lstStyle/>
+                    <a:p>
+                      <a:r>
+                        <a:rPr sz="1300" b="0"/>
+                        <a:t>Desktop/Windows/Linux agents for sensor health; Platform Ops for security signal — detection opens an Incident; isolation is Tier 3</a:t>
+                      </a:r>
+                    </a:p>
+                  </a:txBody>
+                  <a:tcPr/>
+                </a:tc>
+              </a:tr>
+              <a:tr h="467360">
+                <a:tc>
+                  <a:txBody>
+                    <a:bodyPr/>
+                    <a:lstStyle/>
+                    <a:p>
+                      <a:r>
+                        <a:rPr sz="1300" b="1"/>
+                        <a:t>Splunk</a:t>
+                      </a:r>
+                    </a:p>
+                  </a:txBody>
+                  <a:tcPr/>
+                </a:tc>
+                <a:tc>
+                  <a:txBody>
+                    <a:bodyPr/>
+                    <a:lstStyle/>
+                    <a:p>
+                      <a:r>
+                        <a:rPr sz="1300" b="0"/>
+                        <a:t>SIEM &amp; log analytics — cross-system correlation, security analytics, query surface over the immutable audit log</a:t>
+                      </a:r>
+                    </a:p>
+                  </a:txBody>
+                  <a:tcPr/>
+                </a:tc>
+                <a:tc>
+                  <a:txBody>
+                    <a:bodyPr/>
+                    <a:lstStyle/>
+                    <a:p>
+                      <a:r>
+                        <a:rPr sz="1300" b="0"/>
+                        <a:t>Platform Ops alongside Zabbix/SCOM/Azure Monitor; the audit-log search layer for human reviewers</a:t>
+                      </a:r>
+                    </a:p>
+                  </a:txBody>
+                  <a:tcPr/>
+                </a:tc>
+              </a:tr>
+              <a:tr h="467360">
+                <a:tc>
+                  <a:txBody>
+                    <a:bodyPr/>
+                    <a:lstStyle/>
+                    <a:p>
+                      <a:r>
+                        <a:rPr sz="1300" b="1"/>
+                        <a:t>NetApp ONTAP</a:t>
+                      </a:r>
+                    </a:p>
+                  </a:txBody>
+                  <a:tcPr/>
+                </a:tc>
+                <a:tc>
+                  <a:txBody>
+                    <a:bodyPr/>
+                    <a:lstStyle/>
+                    <a:p>
+                      <a:r>
+                        <a:rPr sz="1300" b="0"/>
+                        <a:t>Enterprise storage — NFS/SMB/iSCSI capacity, volume/LUN provisioning, snapshots, SnapMirror replication (ONTAP REST API)</a:t>
+                      </a:r>
+                    </a:p>
+                  </a:txBody>
+                  <a:tcPr/>
+                </a:tc>
+                <a:tc>
+                  <a:txBody>
+                    <a:bodyPr/>
+                    <a:lstStyle/>
+                    <a:p>
+                      <a:r>
+                        <a:rPr sz="1300" b="0"/>
+                        <a:t>VMware/Database/Windows/Linux agents for capacity &amp; snapshot state; provisioning and destructive actions are Tier 3</a:t>
+                      </a:r>
+                    </a:p>
+                  </a:txBody>
+                  <a:tcPr/>
+                </a:tc>
+              </a:tr>
+              <a:tr h="467360">
+                <a:tc>
+                  <a:txBody>
+                    <a:bodyPr/>
+                    <a:lstStyle/>
+                    <a:p>
+                      <a:r>
+                        <a:rPr sz="1300" b="1"/>
+                        <a:t>Dell storage</a:t>
+                      </a:r>
+                    </a:p>
+                  </a:txBody>
+                  <a:tcPr/>
+                </a:tc>
+                <a:tc>
+                  <a:txBody>
+                    <a:bodyPr/>
+                    <a:lstStyle/>
+                    <a:p>
+                      <a:r>
+                        <a:rPr sz="1300" b="0"/>
+                        <a:t>Enterprise storage — PowerStore/PowerMax/Unity: capacity, provisioning, snapshots, replication (Dell REST API)</a:t>
+                      </a:r>
+                    </a:p>
+                  </a:txBody>
+                  <a:tcPr/>
+                </a:tc>
+                <a:tc>
+                  <a:txBody>
+                    <a:bodyPr/>
+                    <a:lstStyle/>
+                    <a:p>
+                      <a:r>
+                        <a:rPr sz="1300" b="0"/>
+                        <a:t>Same consumers as NetApp — no single-vendor lock-in; read-mostly, provisioning gated at Tier 3</a:t>
+                      </a:r>
+                    </a:p>
+                  </a:txBody>
+                  <a:tcPr/>
+                </a:tc>
+              </a:tr>
+              <a:tr h="467360">
+                <a:tc>
+                  <a:txBody>
+                    <a:bodyPr/>
+                    <a:lstStyle/>
+                    <a:p>
+                      <a:r>
+                        <a:rPr sz="1300" b="1"/>
+                        <a:t>Dell PowerSwitch (ToR)</a:t>
+                      </a:r>
+                    </a:p>
+                  </a:txBody>
+                  <a:tcPr/>
+                </a:tc>
+                <a:tc>
+                  <a:txBody>
+                    <a:bodyPr/>
+                    <a:lstStyle/>
+                    <a:p>
+                      <a:r>
+                        <a:rPr sz="1300" b="0"/>
+                        <a:t>Top-of-rack DC switching on SmartFabric OS10 — leaf/ToR port, VLAN, fabric config (OS10 REST API / Ansible)</a:t>
+                      </a:r>
+                    </a:p>
+                  </a:txBody>
+                  <a:tcPr/>
+                </a:tc>
+                <a:tc>
+                  <a:txBody>
+                    <a:bodyPr/>
+                    <a:lstStyle/>
+                    <a:p>
+                      <a:r>
+                        <a:rPr sz="1300" b="0"/>
+                        <a:t>Network agent alongside Cisco IOS/NX-OS; Batfish models OS10 the same way, so dry-run covers the ToR layer</a:t>
+                      </a:r>
+                    </a:p>
+                  </a:txBody>
+                  <a:tcPr/>
+                </a:tc>
+              </a:tr>
+              <a:tr h="467360">
+                <a:tc>
+                  <a:txBody>
+                    <a:bodyPr/>
+                    <a:lstStyle/>
+                    <a:p>
+                      <a:r>
+                        <a:rPr sz="1300" b="1"/>
+                        <a:t>Backup &amp; recovery</a:t>
+                      </a:r>
+                    </a:p>
+                  </a:txBody>
+                  <a:tcPr/>
+                </a:tc>
+                <a:tc>
+                  <a:txBody>
+                    <a:bodyPr/>
+                    <a:lstStyle/>
+                    <a:p>
+                      <a:r>
+                        <a:rPr sz="1300" b="0"/>
+                        <a:t>Enterprise backup, immutable/air-gapped copies, restore orchestration (Veeam/Commvault/Rubrik/Cohesity)</a:t>
+                      </a:r>
+                    </a:p>
+                  </a:txBody>
+                  <a:tcPr/>
+                </a:tc>
+                <a:tc>
+                  <a:txBody>
+                    <a:bodyPr/>
+                    <a:lstStyle/>
+                    <a:p>
+                      <a:r>
+                        <a:rPr sz="1300" b="0"/>
+                        <a:t>Database &amp; VMware agents for job status and restore verification; Platform Ops watches success/failure — restores Tier 2, deleting/shortening retention is deny-list</a:t>
+                      </a:r>
+                    </a:p>
+                  </a:txBody>
+                  <a:tcPr/>
+                </a:tc>
+              </a:tr>
+            </a:tbl>
+          </a:graphicData>
+        </a:graphic>
+      </p:graphicFrame>
+      <p:sp>
+        <p:nvSpPr>
+          <p:cNvPr id="5" name="TextBox 4"/>
           <p:cNvSpPr txBox="1"/>
           <p:nvPr/>
         </p:nvSpPr>
         <p:spPr>
           <a:xfrm>
-            <a:off x="548640" y="1463040"/>
-            <a:ext cx="11064240" cy="4846320"/>
+            <a:off x="548640" y="5623560"/>
+            <a:ext cx="11064240" cy="914400"/>
           </a:xfrm>
           <a:prstGeom prst="rect">
             <a:avLst/>
@@ -5414,112 +6010,18 @@
           <a:noFill/>
         </p:spPr>
         <p:txBody>
-          <a:bodyPr wrap="square">
+          <a:bodyPr wrap="none">
             <a:spAutoFit/>
           </a:bodyPr>
           <a:lstStyle/>
           <a:p>
-            <a:pPr>
-              <a:spcAft>
-                <a:spcPts val="1200"/>
-              </a:spcAft>
-              <a:defRPr>
-                <a:latin typeface="Calibri"/>
-              </a:defRPr>
-            </a:pPr>
-            <a:r>
-              <a:rPr b="1" sz="1800">
-                <a:solidFill>
-                  <a:srgbClr val="C96343"/>
+            <a:r>
+              <a:rPr sz="1200">
+                <a:solidFill>
+                  <a:srgbClr val="5B6270"/>
                 </a:solidFill>
               </a:rPr>
-              <a:t>Load-bearing, not decorative:  </a:t>
-            </a:r>
-            <a:r>
-              <a:rPr sz="1800">
-                <a:solidFill>
-                  <a:srgbClr val="1C1F26"/>
-                </a:solidFill>
-              </a:rPr>
-              <a:t>"as autonomous as possible" and "only human interaction is to approve or arbitrate" are the same goal stated twice.</a:t>
-            </a:r>
-          </a:p>
-          <a:p>
-            <a:pPr>
-              <a:spcAft>
-                <a:spcPts val="1200"/>
-              </a:spcAft>
-              <a:defRPr>
-                <a:latin typeface="Calibri"/>
-              </a:defRPr>
-            </a:pPr>
-            <a:r>
-              <a:rPr b="1" sz="1800">
-                <a:solidFill>
-                  <a:srgbClr val="C96343"/>
-                </a:solidFill>
-              </a:rPr>
-              <a:t>Every domain agent  </a:t>
-            </a:r>
-            <a:r>
-              <a:rPr sz="1800">
-                <a:solidFill>
-                  <a:srgbClr val="1C1F26"/>
-                </a:solidFill>
-              </a:rPr>
-              <a:t>can read, plan, and propose without limit — none can commit a change without a plan that already passed the gate.</a:t>
-            </a:r>
-          </a:p>
-          <a:p>
-            <a:pPr>
-              <a:spcAft>
-                <a:spcPts val="1200"/>
-              </a:spcAft>
-              <a:defRPr>
-                <a:latin typeface="Calibri"/>
-              </a:defRPr>
-            </a:pPr>
-            <a:r>
-              <a:rPr b="1" sz="1800">
-                <a:solidFill>
-                  <a:srgbClr val="C96343"/>
-                </a:solidFill>
-              </a:rPr>
-              <a:t>Blast radius:  </a:t>
-            </a:r>
-            <a:r>
-              <a:rPr sz="1800">
-                <a:solidFill>
-                  <a:srgbClr val="1C1F26"/>
-                </a:solidFill>
-              </a:rPr>
-              <a:t>on infrastructure this broad (routers, firewalls, AD, hypervisors, call control), one wrong autonomous write can be a multi-day, multi-team incident.</a:t>
-            </a:r>
-          </a:p>
-          <a:p>
-            <a:pPr>
-              <a:spcAft>
-                <a:spcPts val="1200"/>
-              </a:spcAft>
-              <a:defRPr>
-                <a:latin typeface="Calibri"/>
-              </a:defRPr>
-            </a:pPr>
-            <a:r>
-              <a:rPr b="1" sz="1800">
-                <a:solidFill>
-                  <a:srgbClr val="C96343"/>
-                </a:solidFill>
-              </a:rPr>
-              <a:t>Same rule this project runs under:  </a:t>
-            </a:r>
-            <a:r>
-              <a:rPr sz="1800">
-                <a:solidFill>
-                  <a:srgbClr val="1C1F26"/>
-                </a:solidFill>
-              </a:rPr>
-              <a:t>"anything irreversible, legally gray, or strange → write it down and wait," scaled from one agent to a team managing a real enterprise.</a:t>
+              <a:t>CyberArk, CrowdStrike, Splunk, NetApp, Dell storage, Dell PowerSwitch and the backup/recovery platform — each extends one existing domain agent or Platform Ops, under the same tiers, gate and deny-list.</a:t>
             </a:r>
           </a:p>
         </p:txBody>
@@ -5532,7 +6034,7 @@
 </p:sld>
 </file>
 
-<file path=ppt/slides/slide3.xml><?xml version="1.0" encoding="utf-8"?>
+<file path=ppt/slides/slide2.xml><?xml version="1.0" encoding="utf-8"?>
 <p:sld xmlns:a="http://schemas.openxmlformats.org/drawingml/2006/main" xmlns:p="http://schemas.openxmlformats.org/presentationml/2006/main" xmlns:r="http://schemas.openxmlformats.org/officeDocument/2006/relationships">
   <p:cSld>
     <p:bg>
@@ -5573,13 +6075,13 @@
           <a:lstStyle/>
           <a:p>
             <a:r>
-              <a:rPr sz="3000" b="1">
+              <a:rPr sz="3200" b="1">
                 <a:solidFill>
                   <a:srgbClr val="1C1F26"/>
                 </a:solidFill>
                 <a:latin typeface="Calibri"/>
               </a:rPr>
-              <a:t>High-level architecture</a:t>
+              <a:t>Why a human still approves everything</a:t>
             </a:r>
           </a:p>
         </p:txBody>
@@ -5627,24 +6129,254 @@
           </a:p>
         </p:txBody>
       </p:sp>
+      <p:sp>
+        <p:nvSpPr>
+          <p:cNvPr id="4" name="TextBox 3"/>
+          <p:cNvSpPr txBox="1"/>
+          <p:nvPr/>
+        </p:nvSpPr>
+        <p:spPr>
+          <a:xfrm>
+            <a:off x="548640" y="1463040"/>
+            <a:ext cx="11064240" cy="4846320"/>
+          </a:xfrm>
+          <a:prstGeom prst="rect">
+            <a:avLst/>
+          </a:prstGeom>
+          <a:noFill/>
+        </p:spPr>
+        <p:txBody>
+          <a:bodyPr wrap="square">
+            <a:spAutoFit/>
+          </a:bodyPr>
+          <a:lstStyle/>
+          <a:p>
+            <a:pPr>
+              <a:spcAft>
+                <a:spcPts val="1200"/>
+              </a:spcAft>
+              <a:defRPr>
+                <a:latin typeface="Calibri"/>
+              </a:defRPr>
+            </a:pPr>
+            <a:r>
+              <a:rPr b="1" sz="1800">
+                <a:solidFill>
+                  <a:srgbClr val="C96343"/>
+                </a:solidFill>
+              </a:rPr>
+              <a:t>Load-bearing, not decorative:  </a:t>
+            </a:r>
+            <a:r>
+              <a:rPr sz="1800">
+                <a:solidFill>
+                  <a:srgbClr val="1C1F26"/>
+                </a:solidFill>
+              </a:rPr>
+              <a:t>"as autonomous as possible" and "only human interaction is to approve or arbitrate" are the same goal stated twice.</a:t>
+            </a:r>
+          </a:p>
+          <a:p>
+            <a:pPr>
+              <a:spcAft>
+                <a:spcPts val="1200"/>
+              </a:spcAft>
+              <a:defRPr>
+                <a:latin typeface="Calibri"/>
+              </a:defRPr>
+            </a:pPr>
+            <a:r>
+              <a:rPr b="1" sz="1800">
+                <a:solidFill>
+                  <a:srgbClr val="C96343"/>
+                </a:solidFill>
+              </a:rPr>
+              <a:t>Every domain agent  </a:t>
+            </a:r>
+            <a:r>
+              <a:rPr sz="1800">
+                <a:solidFill>
+                  <a:srgbClr val="1C1F26"/>
+                </a:solidFill>
+              </a:rPr>
+              <a:t>can read, plan, and propose without limit — none can commit a change without a plan that already passed the gate.</a:t>
+            </a:r>
+          </a:p>
+          <a:p>
+            <a:pPr>
+              <a:spcAft>
+                <a:spcPts val="1200"/>
+              </a:spcAft>
+              <a:defRPr>
+                <a:latin typeface="Calibri"/>
+              </a:defRPr>
+            </a:pPr>
+            <a:r>
+              <a:rPr b="1" sz="1800">
+                <a:solidFill>
+                  <a:srgbClr val="C96343"/>
+                </a:solidFill>
+              </a:rPr>
+              <a:t>Blast radius:  </a:t>
+            </a:r>
+            <a:r>
+              <a:rPr sz="1800">
+                <a:solidFill>
+                  <a:srgbClr val="1C1F26"/>
+                </a:solidFill>
+              </a:rPr>
+              <a:t>on infrastructure this broad (routers, firewalls, AD, hypervisors, call control), one wrong autonomous write can be a multi-day, multi-team incident.</a:t>
+            </a:r>
+          </a:p>
+          <a:p>
+            <a:pPr>
+              <a:spcAft>
+                <a:spcPts val="1200"/>
+              </a:spcAft>
+              <a:defRPr>
+                <a:latin typeface="Calibri"/>
+              </a:defRPr>
+            </a:pPr>
+            <a:r>
+              <a:rPr b="1" sz="1800">
+                <a:solidFill>
+                  <a:srgbClr val="C96343"/>
+                </a:solidFill>
+              </a:rPr>
+              <a:t>Same rule this project runs under:  </a:t>
+            </a:r>
+            <a:r>
+              <a:rPr sz="1800">
+                <a:solidFill>
+                  <a:srgbClr val="1C1F26"/>
+                </a:solidFill>
+              </a:rPr>
+              <a:t>"anything irreversible, legally gray, or strange → write it down and wait," scaled from one agent to a team managing a real enterprise.</a:t>
+            </a:r>
+          </a:p>
+        </p:txBody>
+      </p:sp>
+    </p:spTree>
+  </p:cSld>
+  <p:clrMapOvr>
+    <a:masterClrMapping/>
+  </p:clrMapOvr>
+</p:sld>
+</file>
+
+<file path=ppt/slides/slide3.xml><?xml version="1.0" encoding="utf-8"?>
+<p:sld xmlns:a="http://schemas.openxmlformats.org/drawingml/2006/main" xmlns:p="http://schemas.openxmlformats.org/presentationml/2006/main" xmlns:r="http://schemas.openxmlformats.org/officeDocument/2006/relationships">
+  <p:cSld>
+    <p:bg>
+      <p:bgPr>
+        <a:solidFill>
+          <a:srgbClr val="FFFFFF"/>
+        </a:solidFill>
+        <a:effectLst/>
+      </p:bgPr>
+    </p:bg>
+    <p:spTree>
+      <p:nvGrpSpPr>
+        <p:cNvPr id="1" name=""/>
+        <p:cNvGrpSpPr/>
+        <p:nvPr/>
+      </p:nvGrpSpPr>
+      <p:grpSpPr/>
+      <p:sp>
+        <p:nvSpPr>
+          <p:cNvPr id="2" name="TextBox 1"/>
+          <p:cNvSpPr txBox="1"/>
+          <p:nvPr/>
+        </p:nvSpPr>
+        <p:spPr>
+          <a:xfrm>
+            <a:off x="548640" y="365760"/>
+            <a:ext cx="11064240" cy="914400"/>
+          </a:xfrm>
+          <a:prstGeom prst="rect">
+            <a:avLst/>
+          </a:prstGeom>
+          <a:noFill/>
+        </p:spPr>
+        <p:txBody>
+          <a:bodyPr wrap="square">
+            <a:spAutoFit/>
+          </a:bodyPr>
+          <a:lstStyle/>
+          <a:p>
+            <a:r>
+              <a:rPr sz="3000" b="1">
+                <a:solidFill>
+                  <a:srgbClr val="1C1F26"/>
+                </a:solidFill>
+                <a:latin typeface="Calibri"/>
+              </a:rPr>
+              <a:t>High-level architecture</a:t>
+            </a:r>
+          </a:p>
+        </p:txBody>
+      </p:sp>
+      <p:sp>
+        <p:nvSpPr>
+          <p:cNvPr id="3" name="Rectangle 2"/>
+          <p:cNvSpPr/>
+          <p:nvPr/>
+        </p:nvSpPr>
+        <p:spPr>
+          <a:xfrm>
+            <a:off x="548640" y="1143000"/>
+            <a:ext cx="2743200" cy="27940"/>
+          </a:xfrm>
+          <a:prstGeom prst="rect">
+            <a:avLst/>
+          </a:prstGeom>
+          <a:solidFill>
+            <a:srgbClr val="C96343"/>
+          </a:solidFill>
+          <a:ln>
+            <a:noFill/>
+          </a:ln>
+        </p:spPr>
+        <p:style>
+          <a:lnRef idx="1">
+            <a:schemeClr val="accent1"/>
+          </a:lnRef>
+          <a:fillRef idx="3">
+            <a:schemeClr val="accent1"/>
+          </a:fillRef>
+          <a:effectRef idx="2">
+            <a:schemeClr val="accent1"/>
+          </a:effectRef>
+          <a:fontRef idx="minor">
+            <a:schemeClr val="lt1"/>
+          </a:fontRef>
+        </p:style>
+        <p:txBody>
+          <a:bodyPr rtlCol="0" anchor="ctr"/>
+          <a:lstStyle/>
+          <a:p>
+            <a:pPr algn="ctr"/>
+          </a:p>
+        </p:txBody>
+      </p:sp>
       <p:pic>
         <p:nvPicPr>
-          <p:cNvPr id="4" name="Picture 3" descr="arch_diagram.png"/>
+          <p:cNvPr id="4" name="Picture 3" descr="arch_pptx.png"/>
           <p:cNvPicPr>
             <a:picLocks noChangeAspect="1"/>
           </p:cNvPicPr>
           <p:nvPr/>
         </p:nvPicPr>
         <p:blipFill>
-          <a:blip r:embed="rId4"/>
+          <a:blip r:embed="rId5"/>
           <a:stretch>
             <a:fillRect/>
           </a:stretch>
         </p:blipFill>
         <p:spPr>
           <a:xfrm>
-            <a:off x="1491100" y="1371600"/>
-            <a:ext cx="9209495" cy="5186400"/>
+            <a:off x="1920795" y="1371600"/>
+            <a:ext cx="8350104" cy="5186400"/>
           </a:xfrm>
           <a:prstGeom prst="rect">
             <a:avLst/>
@@ -5916,7 +6648,7 @@
                         <a:rPr sz="1300">
                           <a:latin typeface="Calibri"/>
                         </a:rPr>
-                        <a:t>IOS/NX-OS, Ansible, NetBox, Batfish, Nexus Dashboard, Catalyst Center</a:t>
+                        <a:t>IOS/NX-OS, Ansible, NetBox, Batfish, Nexus Dashboard, Catalyst Center, Dell PowerSwitch (OS10 ToR)</a:t>
                       </a:r>
                     </a:p>
                   </a:txBody>
@@ -5994,7 +6726,7 @@
                         <a:rPr sz="1300">
                           <a:latin typeface="Calibri"/>
                         </a:rPr>
-                        <a:t>LDAP/WinRM, Graph API, Cisco ISE</a:t>
+                        <a:t>LDAP/WinRM, Graph API, Cisco ISE, CyberArk (privileged-account vaulting)</a:t>
                       </a:r>
                     </a:p>
                   </a:txBody>
@@ -6072,7 +6804,7 @@
                         <a:rPr sz="1300">
                           <a:latin typeface="Calibri"/>
                         </a:rPr>
-                        <a:t>WinRM, PowerShell DSC</a:t>
+                        <a:t>WinRM, PowerShell DSC; CrowdStrike Falcon sensor health; NetApp/Dell storage capacity</a:t>
                       </a:r>
                     </a:p>
                   </a:txBody>
@@ -6150,7 +6882,7 @@
                         <a:rPr sz="1300">
                           <a:latin typeface="Calibri"/>
                         </a:rPr>
-                        <a:t>SSH, Ansible, Red Hat Satellite</a:t>
+                        <a:t>SSH, Ansible, Red Hat Satellite; CrowdStrike Falcon sensor health</a:t>
                       </a:r>
                     </a:p>
                   </a:txBody>
@@ -6228,7 +6960,7 @@
                         <a:rPr sz="1300">
                           <a:latin typeface="Calibri"/>
                         </a:rPr>
-                        <a:t>Native SQL drivers, read-replica first</a:t>
+                        <a:t>Native SQL drivers, read-replica first; NetApp/Dell snapshots + backup platform for verification</a:t>
                       </a:r>
                     </a:p>
                   </a:txBody>
@@ -6462,7 +7194,7 @@
                         <a:rPr sz="1300">
                           <a:latin typeface="Calibri"/>
                         </a:rPr>
-                        <a:t>vCenter API / PowerCLI, VMware Aria</a:t>
+                        <a:t>vCenter API / PowerCLI, VMware Aria; NetApp/Dell datastores; backup platform for restore verification</a:t>
                       </a:r>
                     </a:p>
                   </a:txBody>
@@ -6540,7 +7272,7 @@
                         <a:rPr sz="1300">
                           <a:latin typeface="Calibri"/>
                         </a:rPr>
-                        <a:t>Intune / Jamf APIs, Microsoft MECM</a:t>
+                        <a:t>Intune / Jamf APIs, Microsoft MECM; CrowdStrike Falcon endpoint EDR/containment</a:t>
                       </a:r>
                     </a:p>
                   </a:txBody>

</xml_diff>